<commit_message>
docs: add Member 6 Esha Verma to Slide 1 and team documentation
</commit_message>
<xml_diff>
--- a/docs/SIH26053_TeraPulse_Official_Presentation.pptx
+++ b/docs/SIH26053_TeraPulse_Official_Presentation.pptx
@@ -3434,9 +3434,9 @@
           <a:p>
             <a:pPr>
               <a:spcAft>
-                <a:spcPts val="600"/>
-              </a:spcAft>
-              <a:defRPr sz="1100">
+                <a:spcPts val="400"/>
+              </a:spcAft>
+              <a:defRPr sz="1019">
                 <a:solidFill>
                   <a:srgbClr val="1E293B"/>
                 </a:solidFill>
@@ -3450,9 +3450,9 @@
           <a:p>
             <a:pPr>
               <a:spcAft>
-                <a:spcPts val="600"/>
-              </a:spcAft>
-              <a:defRPr sz="1100">
+                <a:spcPts val="400"/>
+              </a:spcAft>
+              <a:defRPr sz="1019">
                 <a:solidFill>
                   <a:srgbClr val="1E293B"/>
                 </a:solidFill>
@@ -3466,9 +3466,9 @@
           <a:p>
             <a:pPr>
               <a:spcAft>
-                <a:spcPts val="600"/>
-              </a:spcAft>
-              <a:defRPr sz="1100">
+                <a:spcPts val="400"/>
+              </a:spcAft>
+              <a:defRPr sz="1019">
                 <a:solidFill>
                   <a:srgbClr val="1E293B"/>
                 </a:solidFill>
@@ -3482,9 +3482,9 @@
           <a:p>
             <a:pPr>
               <a:spcAft>
-                <a:spcPts val="600"/>
-              </a:spcAft>
-              <a:defRPr sz="1100">
+                <a:spcPts val="400"/>
+              </a:spcAft>
+              <a:defRPr sz="1019">
                 <a:solidFill>
                   <a:srgbClr val="1E293B"/>
                 </a:solidFill>
@@ -3498,9 +3498,9 @@
           <a:p>
             <a:pPr>
               <a:spcAft>
-                <a:spcPts val="600"/>
-              </a:spcAft>
-              <a:defRPr sz="1100">
+                <a:spcPts val="400"/>
+              </a:spcAft>
+              <a:defRPr sz="1019">
                 <a:solidFill>
                   <a:srgbClr val="1E293B"/>
                 </a:solidFill>
@@ -3514,9 +3514,25 @@
           <a:p>
             <a:pPr>
               <a:spcAft>
-                <a:spcPts val="600"/>
-              </a:spcAft>
-              <a:defRPr sz="1100">
+                <a:spcPts val="400"/>
+              </a:spcAft>
+              <a:defRPr sz="1019">
+                <a:solidFill>
+                  <a:srgbClr val="1E293B"/>
+                </a:solidFill>
+                <a:latin typeface="Arial"/>
+              </a:defRPr>
+            </a:pPr>
+            <a:r>
+              <a:t>• Member 6: Esha Verma (Dataset Curation, QA &amp; Documentation)</a:t>
+            </a:r>
+          </a:p>
+          <a:p>
+            <a:pPr>
+              <a:spcAft>
+                <a:spcPts val="400"/>
+              </a:spcAft>
+              <a:defRPr sz="1019">
                 <a:solidFill>
                   <a:srgbClr val="1E293B"/>
                 </a:solidFill>
@@ -3530,9 +3546,9 @@
           <a:p>
             <a:pPr>
               <a:spcAft>
-                <a:spcPts val="600"/>
-              </a:spcAft>
-              <a:defRPr sz="1100">
+                <a:spcPts val="400"/>
+              </a:spcAft>
+              <a:defRPr sz="1019">
                 <a:solidFill>
                   <a:srgbClr val="1E293B"/>
                 </a:solidFill>

</xml_diff>

<commit_message>
style: increase font sizes and enlarge images across all 6 slides
</commit_message>
<xml_diff>
--- a/docs/SIH26053_TeraPulse_Official_Presentation.pptx
+++ b/docs/SIH26053_TeraPulse_Official_Presentation.pptx
@@ -3101,8 +3101,8 @@
         </p:nvSpPr>
         <p:spPr>
           <a:xfrm>
-            <a:off x="914400" y="320040"/>
-            <a:ext cx="9144000" cy="548640"/>
+            <a:off x="914400" y="274320"/>
+            <a:ext cx="9144000" cy="594360"/>
           </a:xfrm>
           <a:prstGeom prst="rect">
             <a:avLst/>
@@ -3116,7 +3116,7 @@
           <a:lstStyle/>
           <a:p>
             <a:pPr algn="ctr">
-              <a:defRPr sz="2400" b="1">
+              <a:defRPr sz="2600" b="1">
                 <a:solidFill>
                   <a:srgbClr val="1E4082"/>
                 </a:solidFill>
@@ -3137,8 +3137,8 @@
         </p:nvSpPr>
         <p:spPr>
           <a:xfrm>
-            <a:off x="731520" y="868680"/>
-            <a:ext cx="9601200" cy="1097280"/>
+            <a:off x="731520" y="841248"/>
+            <a:ext cx="9601200" cy="1188720"/>
           </a:xfrm>
           <a:prstGeom prst="rect">
             <a:avLst/>
@@ -3152,7 +3152,7 @@
           <a:lstStyle/>
           <a:p>
             <a:pPr algn="ctr">
-              <a:defRPr sz="2600" b="1">
+              <a:defRPr sz="2750" b="1">
                 <a:solidFill>
                   <a:srgbClr val="111827"/>
                 </a:solidFill>
@@ -3185,8 +3185,8 @@
         </p:blipFill>
         <p:spPr>
           <a:xfrm>
-            <a:off x="10241280" y="182880"/>
-            <a:ext cx="1463040" cy="691294"/>
+            <a:off x="10149840" y="164592"/>
+            <a:ext cx="1600200" cy="756103"/>
           </a:xfrm>
           <a:prstGeom prst="rect">
             <a:avLst/>
@@ -3201,8 +3201,8 @@
         </p:nvSpPr>
         <p:spPr>
           <a:xfrm>
-            <a:off x="731520" y="2286000"/>
-            <a:ext cx="6858000" cy="4114800"/>
+            <a:off x="731520" y="2240280"/>
+            <a:ext cx="6766560" cy="4206240"/>
           </a:xfrm>
           <a:prstGeom prst="rect">
             <a:avLst/>
@@ -3217,9 +3217,9 @@
           <a:p>
             <a:pPr>
               <a:spcAft>
-                <a:spcPts val="800"/>
+                <a:spcPts val="700"/>
               </a:spcAft>
-              <a:defRPr sz="1300">
+              <a:defRPr sz="1350">
                 <a:solidFill>
                   <a:srgbClr val="111827"/>
                 </a:solidFill>
@@ -3233,9 +3233,9 @@
           <a:p>
             <a:pPr>
               <a:spcAft>
-                <a:spcPts val="800"/>
+                <a:spcPts val="700"/>
               </a:spcAft>
-              <a:defRPr sz="1300">
+              <a:defRPr sz="1350">
                 <a:solidFill>
                   <a:srgbClr val="111827"/>
                 </a:solidFill>
@@ -3249,9 +3249,9 @@
           <a:p>
             <a:pPr>
               <a:spcAft>
-                <a:spcPts val="800"/>
+                <a:spcPts val="700"/>
               </a:spcAft>
-              <a:defRPr sz="1300">
+              <a:defRPr sz="1350">
                 <a:solidFill>
                   <a:srgbClr val="111827"/>
                 </a:solidFill>
@@ -3265,9 +3265,9 @@
           <a:p>
             <a:pPr>
               <a:spcAft>
-                <a:spcPts val="800"/>
+                <a:spcPts val="700"/>
               </a:spcAft>
-              <a:defRPr sz="1300">
+              <a:defRPr sz="1350">
                 <a:solidFill>
                   <a:srgbClr val="111827"/>
                 </a:solidFill>
@@ -3281,9 +3281,9 @@
           <a:p>
             <a:pPr>
               <a:spcAft>
-                <a:spcPts val="800"/>
+                <a:spcPts val="700"/>
               </a:spcAft>
-              <a:defRPr sz="1300">
+              <a:defRPr sz="1350">
                 <a:solidFill>
                   <a:srgbClr val="111827"/>
                 </a:solidFill>
@@ -3297,9 +3297,9 @@
           <a:p>
             <a:pPr>
               <a:spcAft>
-                <a:spcPts val="800"/>
+                <a:spcPts val="700"/>
               </a:spcAft>
-              <a:defRPr sz="1300">
+              <a:defRPr sz="1350">
                 <a:solidFill>
                   <a:srgbClr val="111827"/>
                 </a:solidFill>
@@ -3313,9 +3313,9 @@
           <a:p>
             <a:pPr>
               <a:spcAft>
-                <a:spcPts val="800"/>
+                <a:spcPts val="700"/>
               </a:spcAft>
-              <a:defRPr sz="1300">
+              <a:defRPr sz="1350">
                 <a:solidFill>
                   <a:srgbClr val="111827"/>
                 </a:solidFill>
@@ -3333,9 +3333,9 @@
           <a:p>
             <a:pPr>
               <a:spcAft>
-                <a:spcPts val="800"/>
+                <a:spcPts val="700"/>
               </a:spcAft>
-              <a:defRPr sz="1300">
+              <a:defRPr sz="1350">
                 <a:solidFill>
                   <a:srgbClr val="111827"/>
                 </a:solidFill>
@@ -3364,8 +3364,8 @@
         </p:blipFill>
         <p:spPr>
           <a:xfrm>
-            <a:off x="7132320" y="2103120"/>
-            <a:ext cx="4389120" cy="4693846"/>
+            <a:off x="7040880" y="2011680"/>
+            <a:ext cx="4663440" cy="4987211"/>
           </a:xfrm>
           <a:prstGeom prst="rect">
             <a:avLst/>
@@ -3398,8 +3398,8 @@
         </p:nvSpPr>
         <p:spPr>
           <a:xfrm>
-            <a:off x="457200" y="228600"/>
-            <a:ext cx="1234440" cy="777240"/>
+            <a:off x="457200" y="201168"/>
+            <a:ext cx="1280160" cy="822960"/>
           </a:xfrm>
           <a:prstGeom prst="ellipse">
             <a:avLst/>
@@ -3432,7 +3432,7 @@
           <a:lstStyle/>
           <a:p>
             <a:pPr algn="ctr">
-              <a:defRPr sz="1100" b="1">
+              <a:defRPr sz="1200" b="1">
                 <a:solidFill>
                   <a:srgbClr val="111827"/>
                 </a:solidFill>
@@ -3457,8 +3457,8 @@
         </p:nvSpPr>
         <p:spPr>
           <a:xfrm>
-            <a:off x="1920240" y="228600"/>
-            <a:ext cx="8046720" cy="777240"/>
+            <a:off x="1920240" y="201168"/>
+            <a:ext cx="8046720" cy="822960"/>
           </a:xfrm>
           <a:prstGeom prst="rect">
             <a:avLst/>
@@ -3472,7 +3472,7 @@
           <a:lstStyle/>
           <a:p>
             <a:pPr algn="ctr">
-              <a:defRPr sz="2100" b="1">
+              <a:defRPr sz="2150" b="1">
                 <a:solidFill>
                   <a:srgbClr val="111827"/>
                 </a:solidFill>
@@ -3505,8 +3505,8 @@
         </p:blipFill>
         <p:spPr>
           <a:xfrm>
-            <a:off x="10241280" y="182880"/>
-            <a:ext cx="1463040" cy="691294"/>
+            <a:off x="10149840" y="164592"/>
+            <a:ext cx="1600200" cy="756103"/>
           </a:xfrm>
           <a:prstGeom prst="rect">
             <a:avLst/>
@@ -3521,8 +3521,8 @@
         </p:nvSpPr>
         <p:spPr>
           <a:xfrm>
-            <a:off x="0" y="6537960"/>
-            <a:ext cx="12191695" cy="320040"/>
+            <a:off x="0" y="6510528"/>
+            <a:ext cx="12191695" cy="347472"/>
           </a:xfrm>
           <a:prstGeom prst="rect">
             <a:avLst/>
@@ -3549,11 +3549,11 @@
           </a:fontRef>
         </p:style>
         <p:txBody>
-          <a:bodyPr rtlCol="0" anchor="ctr"/>
+          <a:bodyPr rtlCol="0" anchor="ctr" tIns="54864"/>
           <a:lstStyle/>
           <a:p>
             <a:pPr algn="ctr">
-              <a:defRPr sz="1000">
+              <a:defRPr sz="1050">
                 <a:solidFill>
                   <a:srgbClr val="FFFFFF"/>
                 </a:solidFill>
@@ -3574,8 +3574,8 @@
         </p:nvSpPr>
         <p:spPr>
           <a:xfrm>
-            <a:off x="548640" y="1188720"/>
-            <a:ext cx="5669280" cy="457200"/>
+            <a:off x="548640" y="1143000"/>
+            <a:ext cx="5852160" cy="457200"/>
           </a:xfrm>
           <a:prstGeom prst="rect">
             <a:avLst/>
@@ -3589,7 +3589,7 @@
           <a:lstStyle/>
           <a:p>
             <a:pPr>
-              <a:defRPr sz="1700" b="1">
+              <a:defRPr sz="1800" b="1">
                 <a:solidFill>
                   <a:srgbClr val="1D4ED8"/>
                 </a:solidFill>
@@ -3611,7 +3611,7 @@
         <p:spPr>
           <a:xfrm>
             <a:off x="548640" y="1600200"/>
-            <a:ext cx="5669280" cy="2468880"/>
+            <a:ext cx="5852160" cy="2468880"/>
           </a:xfrm>
           <a:prstGeom prst="rect">
             <a:avLst/>
@@ -3628,7 +3628,7 @@
               <a:spcAft>
                 <a:spcPts val="400"/>
               </a:spcAft>
-              <a:defRPr sz="1150">
+              <a:defRPr sz="1250">
                 <a:solidFill>
                   <a:srgbClr val="1F2937"/>
                 </a:solidFill>
@@ -3644,7 +3644,7 @@
               <a:spcAft>
                 <a:spcPts val="400"/>
               </a:spcAft>
-              <a:defRPr sz="1150">
+              <a:defRPr sz="1250">
                 <a:solidFill>
                   <a:srgbClr val="1F2937"/>
                 </a:solidFill>
@@ -3660,7 +3660,7 @@
               <a:spcAft>
                 <a:spcPts val="400"/>
               </a:spcAft>
-              <a:defRPr sz="1150">
+              <a:defRPr sz="1250">
                 <a:solidFill>
                   <a:srgbClr val="1F2937"/>
                 </a:solidFill>
@@ -3676,7 +3676,7 @@
               <a:spcAft>
                 <a:spcPts val="400"/>
               </a:spcAft>
-              <a:defRPr sz="1150">
+              <a:defRPr sz="1250">
                 <a:solidFill>
                   <a:srgbClr val="1F2937"/>
                 </a:solidFill>
@@ -3692,7 +3692,7 @@
               <a:spcAft>
                 <a:spcPts val="400"/>
               </a:spcAft>
-              <a:defRPr sz="1150">
+              <a:defRPr sz="1250">
                 <a:solidFill>
                   <a:srgbClr val="1F2937"/>
                 </a:solidFill>
@@ -3708,7 +3708,7 @@
               <a:spcAft>
                 <a:spcPts val="400"/>
               </a:spcAft>
-              <a:defRPr sz="1150">
+              <a:defRPr sz="1250">
                 <a:solidFill>
                   <a:srgbClr val="1F2937"/>
                 </a:solidFill>
@@ -3730,7 +3730,7 @@
         <p:spPr>
           <a:xfrm>
             <a:off x="548640" y="4160520"/>
-            <a:ext cx="5669280" cy="411480"/>
+            <a:ext cx="5852160" cy="411480"/>
           </a:xfrm>
           <a:prstGeom prst="rect">
             <a:avLst/>
@@ -3744,7 +3744,7 @@
           <a:lstStyle/>
           <a:p>
             <a:pPr>
-              <a:defRPr sz="1700" b="1">
+              <a:defRPr sz="1800" b="1">
                 <a:solidFill>
                   <a:srgbClr val="1D4ED8"/>
                 </a:solidFill>
@@ -3765,8 +3765,8 @@
         </p:nvSpPr>
         <p:spPr>
           <a:xfrm>
-            <a:off x="548640" y="4572000"/>
-            <a:ext cx="5669280" cy="1737360"/>
+            <a:off x="548640" y="4617720"/>
+            <a:ext cx="5852160" cy="1737360"/>
           </a:xfrm>
           <a:prstGeom prst="rect">
             <a:avLst/>
@@ -3783,7 +3783,7 @@
               <a:spcAft>
                 <a:spcPts val="600"/>
               </a:spcAft>
-              <a:defRPr sz="1150" i="1">
+              <a:defRPr sz="1250" i="1">
                 <a:solidFill>
                   <a:srgbClr val="1F2937"/>
                 </a:solidFill>
@@ -3796,7 +3796,7 @@
           </a:p>
           <a:p>
             <a:pPr>
-              <a:defRPr sz="1150">
+              <a:defRPr sz="1250">
                 <a:solidFill>
                   <a:srgbClr val="1F2937"/>
                 </a:solidFill>
@@ -3817,8 +3817,8 @@
         </p:nvSpPr>
         <p:spPr>
           <a:xfrm>
-            <a:off x="6858000" y="1645920"/>
-            <a:ext cx="4389120" cy="4389120"/>
+            <a:off x="6766560" y="1600200"/>
+            <a:ext cx="4663440" cy="4663440"/>
           </a:xfrm>
           <a:prstGeom prst="ellipse">
             <a:avLst/>
@@ -3826,7 +3826,7 @@
           <a:solidFill>
             <a:srgbClr val="BEDCFA"/>
           </a:solidFill>
-          <a:ln w="25400">
+          <a:ln w="31750">
             <a:solidFill>
               <a:srgbClr val="64A0E6"/>
             </a:solidFill>
@@ -3862,8 +3862,8 @@
         </p:nvSpPr>
         <p:spPr>
           <a:xfrm>
-            <a:off x="7955279" y="2743200"/>
-            <a:ext cx="2194560" cy="2194560"/>
+            <a:off x="7955279" y="2788920"/>
+            <a:ext cx="2286000" cy="2286000"/>
           </a:xfrm>
           <a:prstGeom prst="ellipse">
             <a:avLst/>
@@ -3871,7 +3871,7 @@
           <a:solidFill>
             <a:srgbClr val="146EC8"/>
           </a:solidFill>
-          <a:ln w="25400">
+          <a:ln w="31750">
             <a:solidFill>
               <a:srgbClr val="0A50A0"/>
             </a:solidFill>
@@ -3907,8 +3907,8 @@
         </p:nvSpPr>
         <p:spPr>
           <a:xfrm>
-            <a:off x="8823960" y="3611880"/>
-            <a:ext cx="457200" cy="457200"/>
+            <a:off x="8869680" y="3703320"/>
+            <a:ext cx="475488" cy="475488"/>
           </a:xfrm>
           <a:prstGeom prst="ellipse">
             <a:avLst/>
@@ -3950,8 +3950,8 @@
         </p:nvSpPr>
         <p:spPr>
           <a:xfrm>
-            <a:off x="6583680" y="1188720"/>
-            <a:ext cx="4937760" cy="365760"/>
+            <a:off x="6583680" y="1143000"/>
+            <a:ext cx="5029200" cy="411480"/>
           </a:xfrm>
           <a:prstGeom prst="rect">
             <a:avLst/>
@@ -3965,7 +3965,7 @@
           <a:lstStyle/>
           <a:p>
             <a:pPr algn="ctr">
-              <a:defRPr sz="1400" b="1">
+              <a:defRPr sz="1550" b="1">
                 <a:solidFill>
                   <a:srgbClr val="111827"/>
                 </a:solidFill>
@@ -3986,8 +3986,8 @@
         </p:nvSpPr>
         <p:spPr>
           <a:xfrm>
-            <a:off x="6858000" y="5852160"/>
-            <a:ext cx="320040" cy="228600"/>
+            <a:off x="6766560" y="5806440"/>
+            <a:ext cx="365760" cy="256032"/>
           </a:xfrm>
           <a:prstGeom prst="rect">
             <a:avLst/>
@@ -4029,8 +4029,8 @@
         </p:nvSpPr>
         <p:spPr>
           <a:xfrm>
-            <a:off x="7269480" y="5806440"/>
-            <a:ext cx="4389120" cy="274320"/>
+            <a:off x="7223760" y="5779008"/>
+            <a:ext cx="4572000" cy="292608"/>
           </a:xfrm>
           <a:prstGeom prst="rect">
             <a:avLst/>
@@ -4044,7 +4044,7 @@
           <a:lstStyle/>
           <a:p>
             <a:pPr>
-              <a:defRPr sz="950">
+              <a:defRPr sz="1050">
                 <a:solidFill>
                   <a:srgbClr val="1F2937"/>
                 </a:solidFill>
@@ -4064,8 +4064,8 @@
         </p:nvSpPr>
         <p:spPr>
           <a:xfrm>
-            <a:off x="6858000" y="6172200"/>
-            <a:ext cx="320040" cy="228600"/>
+            <a:off x="6766560" y="6144768"/>
+            <a:ext cx="365760" cy="256032"/>
           </a:xfrm>
           <a:prstGeom prst="rect">
             <a:avLst/>
@@ -4107,8 +4107,8 @@
         </p:nvSpPr>
         <p:spPr>
           <a:xfrm>
-            <a:off x="7269480" y="6126480"/>
-            <a:ext cx="4389120" cy="274320"/>
+            <a:off x="7223760" y="6108192"/>
+            <a:ext cx="4572000" cy="292608"/>
           </a:xfrm>
           <a:prstGeom prst="rect">
             <a:avLst/>
@@ -4122,7 +4122,7 @@
           <a:lstStyle/>
           <a:p>
             <a:pPr>
-              <a:defRPr sz="950">
+              <a:defRPr sz="1050">
                 <a:solidFill>
                   <a:srgbClr val="1F2937"/>
                 </a:solidFill>
@@ -4160,8 +4160,8 @@
         </p:nvSpPr>
         <p:spPr>
           <a:xfrm>
-            <a:off x="457200" y="228600"/>
-            <a:ext cx="1234440" cy="777240"/>
+            <a:off x="457200" y="201168"/>
+            <a:ext cx="1280160" cy="822960"/>
           </a:xfrm>
           <a:prstGeom prst="ellipse">
             <a:avLst/>
@@ -4194,7 +4194,7 @@
           <a:lstStyle/>
           <a:p>
             <a:pPr algn="ctr">
-              <a:defRPr sz="1100" b="1">
+              <a:defRPr sz="1200" b="1">
                 <a:solidFill>
                   <a:srgbClr val="111827"/>
                 </a:solidFill>
@@ -4219,8 +4219,8 @@
         </p:nvSpPr>
         <p:spPr>
           <a:xfrm>
-            <a:off x="1920240" y="228600"/>
-            <a:ext cx="8046720" cy="777240"/>
+            <a:off x="1920240" y="201168"/>
+            <a:ext cx="8046720" cy="822960"/>
           </a:xfrm>
           <a:prstGeom prst="rect">
             <a:avLst/>
@@ -4234,7 +4234,7 @@
           <a:lstStyle/>
           <a:p>
             <a:pPr algn="ctr">
-              <a:defRPr sz="2100" b="1">
+              <a:defRPr sz="2150" b="1">
                 <a:solidFill>
                   <a:srgbClr val="111827"/>
                 </a:solidFill>
@@ -4263,8 +4263,8 @@
         </p:blipFill>
         <p:spPr>
           <a:xfrm>
-            <a:off x="10241280" y="182880"/>
-            <a:ext cx="1463040" cy="691294"/>
+            <a:off x="10149840" y="164592"/>
+            <a:ext cx="1600200" cy="756103"/>
           </a:xfrm>
           <a:prstGeom prst="rect">
             <a:avLst/>
@@ -4279,8 +4279,8 @@
         </p:nvSpPr>
         <p:spPr>
           <a:xfrm>
-            <a:off x="0" y="6537960"/>
-            <a:ext cx="12191695" cy="320040"/>
+            <a:off x="0" y="6510528"/>
+            <a:ext cx="12191695" cy="347472"/>
           </a:xfrm>
           <a:prstGeom prst="rect">
             <a:avLst/>
@@ -4307,11 +4307,11 @@
           </a:fontRef>
         </p:style>
         <p:txBody>
-          <a:bodyPr rtlCol="0" anchor="ctr"/>
+          <a:bodyPr rtlCol="0" anchor="ctr" tIns="54864"/>
           <a:lstStyle/>
           <a:p>
             <a:pPr algn="ctr">
-              <a:defRPr sz="1000">
+              <a:defRPr sz="1050">
                 <a:solidFill>
                   <a:srgbClr val="FFFFFF"/>
                 </a:solidFill>
@@ -4332,8 +4332,8 @@
         </p:nvSpPr>
         <p:spPr>
           <a:xfrm>
-            <a:off x="548640" y="1188720"/>
-            <a:ext cx="4572000" cy="411480"/>
+            <a:off x="548640" y="1143000"/>
+            <a:ext cx="4389120" cy="411480"/>
           </a:xfrm>
           <a:prstGeom prst="rect">
             <a:avLst/>
@@ -4347,7 +4347,7 @@
           <a:lstStyle/>
           <a:p>
             <a:pPr>
-              <a:defRPr sz="1700" b="1">
+              <a:defRPr sz="1800" b="1">
                 <a:solidFill>
                   <a:srgbClr val="1D4ED8"/>
                 </a:solidFill>
@@ -4368,8 +4368,8 @@
         </p:nvSpPr>
         <p:spPr>
           <a:xfrm>
-            <a:off x="548640" y="1691640"/>
-            <a:ext cx="4206240" cy="502920"/>
+            <a:off x="548640" y="1645920"/>
+            <a:ext cx="4206240" cy="530352"/>
           </a:xfrm>
           <a:prstGeom prst="roundRect">
             <a:avLst/>
@@ -4400,7 +4400,7 @@
           <a:lstStyle/>
           <a:p>
             <a:pPr algn="ctr">
-              <a:defRPr sz="1100" b="1">
+              <a:defRPr sz="1150" b="1">
                 <a:solidFill>
                   <a:srgbClr val="FFFFFF"/>
                 </a:solidFill>
@@ -4421,7 +4421,7 @@
         </p:nvSpPr>
         <p:spPr>
           <a:xfrm>
-            <a:off x="2514600" y="2221992"/>
+            <a:off x="2514600" y="2203704"/>
             <a:ext cx="274320" cy="182880"/>
           </a:xfrm>
           <a:prstGeom prst="downArrow">
@@ -4464,8 +4464,8 @@
         </p:nvSpPr>
         <p:spPr>
           <a:xfrm>
-            <a:off x="548640" y="2468880"/>
-            <a:ext cx="4206240" cy="502920"/>
+            <a:off x="548640" y="2441448"/>
+            <a:ext cx="4206240" cy="530352"/>
           </a:xfrm>
           <a:prstGeom prst="roundRect">
             <a:avLst/>
@@ -4496,7 +4496,7 @@
           <a:lstStyle/>
           <a:p>
             <a:pPr algn="ctr">
-              <a:defRPr sz="1100" b="1">
+              <a:defRPr sz="1150" b="1">
                 <a:solidFill>
                   <a:srgbClr val="FFFFFF"/>
                 </a:solidFill>
@@ -4560,8 +4560,8 @@
         </p:nvSpPr>
         <p:spPr>
           <a:xfrm>
-            <a:off x="548640" y="3246120"/>
-            <a:ext cx="4206240" cy="502920"/>
+            <a:off x="548640" y="3236976"/>
+            <a:ext cx="4206240" cy="530352"/>
           </a:xfrm>
           <a:prstGeom prst="roundRect">
             <a:avLst/>
@@ -4592,7 +4592,7 @@
           <a:lstStyle/>
           <a:p>
             <a:pPr algn="ctr">
-              <a:defRPr sz="1100" b="1">
+              <a:defRPr sz="1150" b="1">
                 <a:solidFill>
                   <a:srgbClr val="FFFFFF"/>
                 </a:solidFill>
@@ -4613,7 +4613,7 @@
         </p:nvSpPr>
         <p:spPr>
           <a:xfrm>
-            <a:off x="2514600" y="3776472"/>
+            <a:off x="2514600" y="3794760"/>
             <a:ext cx="274320" cy="182880"/>
           </a:xfrm>
           <a:prstGeom prst="downArrow">
@@ -4656,8 +4656,8 @@
         </p:nvSpPr>
         <p:spPr>
           <a:xfrm>
-            <a:off x="548640" y="4023360"/>
-            <a:ext cx="4206240" cy="502920"/>
+            <a:off x="548640" y="4032504"/>
+            <a:ext cx="4206240" cy="530352"/>
           </a:xfrm>
           <a:prstGeom prst="roundRect">
             <a:avLst/>
@@ -4688,7 +4688,7 @@
           <a:lstStyle/>
           <a:p>
             <a:pPr algn="ctr">
-              <a:defRPr sz="1100" b="1">
+              <a:defRPr sz="1150" b="1">
                 <a:solidFill>
                   <a:srgbClr val="FFFFFF"/>
                 </a:solidFill>
@@ -4709,7 +4709,7 @@
         </p:nvSpPr>
         <p:spPr>
           <a:xfrm>
-            <a:off x="2514600" y="4553712"/>
+            <a:off x="2514600" y="4590288"/>
             <a:ext cx="274320" cy="182880"/>
           </a:xfrm>
           <a:prstGeom prst="downArrow">
@@ -4752,8 +4752,8 @@
         </p:nvSpPr>
         <p:spPr>
           <a:xfrm>
-            <a:off x="548640" y="4800600"/>
-            <a:ext cx="4206240" cy="502920"/>
+            <a:off x="548640" y="4828032"/>
+            <a:ext cx="4206240" cy="530352"/>
           </a:xfrm>
           <a:prstGeom prst="roundRect">
             <a:avLst/>
@@ -4784,7 +4784,7 @@
           <a:lstStyle/>
           <a:p>
             <a:pPr algn="ctr">
-              <a:defRPr sz="1100" b="1">
+              <a:defRPr sz="1150" b="1">
                 <a:solidFill>
                   <a:srgbClr val="FFFFFF"/>
                 </a:solidFill>
@@ -4805,7 +4805,7 @@
         </p:nvSpPr>
         <p:spPr>
           <a:xfrm>
-            <a:off x="2514600" y="5330952"/>
+            <a:off x="2514600" y="5385816"/>
             <a:ext cx="274320" cy="182880"/>
           </a:xfrm>
           <a:prstGeom prst="downArrow">
@@ -4848,8 +4848,8 @@
         </p:nvSpPr>
         <p:spPr>
           <a:xfrm>
-            <a:off x="548640" y="5577840"/>
-            <a:ext cx="4206240" cy="502920"/>
+            <a:off x="548640" y="5623560"/>
+            <a:ext cx="4206240" cy="530352"/>
           </a:xfrm>
           <a:prstGeom prst="roundRect">
             <a:avLst/>
@@ -4880,7 +4880,7 @@
           <a:lstStyle/>
           <a:p>
             <a:pPr algn="ctr">
-              <a:defRPr sz="1100" b="1">
+              <a:defRPr sz="1150" b="1">
                 <a:solidFill>
                   <a:srgbClr val="FFFFFF"/>
                 </a:solidFill>
@@ -4909,8 +4909,8 @@
         </p:blipFill>
         <p:spPr>
           <a:xfrm>
-            <a:off x="5120640" y="1234440"/>
-            <a:ext cx="6583680" cy="3976813"/>
+            <a:off x="4937760" y="1188720"/>
+            <a:ext cx="6766560" cy="4087280"/>
           </a:xfrm>
           <a:prstGeom prst="rect">
             <a:avLst/>
@@ -4925,8 +4925,8 @@
         </p:nvSpPr>
         <p:spPr>
           <a:xfrm>
-            <a:off x="5120640" y="4663440"/>
-            <a:ext cx="6583680" cy="320040"/>
+            <a:off x="4937760" y="4663440"/>
+            <a:ext cx="6766560" cy="320040"/>
           </a:xfrm>
           <a:prstGeom prst="rect">
             <a:avLst/>
@@ -4940,7 +4940,7 @@
           <a:lstStyle/>
           <a:p>
             <a:pPr>
-              <a:defRPr sz="1300" b="1">
+              <a:defRPr sz="1400" b="1">
                 <a:solidFill>
                   <a:srgbClr val="1D4ED8"/>
                 </a:solidFill>
@@ -4948,7 +4948,7 @@
               </a:defRPr>
             </a:pPr>
             <a:r>
-              <a:t>Technologies &amp; Core Implementation:</a:t>
+              <a:t>Technologies &amp; Implementation:</a:t>
             </a:r>
           </a:p>
         </p:txBody>
@@ -4961,8 +4961,8 @@
         </p:nvSpPr>
         <p:spPr>
           <a:xfrm>
-            <a:off x="5120640" y="5029200"/>
-            <a:ext cx="6583680" cy="1371600"/>
+            <a:off x="4937760" y="5029200"/>
+            <a:ext cx="6766560" cy="1371600"/>
           </a:xfrm>
           <a:prstGeom prst="rect">
             <a:avLst/>
@@ -4977,9 +4977,9 @@
           <a:p>
             <a:pPr>
               <a:spcAft>
-                <a:spcPts val="200"/>
+                <a:spcPts val="300"/>
               </a:spcAft>
-              <a:defRPr sz="1050">
+              <a:defRPr sz="1100">
                 <a:solidFill>
                   <a:srgbClr val="1F2937"/>
                 </a:solidFill>
@@ -4987,15 +4987,15 @@
               </a:defRPr>
             </a:pPr>
             <a:r>
-              <a:t>• Python 3.12, NumPy (vectorized hashing), Open3D (point cloud geometry)</a:t>
+              <a:t>• Python 3.12, NumPy (vectorized hashing), Open3D (point cloud processing)</a:t>
             </a:r>
           </a:p>
           <a:p>
             <a:pPr>
               <a:spcAft>
-                <a:spcPts val="200"/>
+                <a:spcPts val="300"/>
               </a:spcAft>
-              <a:defRPr sz="1050">
+              <a:defRPr sz="1100">
                 <a:solidFill>
                   <a:srgbClr val="1F2937"/>
                 </a:solidFill>
@@ -5009,9 +5009,9 @@
           <a:p>
             <a:pPr>
               <a:spcAft>
-                <a:spcPts val="200"/>
+                <a:spcPts val="300"/>
               </a:spcAft>
-              <a:defRPr sz="1050">
+              <a:defRPr sz="1100">
                 <a:solidFill>
                   <a:srgbClr val="1F2937"/>
                 </a:solidFill>
@@ -5025,9 +5025,9 @@
           <a:p>
             <a:pPr>
               <a:spcAft>
-                <a:spcPts val="200"/>
+                <a:spcPts val="300"/>
               </a:spcAft>
-              <a:defRPr sz="1050">
+              <a:defRPr sz="1100">
                 <a:solidFill>
                   <a:srgbClr val="1F2937"/>
                 </a:solidFill>
@@ -5066,8 +5066,8 @@
         </p:nvSpPr>
         <p:spPr>
           <a:xfrm>
-            <a:off x="457200" y="228600"/>
-            <a:ext cx="1234440" cy="777240"/>
+            <a:off x="457200" y="201168"/>
+            <a:ext cx="1280160" cy="822960"/>
           </a:xfrm>
           <a:prstGeom prst="ellipse">
             <a:avLst/>
@@ -5100,7 +5100,7 @@
           <a:lstStyle/>
           <a:p>
             <a:pPr algn="ctr">
-              <a:defRPr sz="1100" b="1">
+              <a:defRPr sz="1200" b="1">
                 <a:solidFill>
                   <a:srgbClr val="111827"/>
                 </a:solidFill>
@@ -5125,8 +5125,8 @@
         </p:nvSpPr>
         <p:spPr>
           <a:xfrm>
-            <a:off x="1920240" y="228600"/>
-            <a:ext cx="8046720" cy="777240"/>
+            <a:off x="1920240" y="201168"/>
+            <a:ext cx="8046720" cy="822960"/>
           </a:xfrm>
           <a:prstGeom prst="rect">
             <a:avLst/>
@@ -5140,7 +5140,7 @@
           <a:lstStyle/>
           <a:p>
             <a:pPr algn="ctr">
-              <a:defRPr sz="2100" b="1">
+              <a:defRPr sz="2150" b="1">
                 <a:solidFill>
                   <a:srgbClr val="111827"/>
                 </a:solidFill>
@@ -5169,8 +5169,8 @@
         </p:blipFill>
         <p:spPr>
           <a:xfrm>
-            <a:off x="10241280" y="182880"/>
-            <a:ext cx="1463040" cy="691294"/>
+            <a:off x="10149840" y="164592"/>
+            <a:ext cx="1600200" cy="756103"/>
           </a:xfrm>
           <a:prstGeom prst="rect">
             <a:avLst/>
@@ -5185,8 +5185,8 @@
         </p:nvSpPr>
         <p:spPr>
           <a:xfrm>
-            <a:off x="0" y="6537960"/>
-            <a:ext cx="12191695" cy="320040"/>
+            <a:off x="0" y="6510528"/>
+            <a:ext cx="12191695" cy="347472"/>
           </a:xfrm>
           <a:prstGeom prst="rect">
             <a:avLst/>
@@ -5213,11 +5213,11 @@
           </a:fontRef>
         </p:style>
         <p:txBody>
-          <a:bodyPr rtlCol="0" anchor="ctr"/>
+          <a:bodyPr rtlCol="0" anchor="ctr" tIns="54864"/>
           <a:lstStyle/>
           <a:p>
             <a:pPr algn="ctr">
-              <a:defRPr sz="1000">
+              <a:defRPr sz="1050">
                 <a:solidFill>
                   <a:srgbClr val="FFFFFF"/>
                 </a:solidFill>
@@ -5238,8 +5238,8 @@
         </p:nvSpPr>
         <p:spPr>
           <a:xfrm>
-            <a:off x="548640" y="1188720"/>
-            <a:ext cx="2011680" cy="411480"/>
+            <a:off x="548640" y="1143000"/>
+            <a:ext cx="2011680" cy="438912"/>
           </a:xfrm>
           <a:prstGeom prst="roundRect">
             <a:avLst/>
@@ -5270,7 +5270,7 @@
           <a:lstStyle/>
           <a:p>
             <a:pPr algn="ctr">
-              <a:defRPr sz="1250" b="1">
+              <a:defRPr sz="1350" b="1">
                 <a:solidFill>
                   <a:srgbClr val="FFFFFF"/>
                 </a:solidFill>
@@ -5309,7 +5309,7 @@
               <a:spcAft>
                 <a:spcPts val="300"/>
               </a:spcAft>
-              <a:defRPr sz="1050">
+              <a:defRPr sz="1100">
                 <a:solidFill>
                   <a:srgbClr val="1F2937"/>
                 </a:solidFill>
@@ -5325,7 +5325,7 @@
               <a:spcAft>
                 <a:spcPts val="300"/>
               </a:spcAft>
-              <a:defRPr sz="1050">
+              <a:defRPr sz="1100">
                 <a:solidFill>
                   <a:srgbClr val="1F2937"/>
                 </a:solidFill>
@@ -5341,7 +5341,7 @@
               <a:spcAft>
                 <a:spcPts val="300"/>
               </a:spcAft>
-              <a:defRPr sz="1050">
+              <a:defRPr sz="1100">
                 <a:solidFill>
                   <a:srgbClr val="1F2937"/>
                 </a:solidFill>
@@ -5357,7 +5357,7 @@
               <a:spcAft>
                 <a:spcPts val="300"/>
               </a:spcAft>
-              <a:defRPr sz="1050">
+              <a:defRPr sz="1100">
                 <a:solidFill>
                   <a:srgbClr val="1F2937"/>
                 </a:solidFill>
@@ -5378,8 +5378,8 @@
         </p:nvSpPr>
         <p:spPr>
           <a:xfrm>
-            <a:off x="548640" y="3657600"/>
-            <a:ext cx="2011680" cy="411480"/>
+            <a:off x="548640" y="3611880"/>
+            <a:ext cx="2011680" cy="438912"/>
           </a:xfrm>
           <a:prstGeom prst="roundRect">
             <a:avLst/>
@@ -5410,7 +5410,7 @@
           <a:lstStyle/>
           <a:p>
             <a:pPr algn="ctr">
-              <a:defRPr sz="1250" b="1">
+              <a:defRPr sz="1350" b="1">
                 <a:solidFill>
                   <a:srgbClr val="FFFFFF"/>
                 </a:solidFill>
@@ -5449,7 +5449,7 @@
               <a:spcAft>
                 <a:spcPts val="300"/>
               </a:spcAft>
-              <a:defRPr sz="1050">
+              <a:defRPr sz="1100">
                 <a:solidFill>
                   <a:srgbClr val="1F2937"/>
                 </a:solidFill>
@@ -5465,7 +5465,7 @@
               <a:spcAft>
                 <a:spcPts val="300"/>
               </a:spcAft>
-              <a:defRPr sz="1050">
+              <a:defRPr sz="1100">
                 <a:solidFill>
                   <a:srgbClr val="1F2937"/>
                 </a:solidFill>
@@ -5481,7 +5481,7 @@
               <a:spcAft>
                 <a:spcPts val="300"/>
               </a:spcAft>
-              <a:defRPr sz="1050">
+              <a:defRPr sz="1100">
                 <a:solidFill>
                   <a:srgbClr val="1F2937"/>
                 </a:solidFill>
@@ -5497,7 +5497,7 @@
               <a:spcAft>
                 <a:spcPts val="300"/>
               </a:spcAft>
-              <a:defRPr sz="1050">
+              <a:defRPr sz="1100">
                 <a:solidFill>
                   <a:srgbClr val="1F2937"/>
                 </a:solidFill>
@@ -5518,8 +5518,8 @@
         </p:nvSpPr>
         <p:spPr>
           <a:xfrm>
-            <a:off x="6217920" y="1188720"/>
-            <a:ext cx="2377440" cy="411480"/>
+            <a:off x="6126480" y="1143000"/>
+            <a:ext cx="2468880" cy="438912"/>
           </a:xfrm>
           <a:prstGeom prst="roundRect">
             <a:avLst/>
@@ -5550,7 +5550,7 @@
           <a:lstStyle/>
           <a:p>
             <a:pPr algn="ctr">
-              <a:defRPr sz="1250" b="1">
+              <a:defRPr sz="1350" b="1">
                 <a:solidFill>
                   <a:srgbClr val="FFFFFF"/>
                 </a:solidFill>
@@ -5571,8 +5571,8 @@
         </p:nvSpPr>
         <p:spPr>
           <a:xfrm>
-            <a:off x="6217920" y="1691640"/>
-            <a:ext cx="5303520" cy="1463040"/>
+            <a:off x="6126480" y="1691640"/>
+            <a:ext cx="5486400" cy="1463040"/>
           </a:xfrm>
           <a:prstGeom prst="rect">
             <a:avLst/>
@@ -5589,7 +5589,7 @@
               <a:spcAft>
                 <a:spcPts val="300"/>
               </a:spcAft>
-              <a:defRPr sz="1050">
+              <a:defRPr sz="1100">
                 <a:solidFill>
                   <a:srgbClr val="1F2937"/>
                 </a:solidFill>
@@ -5605,7 +5605,7 @@
               <a:spcAft>
                 <a:spcPts val="300"/>
               </a:spcAft>
-              <a:defRPr sz="1050">
+              <a:defRPr sz="1100">
                 <a:solidFill>
                   <a:srgbClr val="1F2937"/>
                 </a:solidFill>
@@ -5621,7 +5621,7 @@
               <a:spcAft>
                 <a:spcPts val="300"/>
               </a:spcAft>
-              <a:defRPr sz="1050">
+              <a:defRPr sz="1100">
                 <a:solidFill>
                   <a:srgbClr val="1F2937"/>
                 </a:solidFill>
@@ -5637,7 +5637,7 @@
               <a:spcAft>
                 <a:spcPts val="300"/>
               </a:spcAft>
-              <a:defRPr sz="1050">
+              <a:defRPr sz="1100">
                 <a:solidFill>
                   <a:srgbClr val="1F2937"/>
                 </a:solidFill>
@@ -5666,8 +5666,8 @@
         </p:blipFill>
         <p:spPr>
           <a:xfrm>
-            <a:off x="6217920" y="3291840"/>
-            <a:ext cx="5303520" cy="3897155"/>
+            <a:off x="6126480" y="3154680"/>
+            <a:ext cx="5669280" cy="4165925"/>
           </a:xfrm>
           <a:prstGeom prst="rect">
             <a:avLst/>
@@ -5700,8 +5700,8 @@
         </p:nvSpPr>
         <p:spPr>
           <a:xfrm>
-            <a:off x="457200" y="228600"/>
-            <a:ext cx="1234440" cy="777240"/>
+            <a:off x="457200" y="201168"/>
+            <a:ext cx="1280160" cy="822960"/>
           </a:xfrm>
           <a:prstGeom prst="ellipse">
             <a:avLst/>
@@ -5734,7 +5734,7 @@
           <a:lstStyle/>
           <a:p>
             <a:pPr algn="ctr">
-              <a:defRPr sz="1100" b="1">
+              <a:defRPr sz="1200" b="1">
                 <a:solidFill>
                   <a:srgbClr val="111827"/>
                 </a:solidFill>
@@ -5759,8 +5759,8 @@
         </p:nvSpPr>
         <p:spPr>
           <a:xfrm>
-            <a:off x="1920240" y="228600"/>
-            <a:ext cx="8046720" cy="777240"/>
+            <a:off x="1920240" y="201168"/>
+            <a:ext cx="8046720" cy="822960"/>
           </a:xfrm>
           <a:prstGeom prst="rect">
             <a:avLst/>
@@ -5774,7 +5774,7 @@
           <a:lstStyle/>
           <a:p>
             <a:pPr algn="ctr">
-              <a:defRPr sz="2100" b="1">
+              <a:defRPr sz="2150" b="1">
                 <a:solidFill>
                   <a:srgbClr val="111827"/>
                 </a:solidFill>
@@ -5803,8 +5803,8 @@
         </p:blipFill>
         <p:spPr>
           <a:xfrm>
-            <a:off x="10241280" y="182880"/>
-            <a:ext cx="1463040" cy="691294"/>
+            <a:off x="10149840" y="164592"/>
+            <a:ext cx="1600200" cy="756103"/>
           </a:xfrm>
           <a:prstGeom prst="rect">
             <a:avLst/>
@@ -5819,8 +5819,8 @@
         </p:nvSpPr>
         <p:spPr>
           <a:xfrm>
-            <a:off x="0" y="6537960"/>
-            <a:ext cx="12191695" cy="320040"/>
+            <a:off x="0" y="6510528"/>
+            <a:ext cx="12191695" cy="347472"/>
           </a:xfrm>
           <a:prstGeom prst="rect">
             <a:avLst/>
@@ -5847,11 +5847,11 @@
           </a:fontRef>
         </p:style>
         <p:txBody>
-          <a:bodyPr rtlCol="0" anchor="ctr"/>
+          <a:bodyPr rtlCol="0" anchor="ctr" tIns="54864"/>
           <a:lstStyle/>
           <a:p>
             <a:pPr algn="ctr">
-              <a:defRPr sz="1000">
+              <a:defRPr sz="1050">
                 <a:solidFill>
                   <a:srgbClr val="FFFFFF"/>
                 </a:solidFill>
@@ -5872,8 +5872,8 @@
         </p:nvSpPr>
         <p:spPr>
           <a:xfrm>
-            <a:off x="548640" y="1188720"/>
-            <a:ext cx="1828800" cy="411480"/>
+            <a:off x="548640" y="1143000"/>
+            <a:ext cx="1920240" cy="438912"/>
           </a:xfrm>
           <a:prstGeom prst="roundRect">
             <a:avLst/>
@@ -5904,7 +5904,7 @@
           <a:lstStyle/>
           <a:p>
             <a:pPr algn="ctr">
-              <a:defRPr sz="1250" b="1">
+              <a:defRPr sz="1350" b="1">
                 <a:solidFill>
                   <a:srgbClr val="FFFFFF"/>
                 </a:solidFill>
@@ -5925,8 +5925,8 @@
         </p:nvSpPr>
         <p:spPr>
           <a:xfrm>
-            <a:off x="548640" y="1691640"/>
-            <a:ext cx="4572000" cy="1463040"/>
+            <a:off x="548640" y="1664208"/>
+            <a:ext cx="4389120" cy="1463040"/>
           </a:xfrm>
           <a:prstGeom prst="rect">
             <a:avLst/>
@@ -5943,7 +5943,7 @@
               <a:spcAft>
                 <a:spcPts val="200"/>
               </a:spcAft>
-              <a:defRPr sz="1000">
+              <a:defRPr sz="1100">
                 <a:solidFill>
                   <a:srgbClr val="1F2937"/>
                 </a:solidFill>
@@ -5959,7 +5959,7 @@
               <a:spcAft>
                 <a:spcPts val="200"/>
               </a:spcAft>
-              <a:defRPr sz="1000">
+              <a:defRPr sz="1100">
                 <a:solidFill>
                   <a:srgbClr val="1F2937"/>
                 </a:solidFill>
@@ -5975,7 +5975,7 @@
               <a:spcAft>
                 <a:spcPts val="200"/>
               </a:spcAft>
-              <a:defRPr sz="1000">
+              <a:defRPr sz="1100">
                 <a:solidFill>
                   <a:srgbClr val="1F2937"/>
                 </a:solidFill>
@@ -5991,7 +5991,7 @@
               <a:spcAft>
                 <a:spcPts val="200"/>
               </a:spcAft>
-              <a:defRPr sz="1000">
+              <a:defRPr sz="1100">
                 <a:solidFill>
                   <a:srgbClr val="1F2937"/>
                 </a:solidFill>
@@ -6013,7 +6013,7 @@
         <p:spPr>
           <a:xfrm>
             <a:off x="548640" y="3246120"/>
-            <a:ext cx="2011680" cy="411480"/>
+            <a:ext cx="2103120" cy="438912"/>
           </a:xfrm>
           <a:prstGeom prst="roundRect">
             <a:avLst/>
@@ -6044,7 +6044,7 @@
           <a:lstStyle/>
           <a:p>
             <a:pPr algn="ctr">
-              <a:defRPr sz="1250" b="1">
+              <a:defRPr sz="1350" b="1">
                 <a:solidFill>
                   <a:srgbClr val="FFFFFF"/>
                 </a:solidFill>
@@ -6065,8 +6065,8 @@
         </p:nvSpPr>
         <p:spPr>
           <a:xfrm>
-            <a:off x="548640" y="3749039"/>
-            <a:ext cx="4572000" cy="1280160"/>
+            <a:off x="548640" y="3767328"/>
+            <a:ext cx="4389120" cy="1280160"/>
           </a:xfrm>
           <a:prstGeom prst="rect">
             <a:avLst/>
@@ -6083,7 +6083,7 @@
               <a:spcAft>
                 <a:spcPts val="200"/>
               </a:spcAft>
-              <a:defRPr sz="1000">
+              <a:defRPr sz="1100">
                 <a:solidFill>
                   <a:srgbClr val="1F2937"/>
                 </a:solidFill>
@@ -6099,7 +6099,7 @@
               <a:spcAft>
                 <a:spcPts val="200"/>
               </a:spcAft>
-              <a:defRPr sz="1000">
+              <a:defRPr sz="1100">
                 <a:solidFill>
                   <a:srgbClr val="1F2937"/>
                 </a:solidFill>
@@ -6115,7 +6115,7 @@
               <a:spcAft>
                 <a:spcPts val="200"/>
               </a:spcAft>
-              <a:defRPr sz="1000">
+              <a:defRPr sz="1100">
                 <a:solidFill>
                   <a:srgbClr val="1F2937"/>
                 </a:solidFill>
@@ -6136,8 +6136,8 @@
         </p:nvSpPr>
         <p:spPr>
           <a:xfrm>
-            <a:off x="548640" y="4846320"/>
-            <a:ext cx="1828800" cy="411480"/>
+            <a:off x="548640" y="4892040"/>
+            <a:ext cx="1920240" cy="438912"/>
           </a:xfrm>
           <a:prstGeom prst="roundRect">
             <a:avLst/>
@@ -6168,7 +6168,7 @@
           <a:lstStyle/>
           <a:p>
             <a:pPr algn="ctr">
-              <a:defRPr sz="1250" b="1">
+              <a:defRPr sz="1350" b="1">
                 <a:solidFill>
                   <a:srgbClr val="FFFFFF"/>
                 </a:solidFill>
@@ -6189,8 +6189,8 @@
         </p:nvSpPr>
         <p:spPr>
           <a:xfrm>
-            <a:off x="548640" y="5303520"/>
-            <a:ext cx="4572000" cy="1188720"/>
+            <a:off x="548640" y="5394960"/>
+            <a:ext cx="4389120" cy="1188720"/>
           </a:xfrm>
           <a:prstGeom prst="rect">
             <a:avLst/>
@@ -6207,7 +6207,7 @@
               <a:spcAft>
                 <a:spcPts val="200"/>
               </a:spcAft>
-              <a:defRPr sz="1000">
+              <a:defRPr sz="1100">
                 <a:solidFill>
                   <a:srgbClr val="1F2937"/>
                 </a:solidFill>
@@ -6223,7 +6223,7 @@
               <a:spcAft>
                 <a:spcPts val="200"/>
               </a:spcAft>
-              <a:defRPr sz="1000">
+              <a:defRPr sz="1100">
                 <a:solidFill>
                   <a:srgbClr val="1F2937"/>
                 </a:solidFill>
@@ -6239,7 +6239,7 @@
               <a:spcAft>
                 <a:spcPts val="200"/>
               </a:spcAft>
-              <a:defRPr sz="1000">
+              <a:defRPr sz="1100">
                 <a:solidFill>
                   <a:srgbClr val="1F2937"/>
                 </a:solidFill>
@@ -6260,8 +6260,8 @@
         </p:nvSpPr>
         <p:spPr>
           <a:xfrm>
-            <a:off x="5394960" y="1143000"/>
-            <a:ext cx="6217920" cy="320040"/>
+            <a:off x="5212080" y="1115568"/>
+            <a:ext cx="6492240" cy="320040"/>
           </a:xfrm>
           <a:prstGeom prst="rect">
             <a:avLst/>
@@ -6275,7 +6275,7 @@
           <a:lstStyle/>
           <a:p>
             <a:pPr>
-              <a:defRPr sz="1300" b="1">
+              <a:defRPr sz="1400" b="1">
                 <a:solidFill>
                   <a:srgbClr val="1D4ED8"/>
                 </a:solidFill>
@@ -6304,8 +6304,8 @@
         </p:blipFill>
         <p:spPr>
           <a:xfrm>
-            <a:off x="5394960" y="1554480"/>
-            <a:ext cx="3154680" cy="2366010"/>
+            <a:off x="5212080" y="1508760"/>
+            <a:ext cx="3246120" cy="2434590"/>
           </a:xfrm>
           <a:prstGeom prst="rect">
             <a:avLst/>
@@ -6320,8 +6320,8 @@
         </p:nvSpPr>
         <p:spPr>
           <a:xfrm>
-            <a:off x="5394960" y="3931920"/>
-            <a:ext cx="3154680" cy="274320"/>
+            <a:off x="5212080" y="3977639"/>
+            <a:ext cx="3246120" cy="274320"/>
           </a:xfrm>
           <a:prstGeom prst="rect">
             <a:avLst/>
@@ -6335,7 +6335,7 @@
           <a:lstStyle/>
           <a:p>
             <a:pPr algn="ctr">
-              <a:defRPr sz="1000" b="1">
+              <a:defRPr sz="1100" b="1">
                 <a:solidFill>
                   <a:srgbClr val="1F2937"/>
                 </a:solidFill>
@@ -6363,8 +6363,8 @@
         </p:blipFill>
         <p:spPr>
           <a:xfrm>
-            <a:off x="8686800" y="1554480"/>
-            <a:ext cx="3154680" cy="2366010"/>
+            <a:off x="8549640" y="1508760"/>
+            <a:ext cx="3246120" cy="2434590"/>
           </a:xfrm>
           <a:prstGeom prst="rect">
             <a:avLst/>
@@ -6379,8 +6379,8 @@
         </p:nvSpPr>
         <p:spPr>
           <a:xfrm>
-            <a:off x="8686800" y="3931920"/>
-            <a:ext cx="3154680" cy="274320"/>
+            <a:off x="8549640" y="3977639"/>
+            <a:ext cx="3246120" cy="274320"/>
           </a:xfrm>
           <a:prstGeom prst="rect">
             <a:avLst/>
@@ -6394,7 +6394,7 @@
           <a:lstStyle/>
           <a:p>
             <a:pPr algn="ctr">
-              <a:defRPr sz="1000" b="1">
+              <a:defRPr sz="1100" b="1">
                 <a:solidFill>
                   <a:srgbClr val="1F2937"/>
                 </a:solidFill>
@@ -6414,8 +6414,8 @@
         </p:nvSpPr>
         <p:spPr>
           <a:xfrm>
-            <a:off x="5394960" y="4343400"/>
-            <a:ext cx="6400800" cy="2011680"/>
+            <a:off x="5212080" y="4389120"/>
+            <a:ext cx="6583680" cy="1965960"/>
           </a:xfrm>
           <a:prstGeom prst="roundRect">
             <a:avLst/>
@@ -6444,14 +6444,14 @@
           </a:fontRef>
         </p:style>
         <p:txBody>
-          <a:bodyPr rtlCol="0" anchor="ctr" wrap="square" lIns="182880" tIns="182880"/>
+          <a:bodyPr rtlCol="0" anchor="ctr" wrap="square" lIns="164592" tIns="164592"/>
           <a:lstStyle/>
           <a:p>
             <a:pPr algn="ctr">
               <a:spcAft>
                 <a:spcPts val="400"/>
               </a:spcAft>
-              <a:defRPr sz="1100" b="1">
+              <a:defRPr sz="1200" b="1">
                 <a:solidFill>
                   <a:srgbClr val="1D4ED8"/>
                 </a:solidFill>
@@ -6467,7 +6467,7 @@
               <a:spcAft>
                 <a:spcPts val="200"/>
               </a:spcAft>
-              <a:defRPr sz="950">
+              <a:defRPr sz="1019">
                 <a:solidFill>
                   <a:srgbClr val="1F2937"/>
                 </a:solidFill>
@@ -6483,7 +6483,7 @@
               <a:spcAft>
                 <a:spcPts val="200"/>
               </a:spcAft>
-              <a:defRPr sz="950">
+              <a:defRPr sz="1019">
                 <a:solidFill>
                   <a:srgbClr val="1F2937"/>
                 </a:solidFill>
@@ -6499,7 +6499,7 @@
               <a:spcAft>
                 <a:spcPts val="200"/>
               </a:spcAft>
-              <a:defRPr sz="950">
+              <a:defRPr sz="1019">
                 <a:solidFill>
                   <a:srgbClr val="1F2937"/>
                 </a:solidFill>
@@ -6515,7 +6515,7 @@
               <a:spcAft>
                 <a:spcPts val="200"/>
               </a:spcAft>
-              <a:defRPr sz="950">
+              <a:defRPr sz="1019">
                 <a:solidFill>
                   <a:srgbClr val="1F2937"/>
                 </a:solidFill>
@@ -6554,8 +6554,8 @@
         </p:nvSpPr>
         <p:spPr>
           <a:xfrm>
-            <a:off x="457200" y="228600"/>
-            <a:ext cx="1234440" cy="777240"/>
+            <a:off x="457200" y="201168"/>
+            <a:ext cx="1280160" cy="822960"/>
           </a:xfrm>
           <a:prstGeom prst="ellipse">
             <a:avLst/>
@@ -6588,7 +6588,7 @@
           <a:lstStyle/>
           <a:p>
             <a:pPr algn="ctr">
-              <a:defRPr sz="1100" b="1">
+              <a:defRPr sz="1200" b="1">
                 <a:solidFill>
                   <a:srgbClr val="111827"/>
                 </a:solidFill>
@@ -6613,8 +6613,8 @@
         </p:nvSpPr>
         <p:spPr>
           <a:xfrm>
-            <a:off x="1920240" y="228600"/>
-            <a:ext cx="8046720" cy="777240"/>
+            <a:off x="1920240" y="201168"/>
+            <a:ext cx="8046720" cy="822960"/>
           </a:xfrm>
           <a:prstGeom prst="rect">
             <a:avLst/>
@@ -6628,7 +6628,7 @@
           <a:lstStyle/>
           <a:p>
             <a:pPr algn="ctr">
-              <a:defRPr sz="2100" b="1">
+              <a:defRPr sz="2150" b="1">
                 <a:solidFill>
                   <a:srgbClr val="111827"/>
                 </a:solidFill>
@@ -6657,8 +6657,8 @@
         </p:blipFill>
         <p:spPr>
           <a:xfrm>
-            <a:off x="10241280" y="182880"/>
-            <a:ext cx="1463040" cy="691294"/>
+            <a:off x="10149840" y="164592"/>
+            <a:ext cx="1600200" cy="756103"/>
           </a:xfrm>
           <a:prstGeom prst="rect">
             <a:avLst/>
@@ -6673,8 +6673,8 @@
         </p:nvSpPr>
         <p:spPr>
           <a:xfrm>
-            <a:off x="0" y="6537960"/>
-            <a:ext cx="12191695" cy="320040"/>
+            <a:off x="0" y="6510528"/>
+            <a:ext cx="12191695" cy="347472"/>
           </a:xfrm>
           <a:prstGeom prst="rect">
             <a:avLst/>
@@ -6701,11 +6701,11 @@
           </a:fontRef>
         </p:style>
         <p:txBody>
-          <a:bodyPr rtlCol="0" anchor="ctr"/>
+          <a:bodyPr rtlCol="0" anchor="ctr" tIns="54864"/>
           <a:lstStyle/>
           <a:p>
             <a:pPr algn="ctr">
-              <a:defRPr sz="1000">
+              <a:defRPr sz="1050">
                 <a:solidFill>
                   <a:srgbClr val="FFFFFF"/>
                 </a:solidFill>
@@ -6726,7 +6726,7 @@
         </p:nvSpPr>
         <p:spPr>
           <a:xfrm>
-            <a:off x="548640" y="1188720"/>
+            <a:off x="548640" y="1143000"/>
             <a:ext cx="4114800" cy="365760"/>
           </a:xfrm>
           <a:prstGeom prst="rect">
@@ -6741,7 +6741,7 @@
           <a:lstStyle/>
           <a:p>
             <a:pPr>
-              <a:defRPr sz="1600" b="1">
+              <a:defRPr sz="1700" b="1">
                 <a:solidFill>
                   <a:srgbClr val="1D4ED8"/>
                 </a:solidFill>
@@ -6780,7 +6780,7 @@
               <a:spcAft>
                 <a:spcPts val="200"/>
               </a:spcAft>
-              <a:defRPr sz="1050">
+              <a:defRPr sz="1100">
                 <a:solidFill>
                   <a:srgbClr val="1F2937"/>
                 </a:solidFill>
@@ -6796,7 +6796,7 @@
               <a:spcAft>
                 <a:spcPts val="200"/>
               </a:spcAft>
-              <a:defRPr sz="1050">
+              <a:defRPr sz="1100">
                 <a:solidFill>
                   <a:srgbClr val="1F2937"/>
                 </a:solidFill>
@@ -6812,7 +6812,7 @@
               <a:spcAft>
                 <a:spcPts val="200"/>
               </a:spcAft>
-              <a:defRPr sz="1050">
+              <a:defRPr sz="1100">
                 <a:solidFill>
                   <a:srgbClr val="1F2937"/>
                 </a:solidFill>
@@ -6828,7 +6828,7 @@
               <a:spcAft>
                 <a:spcPts val="200"/>
               </a:spcAft>
-              <a:defRPr sz="1050">
+              <a:defRPr sz="1100">
                 <a:solidFill>
                   <a:srgbClr val="1F2937"/>
                 </a:solidFill>
@@ -6844,7 +6844,7 @@
               <a:spcAft>
                 <a:spcPts val="200"/>
               </a:spcAft>
-              <a:defRPr sz="1050">
+              <a:defRPr sz="1100">
                 <a:solidFill>
                   <a:srgbClr val="1F2937"/>
                 </a:solidFill>
@@ -6865,7 +6865,7 @@
         </p:nvSpPr>
         <p:spPr>
           <a:xfrm>
-            <a:off x="548640" y="3474720"/>
+            <a:off x="548640" y="3429000"/>
             <a:ext cx="4114800" cy="365760"/>
           </a:xfrm>
           <a:prstGeom prst="rect">
@@ -6880,7 +6880,7 @@
           <a:lstStyle/>
           <a:p>
             <a:pPr>
-              <a:defRPr sz="1600" b="1">
+              <a:defRPr sz="1700" b="1">
                 <a:solidFill>
                   <a:srgbClr val="1D4ED8"/>
                 </a:solidFill>
@@ -6901,7 +6901,7 @@
         </p:nvSpPr>
         <p:spPr>
           <a:xfrm>
-            <a:off x="548640" y="3886200"/>
+            <a:off x="548640" y="3840480"/>
             <a:ext cx="4114800" cy="2377440"/>
           </a:xfrm>
           <a:prstGeom prst="rect">
@@ -6919,7 +6919,7 @@
               <a:spcAft>
                 <a:spcPts val="300"/>
               </a:spcAft>
-              <a:defRPr sz="1000">
+              <a:defRPr sz="1050">
                 <a:solidFill>
                   <a:srgbClr val="1F2937"/>
                 </a:solidFill>
@@ -6935,7 +6935,7 @@
               <a:spcAft>
                 <a:spcPts val="300"/>
               </a:spcAft>
-              <a:defRPr sz="1000">
+              <a:defRPr sz="1050">
                 <a:solidFill>
                   <a:srgbClr val="1F2937"/>
                 </a:solidFill>
@@ -6951,7 +6951,7 @@
               <a:spcAft>
                 <a:spcPts val="300"/>
               </a:spcAft>
-              <a:defRPr sz="1000">
+              <a:defRPr sz="1050">
                 <a:solidFill>
                   <a:srgbClr val="1F2937"/>
                 </a:solidFill>
@@ -6967,7 +6967,7 @@
               <a:spcAft>
                 <a:spcPts val="300"/>
               </a:spcAft>
-              <a:defRPr sz="1000">
+              <a:defRPr sz="1050">
                 <a:solidFill>
                   <a:srgbClr val="1F2937"/>
                 </a:solidFill>
@@ -6983,7 +6983,7 @@
               <a:spcAft>
                 <a:spcPts val="300"/>
               </a:spcAft>
-              <a:defRPr sz="1000">
+              <a:defRPr sz="1050">
                 <a:solidFill>
                   <a:srgbClr val="1F2937"/>
                 </a:solidFill>
@@ -7004,8 +7004,8 @@
         </p:nvSpPr>
         <p:spPr>
           <a:xfrm>
-            <a:off x="4937760" y="1188720"/>
-            <a:ext cx="6858000" cy="365760"/>
+            <a:off x="4846320" y="1115568"/>
+            <a:ext cx="7040880" cy="365760"/>
           </a:xfrm>
           <a:prstGeom prst="rect">
             <a:avLst/>
@@ -7019,7 +7019,7 @@
           <a:lstStyle/>
           <a:p>
             <a:pPr algn="ctr">
-              <a:defRPr sz="1600" b="1">
+              <a:defRPr sz="1650" b="1">
                 <a:solidFill>
                   <a:srgbClr val="111827"/>
                 </a:solidFill>
@@ -7048,8 +7048,8 @@
         </p:blipFill>
         <p:spPr>
           <a:xfrm>
-            <a:off x="4846320" y="1691640"/>
-            <a:ext cx="6949440" cy="3813367"/>
+            <a:off x="4754880" y="1600200"/>
+            <a:ext cx="7132320" cy="3913718"/>
           </a:xfrm>
           <a:prstGeom prst="rect">
             <a:avLst/>
@@ -7064,8 +7064,8 @@
         </p:nvSpPr>
         <p:spPr>
           <a:xfrm>
-            <a:off x="4846320" y="4663440"/>
-            <a:ext cx="6949440" cy="1691640"/>
+            <a:off x="4754880" y="4663440"/>
+            <a:ext cx="7132320" cy="1691640"/>
           </a:xfrm>
           <a:prstGeom prst="roundRect">
             <a:avLst/>
@@ -7094,14 +7094,14 @@
           </a:fontRef>
         </p:style>
         <p:txBody>
-          <a:bodyPr rtlCol="0" anchor="ctr" wrap="square" lIns="137160" tIns="137160"/>
+          <a:bodyPr rtlCol="0" anchor="ctr" wrap="square" lIns="146304" tIns="146304"/>
           <a:lstStyle/>
           <a:p>
             <a:pPr algn="ctr">
               <a:spcAft>
                 <a:spcPts val="300"/>
               </a:spcAft>
-              <a:defRPr sz="1100" b="1">
+              <a:defRPr sz="1150" b="1">
                 <a:solidFill>
                   <a:srgbClr val="1D4ED8"/>
                 </a:solidFill>
@@ -7117,7 +7117,7 @@
               <a:spcAft>
                 <a:spcPts val="200"/>
               </a:spcAft>
-              <a:defRPr sz="950">
+              <a:defRPr sz="1019">
                 <a:solidFill>
                   <a:srgbClr val="1F2937"/>
                 </a:solidFill>
@@ -7133,7 +7133,7 @@
               <a:spcAft>
                 <a:spcPts val="200"/>
               </a:spcAft>
-              <a:defRPr sz="950">
+              <a:defRPr sz="1019">
                 <a:solidFill>
                   <a:srgbClr val="1F2937"/>
                 </a:solidFill>
@@ -7149,7 +7149,7 @@
               <a:spcAft>
                 <a:spcPts val="200"/>
               </a:spcAft>
-              <a:defRPr sz="950">
+              <a:defRPr sz="1019">
                 <a:solidFill>
                   <a:srgbClr val="1F2937"/>
                 </a:solidFill>
@@ -7165,7 +7165,7 @@
               <a:spcAft>
                 <a:spcPts val="200"/>
               </a:spcAft>
-              <a:defRPr sz="950">
+              <a:defRPr sz="1019">
                 <a:solidFill>
                   <a:srgbClr val="1F2937"/>
                 </a:solidFill>

</xml_diff>

<commit_message>
style: enhance presentation visual attractiveness, bold lead-in highlights, and title emphasis
</commit_message>
<xml_diff>
--- a/docs/SIH26053_TeraPulse_Official_Presentation.pptx
+++ b/docs/SIH26053_TeraPulse_Official_Presentation.pptx
@@ -3101,7 +3101,7 @@
         </p:nvSpPr>
         <p:spPr>
           <a:xfrm>
-            <a:off x="914400" y="274320"/>
+            <a:off x="914400" y="256032"/>
             <a:ext cx="9144000" cy="594360"/>
           </a:xfrm>
           <a:prstGeom prst="rect">
@@ -3118,7 +3118,7 @@
             <a:pPr algn="ctr">
               <a:defRPr sz="2600" b="1">
                 <a:solidFill>
-                  <a:srgbClr val="1E4082"/>
+                  <a:srgbClr val="1D4ED8"/>
                 </a:solidFill>
                 <a:latin typeface="Arial"/>
               </a:defRPr>
@@ -3137,8 +3137,8 @@
         </p:nvSpPr>
         <p:spPr>
           <a:xfrm>
-            <a:off x="731520" y="841248"/>
-            <a:ext cx="9601200" cy="1188720"/>
+            <a:off x="731520" y="804672"/>
+            <a:ext cx="9601200" cy="1234440"/>
           </a:xfrm>
           <a:prstGeom prst="rect">
             <a:avLst/>
@@ -3151,27 +3151,75 @@
           </a:bodyPr>
           <a:lstStyle/>
           <a:p>
-            <a:pPr algn="ctr">
-              <a:defRPr sz="2750" b="1">
-                <a:solidFill>
-                  <a:srgbClr val="111827"/>
-                </a:solidFill>
-                <a:latin typeface="Arial"/>
-              </a:defRPr>
-            </a:pPr>
-            <a:r>
-              <a:t>Adaptive Foveated 2.5D Semantic Mapping for</a:t>
-            </a:r>
-            <a:br/>
-            <a:r>
-              <a:t>Autonomous Navigation</a:t>
-            </a:r>
+            <a:pPr algn="ctr"/>
+            <a:r>
+              <a:rPr sz="2800" b="1">
+                <a:solidFill>
+                  <a:srgbClr val="0F172A"/>
+                </a:solidFill>
+                <a:latin typeface="Arial"/>
+              </a:rPr>
+              <a:t>Adaptive Foveated 2.5D Semantic Mapping
+</a:t>
+            </a:r>
+            <a:r>
+              <a:rPr sz="2600" b="1">
+                <a:solidFill>
+                  <a:srgbClr val="1D4ED8"/>
+                </a:solidFill>
+                <a:latin typeface="Arial"/>
+              </a:rPr>
+              <a:t>for Autonomous Navigation</a:t>
+            </a:r>
+          </a:p>
+        </p:txBody>
+      </p:sp>
+      <p:sp>
+        <p:nvSpPr>
+          <p:cNvPr id="4" name="Rectangle 3"/>
+          <p:cNvSpPr/>
+          <p:nvPr/>
+        </p:nvSpPr>
+        <p:spPr>
+          <a:xfrm>
+            <a:off x="4114800" y="2084831"/>
+            <a:ext cx="3959352" cy="45720"/>
+          </a:xfrm>
+          <a:prstGeom prst="rect">
+            <a:avLst/>
+          </a:prstGeom>
+          <a:solidFill>
+            <a:srgbClr val="0284C7"/>
+          </a:solidFill>
+          <a:ln>
+            <a:noFill/>
+          </a:ln>
+        </p:spPr>
+        <p:style>
+          <a:lnRef idx="1">
+            <a:schemeClr val="accent1"/>
+          </a:lnRef>
+          <a:fillRef idx="3">
+            <a:schemeClr val="accent1"/>
+          </a:fillRef>
+          <a:effectRef idx="2">
+            <a:schemeClr val="accent1"/>
+          </a:effectRef>
+          <a:fontRef idx="minor">
+            <a:schemeClr val="lt1"/>
+          </a:fontRef>
+        </p:style>
+        <p:txBody>
+          <a:bodyPr rtlCol="0" anchor="ctr"/>
+          <a:lstStyle/>
+          <a:p>
+            <a:pPr algn="ctr"/>
           </a:p>
         </p:txBody>
       </p:sp>
       <p:pic>
         <p:nvPicPr>
-          <p:cNvPr id="4" name="Picture 3" descr="page_1_1_Im1.png"/>
+          <p:cNvPr id="5" name="Picture 4" descr="page_1_1_Im1.png"/>
           <p:cNvPicPr>
             <a:picLocks noChangeAspect="1"/>
           </p:cNvPicPr>
@@ -3195,162 +3243,250 @@
       </p:pic>
       <p:sp>
         <p:nvSpPr>
-          <p:cNvPr id="5" name="TextBox 4"/>
-          <p:cNvSpPr txBox="1"/>
+          <p:cNvPr id="6" name="Rounded Rectangle 5"/>
+          <p:cNvSpPr/>
           <p:nvPr/>
         </p:nvSpPr>
         <p:spPr>
           <a:xfrm>
-            <a:off x="731520" y="2240280"/>
-            <a:ext cx="6766560" cy="4206240"/>
-          </a:xfrm>
-          <a:prstGeom prst="rect">
+            <a:off x="731520" y="2267712"/>
+            <a:ext cx="6583680" cy="4114800"/>
+          </a:xfrm>
+          <a:prstGeom prst="roundRect">
             <a:avLst/>
           </a:prstGeom>
-          <a:noFill/>
-        </p:spPr>
-        <p:txBody>
-          <a:bodyPr wrap="square" lIns="0" tIns="0">
-            <a:spAutoFit/>
-          </a:bodyPr>
-          <a:lstStyle/>
+          <a:solidFill>
+            <a:srgbClr val="F8FAFC"/>
+          </a:solidFill>
+          <a:ln w="19050">
+            <a:solidFill>
+              <a:srgbClr val="E2E8F0"/>
+            </a:solidFill>
+          </a:ln>
+        </p:spPr>
+        <p:style>
+          <a:lnRef idx="1">
+            <a:schemeClr val="accent1"/>
+          </a:lnRef>
+          <a:fillRef idx="3">
+            <a:schemeClr val="accent1"/>
+          </a:fillRef>
+          <a:effectRef idx="2">
+            <a:schemeClr val="accent1"/>
+          </a:effectRef>
+          <a:fontRef idx="minor">
+            <a:schemeClr val="lt1"/>
+          </a:fontRef>
+        </p:style>
+        <p:txBody>
+          <a:bodyPr rtlCol="0" anchor="ctr" wrap="square" lIns="228600" tIns="228600"/>
+          <a:lstStyle/>
+          <a:p>
+            <a:pPr algn="ctr">
+              <a:spcAft>
+                <a:spcPts val="600"/>
+              </a:spcAft>
+            </a:pPr>
+            <a:r>
+              <a:rPr sz="1300" b="1">
+                <a:solidFill>
+                  <a:srgbClr val="1D4ED8"/>
+                </a:solidFill>
+                <a:latin typeface="Arial"/>
+              </a:rPr>
+              <a:t>•  Problem Statement ID –</a:t>
+            </a:r>
+            <a:r>
+              <a:rPr sz="1300" b="0">
+                <a:solidFill>
+                  <a:srgbClr val="0F172A"/>
+                </a:solidFill>
+                <a:latin typeface="Arial"/>
+              </a:rPr>
+              <a:t> 26053</a:t>
+            </a:r>
+          </a:p>
           <a:p>
             <a:pPr>
               <a:spcAft>
-                <a:spcPts val="700"/>
+                <a:spcPts val="600"/>
               </a:spcAft>
-              <a:defRPr sz="1350">
-                <a:solidFill>
-                  <a:srgbClr val="111827"/>
-                </a:solidFill>
-                <a:latin typeface="Arial"/>
-              </a:defRPr>
-            </a:pPr>
-            <a:r>
-              <a:t>•  Problem Statement ID – 26053</a:t>
+            </a:pPr>
+            <a:r>
+              <a:rPr sz="1300" b="1">
+                <a:solidFill>
+                  <a:srgbClr val="1D4ED8"/>
+                </a:solidFill>
+                <a:latin typeface="Arial"/>
+              </a:rPr>
+              <a:t>•  Problem Statement Title –</a:t>
+            </a:r>
+            <a:r>
+              <a:rPr sz="1300" b="0">
+                <a:solidFill>
+                  <a:srgbClr val="0F172A"/>
+                </a:solidFill>
+                <a:latin typeface="Arial"/>
+              </a:rPr>
+              <a:t> Adaptive Foveated 2.5D Semantic Mapping from LiDAR Point Clouds for Autonomous Navigation</a:t>
             </a:r>
           </a:p>
           <a:p>
             <a:pPr>
               <a:spcAft>
-                <a:spcPts val="700"/>
+                <a:spcPts val="600"/>
               </a:spcAft>
-              <a:defRPr sz="1350">
-                <a:solidFill>
-                  <a:srgbClr val="111827"/>
-                </a:solidFill>
-                <a:latin typeface="Arial"/>
-              </a:defRPr>
-            </a:pPr>
-            <a:r>
-              <a:t>•  Problem Statement Title – Adaptive Foveated 2.5D Semantic Mapping from LiDAR Point Clouds for Autonomous Navigation</a:t>
+            </a:pPr>
+            <a:r>
+              <a:rPr sz="1300" b="1">
+                <a:solidFill>
+                  <a:srgbClr val="1D4ED8"/>
+                </a:solidFill>
+                <a:latin typeface="Arial"/>
+              </a:rPr>
+              <a:t>•  Theme –</a:t>
+            </a:r>
+            <a:r>
+              <a:rPr sz="1300" b="0">
+                <a:solidFill>
+                  <a:srgbClr val="0F172A"/>
+                </a:solidFill>
+                <a:latin typeface="Arial"/>
+              </a:rPr>
+              <a:t> Smart Vehicles</a:t>
             </a:r>
           </a:p>
           <a:p>
             <a:pPr>
               <a:spcAft>
-                <a:spcPts val="700"/>
+                <a:spcPts val="600"/>
               </a:spcAft>
-              <a:defRPr sz="1350">
-                <a:solidFill>
-                  <a:srgbClr val="111827"/>
-                </a:solidFill>
-                <a:latin typeface="Arial"/>
-              </a:defRPr>
-            </a:pPr>
-            <a:r>
-              <a:t>•  Theme – Smart Vehicles</a:t>
+            </a:pPr>
+            <a:r>
+              <a:rPr sz="1300" b="1">
+                <a:solidFill>
+                  <a:srgbClr val="1D4ED8"/>
+                </a:solidFill>
+                <a:latin typeface="Arial"/>
+              </a:rPr>
+              <a:t>•  PS Category –</a:t>
+            </a:r>
+            <a:r>
+              <a:rPr sz="1300" b="0">
+                <a:solidFill>
+                  <a:srgbClr val="0F172A"/>
+                </a:solidFill>
+                <a:latin typeface="Arial"/>
+              </a:rPr>
+              <a:t> Software</a:t>
             </a:r>
           </a:p>
           <a:p>
             <a:pPr>
               <a:spcAft>
-                <a:spcPts val="700"/>
+                <a:spcPts val="600"/>
               </a:spcAft>
-              <a:defRPr sz="1350">
-                <a:solidFill>
-                  <a:srgbClr val="111827"/>
-                </a:solidFill>
-                <a:latin typeface="Arial"/>
-              </a:defRPr>
-            </a:pPr>
-            <a:r>
-              <a:t>•  PS Category – Software</a:t>
+            </a:pPr>
+            <a:r>
+              <a:rPr sz="1300" b="1">
+                <a:solidFill>
+                  <a:srgbClr val="1D4ED8"/>
+                </a:solidFill>
+                <a:latin typeface="Arial"/>
+              </a:rPr>
+              <a:t>•  Team ID –</a:t>
+            </a:r>
+            <a:r>
+              <a:rPr sz="1300" b="0">
+                <a:solidFill>
+                  <a:srgbClr val="0F172A"/>
+                </a:solidFill>
+                <a:latin typeface="Arial"/>
+              </a:rPr>
+              <a:t> TBA</a:t>
             </a:r>
           </a:p>
           <a:p>
             <a:pPr>
               <a:spcAft>
-                <a:spcPts val="700"/>
+                <a:spcPts val="600"/>
               </a:spcAft>
-              <a:defRPr sz="1350">
-                <a:solidFill>
-                  <a:srgbClr val="111827"/>
-                </a:solidFill>
-                <a:latin typeface="Arial"/>
-              </a:defRPr>
-            </a:pPr>
-            <a:r>
-              <a:t>•  Team ID – TBA</a:t>
+            </a:pPr>
+            <a:r>
+              <a:rPr sz="1300" b="1">
+                <a:solidFill>
+                  <a:srgbClr val="1D4ED8"/>
+                </a:solidFill>
+                <a:latin typeface="Arial"/>
+              </a:rPr>
+              <a:t>•  Team Name –</a:t>
+            </a:r>
+            <a:r>
+              <a:rPr sz="1300" b="0">
+                <a:solidFill>
+                  <a:srgbClr val="0F172A"/>
+                </a:solidFill>
+                <a:latin typeface="Arial"/>
+              </a:rPr>
+              <a:t> TeraPulse</a:t>
             </a:r>
           </a:p>
           <a:p>
             <a:pPr>
               <a:spcAft>
-                <a:spcPts val="700"/>
+                <a:spcPts val="600"/>
               </a:spcAft>
-              <a:defRPr sz="1350">
-                <a:solidFill>
-                  <a:srgbClr val="111827"/>
-                </a:solidFill>
-                <a:latin typeface="Arial"/>
-              </a:defRPr>
-            </a:pPr>
-            <a:r>
-              <a:t>•  Team Name – TeraPulse</a:t>
+            </a:pPr>
+            <a:r>
+              <a:rPr sz="1300" b="1">
+                <a:solidFill>
+                  <a:srgbClr val="1D4ED8"/>
+                </a:solidFill>
+                <a:latin typeface="Arial"/>
+              </a:rPr>
+              <a:t>•  Team Members –</a:t>
+            </a:r>
+            <a:r>
+              <a:rPr sz="1300" b="0">
+                <a:solidFill>
+                  <a:srgbClr val="0F172A"/>
+                </a:solidFill>
+                <a:latin typeface="Arial"/>
+              </a:rPr>
+              <a:t> Abhay Verma (Team Leader), Lokendra Singh,
+Yashvardhan Jain, Chetan Meena, Sachin Chaubey, Esha Verma</a:t>
             </a:r>
           </a:p>
           <a:p>
             <a:pPr>
               <a:spcAft>
-                <a:spcPts val="700"/>
+                <a:spcPts val="600"/>
               </a:spcAft>
-              <a:defRPr sz="1350">
-                <a:solidFill>
-                  <a:srgbClr val="111827"/>
-                </a:solidFill>
-                <a:latin typeface="Arial"/>
-              </a:defRPr>
-            </a:pPr>
-            <a:r>
-              <a:t>•  Team Members – Abhay Verma (Team Leader), Lokendra Singh,</a:t>
-            </a:r>
-            <a:br/>
-            <a:r>
-              <a:t>Yashvardhan Jain, Chetan Meena, Sachin Chaubey, Esha Verma</a:t>
-            </a:r>
-          </a:p>
-          <a:p>
-            <a:pPr>
-              <a:spcAft>
-                <a:spcPts val="700"/>
-              </a:spcAft>
-              <a:defRPr sz="1350">
-                <a:solidFill>
-                  <a:srgbClr val="111827"/>
-                </a:solidFill>
-                <a:latin typeface="Arial"/>
-              </a:defRPr>
-            </a:pPr>
-            <a:r>
-              <a:t>•  Institute – Indian Institute of Information Technology Bhopal</a:t>
+            </a:pPr>
+            <a:r>
+              <a:rPr sz="1300" b="1">
+                <a:solidFill>
+                  <a:srgbClr val="1D4ED8"/>
+                </a:solidFill>
+                <a:latin typeface="Arial"/>
+              </a:rPr>
+              <a:t>•  Institute –</a:t>
+            </a:r>
+            <a:r>
+              <a:rPr sz="1300" b="0">
+                <a:solidFill>
+                  <a:srgbClr val="0F172A"/>
+                </a:solidFill>
+                <a:latin typeface="Arial"/>
+              </a:rPr>
+              <a:t> Indian Institute of Information Technology Bhopal</a:t>
             </a:r>
           </a:p>
         </p:txBody>
       </p:sp>
       <p:pic>
         <p:nvPicPr>
-          <p:cNvPr id="6" name="Picture 5" descr="page_1_0_Im0.png"/>
+          <p:cNvPr id="7" name="Picture 6" descr="page_1_0_Im0.png"/>
           <p:cNvPicPr>
             <a:picLocks noChangeAspect="1"/>
           </p:cNvPicPr>
@@ -3364,8 +3500,8 @@
         </p:blipFill>
         <p:spPr>
           <a:xfrm>
-            <a:off x="7040880" y="2011680"/>
-            <a:ext cx="4663440" cy="4987211"/>
+            <a:off x="7498079" y="2148840"/>
+            <a:ext cx="4389120" cy="4693846"/>
           </a:xfrm>
           <a:prstGeom prst="rect">
             <a:avLst/>
@@ -3398,7 +3534,7 @@
         </p:nvSpPr>
         <p:spPr>
           <a:xfrm>
-            <a:off x="457200" y="201168"/>
+            <a:off x="457200" y="182880"/>
             <a:ext cx="1280160" cy="822960"/>
           </a:xfrm>
           <a:prstGeom prst="ellipse">
@@ -3407,9 +3543,9 @@
           <a:solidFill>
             <a:srgbClr val="FFFFFF"/>
           </a:solidFill>
-          <a:ln w="19050">
+          <a:ln w="25400">
             <a:solidFill>
-              <a:srgbClr val="111827"/>
+              <a:srgbClr val="1D4ED8"/>
             </a:solidFill>
           </a:ln>
         </p:spPr>
@@ -3434,7 +3570,7 @@
             <a:pPr algn="ctr">
               <a:defRPr sz="1200" b="1">
                 <a:solidFill>
-                  <a:srgbClr val="111827"/>
+                  <a:srgbClr val="1D4ED8"/>
                 </a:solidFill>
                 <a:latin typeface="Arial"/>
               </a:defRPr>
@@ -3457,7 +3593,7 @@
         </p:nvSpPr>
         <p:spPr>
           <a:xfrm>
-            <a:off x="1920240" y="201168"/>
+            <a:off x="1920240" y="182880"/>
             <a:ext cx="8046720" cy="822960"/>
           </a:xfrm>
           <a:prstGeom prst="rect">
@@ -3472,9 +3608,9 @@
           <a:lstStyle/>
           <a:p>
             <a:pPr algn="ctr">
-              <a:defRPr sz="2150" b="1">
-                <a:solidFill>
-                  <a:srgbClr val="111827"/>
+              <a:defRPr sz="2200" b="1">
+                <a:solidFill>
+                  <a:srgbClr val="0F172A"/>
                 </a:solidFill>
                 <a:latin typeface="Arial"/>
               </a:defRPr>
@@ -3553,7 +3689,7 @@
           <a:lstStyle/>
           <a:p>
             <a:pPr algn="ctr">
-              <a:defRPr sz="1050">
+              <a:defRPr sz="1050" b="1">
                 <a:solidFill>
                   <a:srgbClr val="FFFFFF"/>
                 </a:solidFill>
@@ -3568,27 +3704,49 @@
       </p:sp>
       <p:sp>
         <p:nvSpPr>
-          <p:cNvPr id="6" name="TextBox 5"/>
-          <p:cNvSpPr txBox="1"/>
+          <p:cNvPr id="6" name="Rounded Rectangle 5"/>
+          <p:cNvSpPr/>
           <p:nvPr/>
         </p:nvSpPr>
         <p:spPr>
           <a:xfrm>
-            <a:off x="548640" y="1143000"/>
-            <a:ext cx="5852160" cy="457200"/>
-          </a:xfrm>
-          <a:prstGeom prst="rect">
+            <a:off x="548640" y="1097280"/>
+            <a:ext cx="5943600" cy="3931920"/>
+          </a:xfrm>
+          <a:prstGeom prst="roundRect">
             <a:avLst/>
           </a:prstGeom>
-          <a:noFill/>
-        </p:spPr>
-        <p:txBody>
-          <a:bodyPr wrap="none">
-            <a:spAutoFit/>
-          </a:bodyPr>
-          <a:lstStyle/>
-          <a:p>
-            <a:pPr>
+          <a:solidFill>
+            <a:srgbClr val="F8FAFC"/>
+          </a:solidFill>
+          <a:ln w="19050">
+            <a:solidFill>
+              <a:srgbClr val="E2E8F0"/>
+            </a:solidFill>
+          </a:ln>
+        </p:spPr>
+        <p:style>
+          <a:lnRef idx="1">
+            <a:schemeClr val="accent1"/>
+          </a:lnRef>
+          <a:fillRef idx="3">
+            <a:schemeClr val="accent1"/>
+          </a:fillRef>
+          <a:effectRef idx="2">
+            <a:schemeClr val="accent1"/>
+          </a:effectRef>
+          <a:fontRef idx="minor">
+            <a:schemeClr val="lt1"/>
+          </a:fontRef>
+        </p:style>
+        <p:txBody>
+          <a:bodyPr rtlCol="0" anchor="ctr" wrap="square" lIns="228600" tIns="228600"/>
+          <a:lstStyle/>
+          <a:p>
+            <a:pPr algn="ctr">
+              <a:spcAft>
+                <a:spcPts val="600"/>
+              </a:spcAft>
               <a:defRPr sz="1800" b="1">
                 <a:solidFill>
                   <a:srgbClr val="1D4ED8"/>
@@ -3600,43 +3758,29 @@
               <a:t>❖ Proposed Solution</a:t>
             </a:r>
           </a:p>
-        </p:txBody>
-      </p:sp>
-      <p:sp>
-        <p:nvSpPr>
-          <p:cNvPr id="7" name="TextBox 6"/>
-          <p:cNvSpPr txBox="1"/>
-          <p:nvPr/>
-        </p:nvSpPr>
-        <p:spPr>
-          <a:xfrm>
-            <a:off x="548640" y="1600200"/>
-            <a:ext cx="5852160" cy="2468880"/>
-          </a:xfrm>
-          <a:prstGeom prst="rect">
-            <a:avLst/>
-          </a:prstGeom>
-          <a:noFill/>
-        </p:spPr>
-        <p:txBody>
-          <a:bodyPr wrap="square" lIns="0" tIns="0">
-            <a:spAutoFit/>
-          </a:bodyPr>
-          <a:lstStyle/>
           <a:p>
             <a:pPr>
               <a:spcAft>
                 <a:spcPts val="400"/>
               </a:spcAft>
-              <a:defRPr sz="1250">
-                <a:solidFill>
-                  <a:srgbClr val="1F2937"/>
-                </a:solidFill>
-                <a:latin typeface="Arial"/>
-              </a:defRPr>
-            </a:pPr>
-            <a:r>
-              <a:t>2.5D semantic elevation map generated from raw LiDAR point clouds.</a:t>
+            </a:pPr>
+            <a:r>
+              <a:rPr sz="1150" b="1">
+                <a:solidFill>
+                  <a:srgbClr val="1D4ED8"/>
+                </a:solidFill>
+                <a:latin typeface="Arial"/>
+              </a:rPr>
+              <a:t>• 2.5D Semantic Elevation Map: </a:t>
+            </a:r>
+            <a:r>
+              <a:rPr sz="1150">
+                <a:solidFill>
+                  <a:srgbClr val="1E293B"/>
+                </a:solidFill>
+                <a:latin typeface="Arial"/>
+              </a:rPr>
+              <a:t>Generates an efficient multi-resolution heightmap from raw 3D LiDAR point clouds.</a:t>
             </a:r>
           </a:p>
           <a:p>
@@ -3644,15 +3788,24 @@
               <a:spcAft>
                 <a:spcPts val="400"/>
               </a:spcAft>
-              <a:defRPr sz="1250">
-                <a:solidFill>
-                  <a:srgbClr val="1F2937"/>
-                </a:solidFill>
-                <a:latin typeface="Arial"/>
-              </a:defRPr>
-            </a:pPr>
-            <a:r>
-              <a:t>High resolution near the vehicle (0.25 m) for critical near-field perception.</a:t>
+            </a:pPr>
+            <a:r>
+              <a:rPr sz="1150" b="1">
+                <a:solidFill>
+                  <a:srgbClr val="1D4ED8"/>
+                </a:solidFill>
+                <a:latin typeface="Arial"/>
+              </a:rPr>
+              <a:t>• High-Precision Near Field (0–10 m): </a:t>
+            </a:r>
+            <a:r>
+              <a:rPr sz="1150">
+                <a:solidFill>
+                  <a:srgbClr val="1E293B"/>
+                </a:solidFill>
+                <a:latin typeface="Arial"/>
+              </a:rPr>
+              <a:t>Fine 0.25 m cells for sub-meter obstacle clearance, terrain slope, and reactive steering.</a:t>
             </a:r>
           </a:p>
           <a:p>
@@ -3660,15 +3813,24 @@
               <a:spcAft>
                 <a:spcPts val="400"/>
               </a:spcAft>
-              <a:defRPr sz="1250">
-                <a:solidFill>
-                  <a:srgbClr val="1F2937"/>
-                </a:solidFill>
-                <a:latin typeface="Arial"/>
-              </a:defRPr>
-            </a:pPr>
-            <a:r>
-              <a:t>Lower resolution for distant regions (0.75 m &amp; 2.0 m) — cuts unnecessary computation.</a:t>
+            </a:pPr>
+            <a:r>
+              <a:rPr sz="1150" b="1">
+                <a:solidFill>
+                  <a:srgbClr val="1D4ED8"/>
+                </a:solidFill>
+                <a:latin typeface="Arial"/>
+              </a:rPr>
+              <a:t>• Bandwidth-Saving Far Field: </a:t>
+            </a:r>
+            <a:r>
+              <a:rPr sz="1150">
+                <a:solidFill>
+                  <a:srgbClr val="1E293B"/>
+                </a:solidFill>
+                <a:latin typeface="Arial"/>
+              </a:rPr>
+              <a:t>Gradually reduces to 0.75 m &amp; 2.0 m resolution to slash unnecessary distant computations.</a:t>
             </a:r>
           </a:p>
           <a:p>
@@ -3676,15 +3838,24 @@
               <a:spcAft>
                 <a:spcPts val="400"/>
               </a:spcAft>
-              <a:defRPr sz="1250">
-                <a:solidFill>
-                  <a:srgbClr val="1F2937"/>
-                </a:solidFill>
-                <a:latin typeface="Arial"/>
-              </a:defRPr>
-            </a:pPr>
-            <a:r>
-              <a:t>Preserves height, terrain gradient &amp; obstacle boundaries without full 3D voxels.</a:t>
+            </a:pPr>
+            <a:r>
+              <a:rPr sz="1150" b="1">
+                <a:solidFill>
+                  <a:srgbClr val="1D4ED8"/>
+                </a:solidFill>
+                <a:latin typeface="Arial"/>
+              </a:rPr>
+              <a:t>• Full Elevation Profiling: </a:t>
+            </a:r>
+            <a:r>
+              <a:rPr sz="1150">
+                <a:solidFill>
+                  <a:srgbClr val="1E293B"/>
+                </a:solidFill>
+                <a:latin typeface="Arial"/>
+              </a:rPr>
+              <a:t>Preserves height, step slope &amp; obstacle boundaries without full 3D voxel memory overload.</a:t>
             </a:r>
           </a:p>
           <a:p>
@@ -3692,15 +3863,24 @@
               <a:spcAft>
                 <a:spcPts val="400"/>
               </a:spcAft>
-              <a:defRPr sz="1250">
-                <a:solidFill>
-                  <a:srgbClr val="1F2937"/>
-                </a:solidFill>
-                <a:latin typeface="Arial"/>
-              </a:defRPr>
-            </a:pPr>
-            <a:r>
-              <a:t>Identifies drivable ground, static obstacles &amp; dynamic objects in real time.</a:t>
+            </a:pPr>
+            <a:r>
+              <a:rPr sz="1150" b="1">
+                <a:solidFill>
+                  <a:srgbClr val="1D4ED8"/>
+                </a:solidFill>
+                <a:latin typeface="Arial"/>
+              </a:rPr>
+              <a:t>• Real-Time Terrain Intelligence: </a:t>
+            </a:r>
+            <a:r>
+              <a:rPr sz="1150">
+                <a:solidFill>
+                  <a:srgbClr val="1E293B"/>
+                </a:solidFill>
+                <a:latin typeface="Arial"/>
+              </a:rPr>
+              <a:t>Accurately classifies drivable ground, static obstacles, and dynamic moving objects.</a:t>
             </a:r>
           </a:p>
           <a:p>
@@ -3708,43 +3888,74 @@
               <a:spcAft>
                 <a:spcPts val="400"/>
               </a:spcAft>
-              <a:defRPr sz="1250">
-                <a:solidFill>
-                  <a:srgbClr val="1F2937"/>
-                </a:solidFill>
-                <a:latin typeface="Arial"/>
-              </a:defRPr>
-            </a:pPr>
-            <a:r>
-              <a:t>Enables fast closed-loop environmental understanding for path planning.</a:t>
-            </a:r>
-          </a:p>
-        </p:txBody>
-      </p:sp>
-      <p:sp>
-        <p:nvSpPr>
-          <p:cNvPr id="8" name="TextBox 7"/>
-          <p:cNvSpPr txBox="1"/>
+            </a:pPr>
+            <a:r>
+              <a:rPr sz="1150" b="1">
+                <a:solidFill>
+                  <a:srgbClr val="1D4ED8"/>
+                </a:solidFill>
+                <a:latin typeface="Arial"/>
+              </a:rPr>
+              <a:t>• Autonomous Navigation Stack: </a:t>
+            </a:r>
+            <a:r>
+              <a:rPr sz="1150">
+                <a:solidFill>
+                  <a:srgbClr val="1E293B"/>
+                </a:solidFill>
+                <a:latin typeface="Arial"/>
+              </a:rPr>
+              <a:t>Enables instant A* heuristic path planning and smooth Pure Pursuit vehicle steering.</a:t>
+            </a:r>
+          </a:p>
+        </p:txBody>
+      </p:sp>
+      <p:sp>
+        <p:nvSpPr>
+          <p:cNvPr id="7" name="Rounded Rectangle 6"/>
+          <p:cNvSpPr/>
           <p:nvPr/>
         </p:nvSpPr>
         <p:spPr>
           <a:xfrm>
-            <a:off x="548640" y="4160520"/>
-            <a:ext cx="5852160" cy="411480"/>
-          </a:xfrm>
-          <a:prstGeom prst="rect">
+            <a:off x="548640" y="5120640"/>
+            <a:ext cx="5943600" cy="1234440"/>
+          </a:xfrm>
+          <a:prstGeom prst="roundRect">
             <a:avLst/>
           </a:prstGeom>
-          <a:noFill/>
-        </p:spPr>
-        <p:txBody>
-          <a:bodyPr wrap="none">
-            <a:spAutoFit/>
-          </a:bodyPr>
-          <a:lstStyle/>
-          <a:p>
-            <a:pPr>
-              <a:defRPr sz="1800" b="1">
+          <a:solidFill>
+            <a:srgbClr val="EFF6FF"/>
+          </a:solidFill>
+          <a:ln w="19050">
+            <a:solidFill>
+              <a:srgbClr val="1D4ED8"/>
+            </a:solidFill>
+          </a:ln>
+        </p:spPr>
+        <p:style>
+          <a:lnRef idx="1">
+            <a:schemeClr val="accent1"/>
+          </a:lnRef>
+          <a:fillRef idx="3">
+            <a:schemeClr val="accent1"/>
+          </a:fillRef>
+          <a:effectRef idx="2">
+            <a:schemeClr val="accent1"/>
+          </a:effectRef>
+          <a:fontRef idx="minor">
+            <a:schemeClr val="lt1"/>
+          </a:fontRef>
+        </p:style>
+        <p:txBody>
+          <a:bodyPr rtlCol="0" anchor="ctr" wrap="square" lIns="164592" tIns="164592"/>
+          <a:lstStyle/>
+          <a:p>
+            <a:pPr algn="ctr">
+              <a:spcAft>
+                <a:spcPts val="400"/>
+              </a:spcAft>
+              <a:defRPr sz="1500" b="1">
                 <a:solidFill>
                   <a:srgbClr val="1D4ED8"/>
                 </a:solidFill>
@@ -3755,70 +3966,60 @@
               <a:t>❖ Innovation &amp; Uniqueness</a:t>
             </a:r>
           </a:p>
-        </p:txBody>
-      </p:sp>
-      <p:sp>
-        <p:nvSpPr>
-          <p:cNvPr id="9" name="TextBox 8"/>
-          <p:cNvSpPr txBox="1"/>
-          <p:nvPr/>
-        </p:nvSpPr>
-        <p:spPr>
-          <a:xfrm>
-            <a:off x="548640" y="4617720"/>
-            <a:ext cx="5852160" cy="1737360"/>
-          </a:xfrm>
-          <a:prstGeom prst="rect">
-            <a:avLst/>
-          </a:prstGeom>
-          <a:noFill/>
-        </p:spPr>
-        <p:txBody>
-          <a:bodyPr wrap="square" lIns="0" tIns="0">
-            <a:spAutoFit/>
-          </a:bodyPr>
-          <a:lstStyle/>
-          <a:p>
-            <a:pPr>
-              <a:spcAft>
-                <a:spcPts val="600"/>
-              </a:spcAft>
-              <a:defRPr sz="1250" i="1">
-                <a:solidFill>
-                  <a:srgbClr val="1F2937"/>
-                </a:solidFill>
-                <a:latin typeface="Arial"/>
-              </a:defRPr>
-            </a:pPr>
-            <a:r>
-              <a:t>Foveated adaptive resolution focuses computational resources where they matter most, instead of processing the entire environment at the same resolution.</a:t>
-            </a:r>
-          </a:p>
-          <a:p>
-            <a:pPr>
-              <a:defRPr sz="1250">
-                <a:solidFill>
-                  <a:srgbClr val="1F2937"/>
-                </a:solidFill>
-                <a:latin typeface="Arial"/>
-              </a:defRPr>
-            </a:pPr>
-            <a:r>
-              <a:t>• Slashing cell memory by 66.2% and processing time to 24.23 ms (&gt;35 FPS).</a:t>
-            </a:r>
-          </a:p>
-        </p:txBody>
-      </p:sp>
-      <p:sp>
-        <p:nvSpPr>
-          <p:cNvPr id="10" name="Oval 9"/>
+          <a:p>
+            <a:r>
+              <a:rPr b="1">
+                <a:solidFill>
+                  <a:srgbClr val="0F172A"/>
+                </a:solidFill>
+              </a:rPr>
+              <a:t>Foveated adaptive resolution </a:t>
+            </a:r>
+            <a:r>
+              <a:rPr>
+                <a:solidFill>
+                  <a:srgbClr val="1E293B"/>
+                </a:solidFill>
+              </a:rPr>
+              <a:t>focuses computational resources where they matter most — slashing memory by </a:t>
+            </a:r>
+            <a:r>
+              <a:rPr b="1">
+                <a:solidFill>
+                  <a:srgbClr val="047857"/>
+                </a:solidFill>
+              </a:rPr>
+              <a:t>66.2% </a:t>
+            </a:r>
+            <a:r>
+              <a:rPr>
+                <a:solidFill>
+                  <a:srgbClr val="1E293B"/>
+                </a:solidFill>
+              </a:rPr>
+              <a:t>and cutting latency to </a:t>
+            </a:r>
+            <a:r>
+              <a:rPr b="1">
+                <a:solidFill>
+                  <a:srgbClr val="1D4ED8"/>
+                </a:solidFill>
+              </a:rPr>
+              <a:t>24.23 ms (&gt;35 FPS).</a:t>
+            </a:r>
+          </a:p>
+        </p:txBody>
+      </p:sp>
+      <p:sp>
+        <p:nvSpPr>
+          <p:cNvPr id="8" name="Oval 7"/>
           <p:cNvSpPr/>
           <p:nvPr/>
         </p:nvSpPr>
         <p:spPr>
           <a:xfrm>
-            <a:off x="6766560" y="1600200"/>
-            <a:ext cx="4663440" cy="4663440"/>
+            <a:off x="6858000" y="1508760"/>
+            <a:ext cx="4754880" cy="4754880"/>
           </a:xfrm>
           <a:prstGeom prst="ellipse">
             <a:avLst/>
@@ -3856,13 +4057,13 @@
       </p:sp>
       <p:sp>
         <p:nvSpPr>
-          <p:cNvPr id="11" name="Oval 10"/>
+          <p:cNvPr id="9" name="Oval 8"/>
           <p:cNvSpPr/>
           <p:nvPr/>
         </p:nvSpPr>
         <p:spPr>
           <a:xfrm>
-            <a:off x="7955279" y="2788920"/>
+            <a:off x="8092440" y="2743200"/>
             <a:ext cx="2286000" cy="2286000"/>
           </a:xfrm>
           <a:prstGeom prst="ellipse">
@@ -3901,13 +4102,13 @@
       </p:sp>
       <p:sp>
         <p:nvSpPr>
-          <p:cNvPr id="12" name="Oval 11"/>
+          <p:cNvPr id="10" name="Oval 9"/>
           <p:cNvSpPr/>
           <p:nvPr/>
         </p:nvSpPr>
         <p:spPr>
           <a:xfrm>
-            <a:off x="8869680" y="3703320"/>
+            <a:off x="9006840" y="3657600"/>
             <a:ext cx="475488" cy="475488"/>
           </a:xfrm>
           <a:prstGeom prst="ellipse">
@@ -3944,13 +4145,13 @@
       </p:sp>
       <p:sp>
         <p:nvSpPr>
-          <p:cNvPr id="13" name="TextBox 12"/>
+          <p:cNvPr id="11" name="TextBox 10"/>
           <p:cNvSpPr txBox="1"/>
           <p:nvPr/>
         </p:nvSpPr>
         <p:spPr>
           <a:xfrm>
-            <a:off x="6583680" y="1143000"/>
+            <a:off x="6675120" y="1051560"/>
             <a:ext cx="5029200" cy="411480"/>
           </a:xfrm>
           <a:prstGeom prst="rect">
@@ -3965,9 +4166,9 @@
           <a:lstStyle/>
           <a:p>
             <a:pPr algn="ctr">
-              <a:defRPr sz="1550" b="1">
-                <a:solidFill>
-                  <a:srgbClr val="111827"/>
+              <a:defRPr sz="1600" b="1">
+                <a:solidFill>
+                  <a:srgbClr val="0F172A"/>
                 </a:solidFill>
                 <a:latin typeface="Arial"/>
               </a:defRPr>
@@ -3980,7 +4181,7 @@
       </p:sp>
       <p:sp>
         <p:nvSpPr>
-          <p:cNvPr id="14" name="Rectangle 13"/>
+          <p:cNvPr id="12" name="Rectangle 11"/>
           <p:cNvSpPr/>
           <p:nvPr/>
         </p:nvSpPr>
@@ -4023,7 +4224,7 @@
       </p:sp>
       <p:sp>
         <p:nvSpPr>
-          <p:cNvPr id="15" name="TextBox 14"/>
+          <p:cNvPr id="13" name="TextBox 12"/>
           <p:cNvSpPr txBox="1"/>
           <p:nvPr/>
         </p:nvSpPr>
@@ -4043,22 +4244,28 @@
           </a:bodyPr>
           <a:lstStyle/>
           <a:p>
-            <a:pPr>
-              <a:defRPr sz="1050">
-                <a:solidFill>
-                  <a:srgbClr val="1F2937"/>
-                </a:solidFill>
-              </a:defRPr>
-            </a:pPr>
-            <a:r>
-              <a:t>High resolution near the vehicle (near-field: 0.25 m)</a:t>
-            </a:r>
-          </a:p>
-        </p:txBody>
-      </p:sp>
-      <p:sp>
-        <p:nvSpPr>
-          <p:cNvPr id="16" name="Rectangle 15"/>
+            <a:r>
+              <a:rPr b="1" sz="1050">
+                <a:solidFill>
+                  <a:srgbClr val="1D4ED8"/>
+                </a:solidFill>
+              </a:rPr>
+              <a:t>High resolution near vehicle </a:t>
+            </a:r>
+            <a:r>
+              <a:rPr sz="1050">
+                <a:solidFill>
+                  <a:srgbClr val="1E293B"/>
+                </a:solidFill>
+              </a:rPr>
+              <a:t>(near-field: 0.25 m bubble)</a:t>
+            </a:r>
+          </a:p>
+        </p:txBody>
+      </p:sp>
+      <p:sp>
+        <p:nvSpPr>
+          <p:cNvPr id="14" name="Rectangle 13"/>
           <p:cNvSpPr/>
           <p:nvPr/>
         </p:nvSpPr>
@@ -4101,7 +4308,7 @@
       </p:sp>
       <p:sp>
         <p:nvSpPr>
-          <p:cNvPr id="17" name="TextBox 16"/>
+          <p:cNvPr id="15" name="TextBox 14"/>
           <p:cNvSpPr txBox="1"/>
           <p:nvPr/>
         </p:nvSpPr>
@@ -4121,15 +4328,21 @@
           </a:bodyPr>
           <a:lstStyle/>
           <a:p>
-            <a:pPr>
-              <a:defRPr sz="1050">
-                <a:solidFill>
-                  <a:srgbClr val="1F2937"/>
-                </a:solidFill>
-              </a:defRPr>
-            </a:pPr>
-            <a:r>
-              <a:t>Lower resolution for distant regions (far-field: 0.75m &amp; 2.0m)</a:t>
+            <a:r>
+              <a:rPr b="1" sz="1050">
+                <a:solidFill>
+                  <a:srgbClr val="0F172A"/>
+                </a:solidFill>
+              </a:rPr>
+              <a:t>Lower resolution for distant regions </a:t>
+            </a:r>
+            <a:r>
+              <a:rPr sz="1050">
+                <a:solidFill>
+                  <a:srgbClr val="1E293B"/>
+                </a:solidFill>
+              </a:rPr>
+              <a:t>(far-field: 0.75m &amp; 2.0m)</a:t>
             </a:r>
           </a:p>
         </p:txBody>
@@ -4160,7 +4373,7 @@
         </p:nvSpPr>
         <p:spPr>
           <a:xfrm>
-            <a:off x="457200" y="201168"/>
+            <a:off x="457200" y="182880"/>
             <a:ext cx="1280160" cy="822960"/>
           </a:xfrm>
           <a:prstGeom prst="ellipse">
@@ -4169,9 +4382,9 @@
           <a:solidFill>
             <a:srgbClr val="FFFFFF"/>
           </a:solidFill>
-          <a:ln w="19050">
+          <a:ln w="25400">
             <a:solidFill>
-              <a:srgbClr val="111827"/>
+              <a:srgbClr val="1D4ED8"/>
             </a:solidFill>
           </a:ln>
         </p:spPr>
@@ -4196,7 +4409,7 @@
             <a:pPr algn="ctr">
               <a:defRPr sz="1200" b="1">
                 <a:solidFill>
-                  <a:srgbClr val="111827"/>
+                  <a:srgbClr val="1D4ED8"/>
                 </a:solidFill>
                 <a:latin typeface="Arial"/>
               </a:defRPr>
@@ -4219,7 +4432,7 @@
         </p:nvSpPr>
         <p:spPr>
           <a:xfrm>
-            <a:off x="1920240" y="201168"/>
+            <a:off x="1920240" y="182880"/>
             <a:ext cx="8046720" cy="822960"/>
           </a:xfrm>
           <a:prstGeom prst="rect">
@@ -4234,9 +4447,9 @@
           <a:lstStyle/>
           <a:p>
             <a:pPr algn="ctr">
-              <a:defRPr sz="2150" b="1">
-                <a:solidFill>
-                  <a:srgbClr val="111827"/>
+              <a:defRPr sz="2200" b="1">
+                <a:solidFill>
+                  <a:srgbClr val="0F172A"/>
                 </a:solidFill>
                 <a:latin typeface="Arial"/>
               </a:defRPr>
@@ -4311,7 +4524,7 @@
           <a:lstStyle/>
           <a:p>
             <a:pPr algn="ctr">
-              <a:defRPr sz="1050">
+              <a:defRPr sz="1050" b="1">
                 <a:solidFill>
                   <a:srgbClr val="FFFFFF"/>
                 </a:solidFill>
@@ -4332,7 +4545,7 @@
         </p:nvSpPr>
         <p:spPr>
           <a:xfrm>
-            <a:off x="548640" y="1143000"/>
+            <a:off x="548640" y="1115568"/>
             <a:ext cx="4389120" cy="411480"/>
           </a:xfrm>
           <a:prstGeom prst="rect">
@@ -4355,7 +4568,7 @@
               </a:defRPr>
             </a:pPr>
             <a:r>
-              <a:t>System Workflow</a:t>
+              <a:t>⚙️ System Workflow Pipeline</a:t>
             </a:r>
           </a:p>
         </p:txBody>
@@ -4368,17 +4581,19 @@
         </p:nvSpPr>
         <p:spPr>
           <a:xfrm>
-            <a:off x="548640" y="1645920"/>
+            <a:off x="548640" y="1627632"/>
             <a:ext cx="4206240" cy="530352"/>
           </a:xfrm>
           <a:prstGeom prst="roundRect">
             <a:avLst/>
           </a:prstGeom>
           <a:solidFill>
-            <a:srgbClr val="146EC8"/>
+            <a:srgbClr val="1D4ED8"/>
           </a:solidFill>
-          <a:ln>
-            <a:noFill/>
+          <a:ln w="12700">
+            <a:solidFill>
+              <a:srgbClr val="FFFFFF"/>
+            </a:solidFill>
           </a:ln>
         </p:spPr>
         <p:style>
@@ -4400,7 +4615,7 @@
           <a:lstStyle/>
           <a:p>
             <a:pPr algn="ctr">
-              <a:defRPr sz="1150" b="1">
+              <a:defRPr sz="1200" b="1">
                 <a:solidFill>
                   <a:srgbClr val="FFFFFF"/>
                 </a:solidFill>
@@ -4408,7 +4623,7 @@
               </a:defRPr>
             </a:pPr>
             <a:r>
-              <a:t>LiDAR Point Cloud</a:t>
+              <a:t>[1]  LiDAR Point Cloud Ingestion</a:t>
             </a:r>
           </a:p>
         </p:txBody>
@@ -4421,14 +4636,14 @@
         </p:nvSpPr>
         <p:spPr>
           <a:xfrm>
-            <a:off x="2514600" y="2203704"/>
+            <a:off x="2514600" y="2185416"/>
             <a:ext cx="274320" cy="182880"/>
           </a:xfrm>
           <a:prstGeom prst="downArrow">
             <a:avLst/>
           </a:prstGeom>
           <a:solidFill>
-            <a:srgbClr val="6496D2"/>
+            <a:srgbClr val="0284C7"/>
           </a:solidFill>
           <a:ln>
             <a:noFill/>
@@ -4464,17 +4679,19 @@
         </p:nvSpPr>
         <p:spPr>
           <a:xfrm>
-            <a:off x="548640" y="2441448"/>
+            <a:off x="548640" y="2423160"/>
             <a:ext cx="4206240" cy="530352"/>
           </a:xfrm>
           <a:prstGeom prst="roundRect">
             <a:avLst/>
           </a:prstGeom>
           <a:solidFill>
-            <a:srgbClr val="146EC8"/>
+            <a:srgbClr val="1D4ED8"/>
           </a:solidFill>
-          <a:ln>
-            <a:noFill/>
+          <a:ln w="12700">
+            <a:solidFill>
+              <a:srgbClr val="FFFFFF"/>
+            </a:solidFill>
           </a:ln>
         </p:spPr>
         <p:style>
@@ -4496,7 +4713,7 @@
           <a:lstStyle/>
           <a:p>
             <a:pPr algn="ctr">
-              <a:defRPr sz="1150" b="1">
+              <a:defRPr sz="1200" b="1">
                 <a:solidFill>
                   <a:srgbClr val="FFFFFF"/>
                 </a:solidFill>
@@ -4504,7 +4721,7 @@
               </a:defRPr>
             </a:pPr>
             <a:r>
-              <a:t>Preprocessing &amp; Noise Removal</a:t>
+              <a:t>[2]  Preprocessing &amp; Noise Removal</a:t>
             </a:r>
           </a:p>
         </p:txBody>
@@ -4517,14 +4734,14 @@
         </p:nvSpPr>
         <p:spPr>
           <a:xfrm>
-            <a:off x="2514600" y="2999232"/>
+            <a:off x="2514600" y="2980944"/>
             <a:ext cx="274320" cy="182880"/>
           </a:xfrm>
           <a:prstGeom prst="downArrow">
             <a:avLst/>
           </a:prstGeom>
           <a:solidFill>
-            <a:srgbClr val="6496D2"/>
+            <a:srgbClr val="0284C7"/>
           </a:solidFill>
           <a:ln>
             <a:noFill/>
@@ -4560,17 +4777,19 @@
         </p:nvSpPr>
         <p:spPr>
           <a:xfrm>
-            <a:off x="548640" y="3236976"/>
+            <a:off x="548640" y="3218687"/>
             <a:ext cx="4206240" cy="530352"/>
           </a:xfrm>
           <a:prstGeom prst="roundRect">
             <a:avLst/>
           </a:prstGeom>
           <a:solidFill>
-            <a:srgbClr val="146EC8"/>
+            <a:srgbClr val="1D4ED8"/>
           </a:solidFill>
-          <a:ln>
-            <a:noFill/>
+          <a:ln w="12700">
+            <a:solidFill>
+              <a:srgbClr val="FFFFFF"/>
+            </a:solidFill>
           </a:ln>
         </p:spPr>
         <p:style>
@@ -4592,7 +4811,7 @@
           <a:lstStyle/>
           <a:p>
             <a:pPr algn="ctr">
-              <a:defRPr sz="1150" b="1">
+              <a:defRPr sz="1200" b="1">
                 <a:solidFill>
                   <a:srgbClr val="FFFFFF"/>
                 </a:solidFill>
@@ -4600,7 +4819,7 @@
               </a:defRPr>
             </a:pPr>
             <a:r>
-              <a:t>Semantic Understanding</a:t>
+              <a:t>[3]  Deep Semantic Classification</a:t>
             </a:r>
           </a:p>
         </p:txBody>
@@ -4613,14 +4832,14 @@
         </p:nvSpPr>
         <p:spPr>
           <a:xfrm>
-            <a:off x="2514600" y="3794760"/>
+            <a:off x="2514600" y="3776472"/>
             <a:ext cx="274320" cy="182880"/>
           </a:xfrm>
           <a:prstGeom prst="downArrow">
             <a:avLst/>
           </a:prstGeom>
           <a:solidFill>
-            <a:srgbClr val="6496D2"/>
+            <a:srgbClr val="0284C7"/>
           </a:solidFill>
           <a:ln>
             <a:noFill/>
@@ -4656,17 +4875,19 @@
         </p:nvSpPr>
         <p:spPr>
           <a:xfrm>
-            <a:off x="548640" y="4032504"/>
+            <a:off x="548640" y="4014215"/>
             <a:ext cx="4206240" cy="530352"/>
           </a:xfrm>
           <a:prstGeom prst="roundRect">
             <a:avLst/>
           </a:prstGeom>
           <a:solidFill>
-            <a:srgbClr val="146EC8"/>
+            <a:srgbClr val="1D4ED8"/>
           </a:solidFill>
-          <a:ln>
-            <a:noFill/>
+          <a:ln w="12700">
+            <a:solidFill>
+              <a:srgbClr val="FFFFFF"/>
+            </a:solidFill>
           </a:ln>
         </p:spPr>
         <p:style>
@@ -4688,7 +4909,7 @@
           <a:lstStyle/>
           <a:p>
             <a:pPr algn="ctr">
-              <a:defRPr sz="1150" b="1">
+              <a:defRPr sz="1200" b="1">
                 <a:solidFill>
                   <a:srgbClr val="FFFFFF"/>
                 </a:solidFill>
@@ -4696,7 +4917,7 @@
               </a:defRPr>
             </a:pPr>
             <a:r>
-              <a:t>Foveated Adaptive Grid Generation</a:t>
+              <a:t>[4]  Foveated Adaptive Grid Generation</a:t>
             </a:r>
           </a:p>
         </p:txBody>
@@ -4709,14 +4930,14 @@
         </p:nvSpPr>
         <p:spPr>
           <a:xfrm>
-            <a:off x="2514600" y="4590288"/>
+            <a:off x="2514600" y="4572000"/>
             <a:ext cx="274320" cy="182880"/>
           </a:xfrm>
           <a:prstGeom prst="downArrow">
             <a:avLst/>
           </a:prstGeom>
           <a:solidFill>
-            <a:srgbClr val="6496D2"/>
+            <a:srgbClr val="0284C7"/>
           </a:solidFill>
           <a:ln>
             <a:noFill/>
@@ -4752,17 +4973,19 @@
         </p:nvSpPr>
         <p:spPr>
           <a:xfrm>
-            <a:off x="548640" y="4828032"/>
+            <a:off x="548640" y="4809744"/>
             <a:ext cx="4206240" cy="530352"/>
           </a:xfrm>
           <a:prstGeom prst="roundRect">
             <a:avLst/>
           </a:prstGeom>
           <a:solidFill>
-            <a:srgbClr val="146EC8"/>
+            <a:srgbClr val="1D4ED8"/>
           </a:solidFill>
-          <a:ln>
-            <a:noFill/>
+          <a:ln w="12700">
+            <a:solidFill>
+              <a:srgbClr val="FFFFFF"/>
+            </a:solidFill>
           </a:ln>
         </p:spPr>
         <p:style>
@@ -4784,7 +5007,7 @@
           <a:lstStyle/>
           <a:p>
             <a:pPr algn="ctr">
-              <a:defRPr sz="1150" b="1">
+              <a:defRPr sz="1200" b="1">
                 <a:solidFill>
                   <a:srgbClr val="FFFFFF"/>
                 </a:solidFill>
@@ -4792,7 +5015,7 @@
               </a:defRPr>
             </a:pPr>
             <a:r>
-              <a:t>2.5D Semantic Elevation Map</a:t>
+              <a:t>[5]  2.5D Semantic Elevation Map</a:t>
             </a:r>
           </a:p>
         </p:txBody>
@@ -4805,14 +5028,14 @@
         </p:nvSpPr>
         <p:spPr>
           <a:xfrm>
-            <a:off x="2514600" y="5385816"/>
+            <a:off x="2514600" y="5367528"/>
             <a:ext cx="274320" cy="182880"/>
           </a:xfrm>
           <a:prstGeom prst="downArrow">
             <a:avLst/>
           </a:prstGeom>
           <a:solidFill>
-            <a:srgbClr val="6496D2"/>
+            <a:srgbClr val="0284C7"/>
           </a:solidFill>
           <a:ln>
             <a:noFill/>
@@ -4848,17 +5071,19 @@
         </p:nvSpPr>
         <p:spPr>
           <a:xfrm>
-            <a:off x="548640" y="5623560"/>
+            <a:off x="548640" y="5605272"/>
             <a:ext cx="4206240" cy="530352"/>
           </a:xfrm>
           <a:prstGeom prst="roundRect">
             <a:avLst/>
           </a:prstGeom>
           <a:solidFill>
-            <a:srgbClr val="146EC8"/>
+            <a:srgbClr val="1D4ED8"/>
           </a:solidFill>
-          <a:ln>
-            <a:noFill/>
+          <a:ln w="12700">
+            <a:solidFill>
+              <a:srgbClr val="FFFFFF"/>
+            </a:solidFill>
           </a:ln>
         </p:spPr>
         <p:style>
@@ -4880,7 +5105,7 @@
           <a:lstStyle/>
           <a:p>
             <a:pPr algn="ctr">
-              <a:defRPr sz="1150" b="1">
+              <a:defRPr sz="1200" b="1">
                 <a:solidFill>
                   <a:srgbClr val="FFFFFF"/>
                 </a:solidFill>
@@ -4888,7 +5113,7 @@
               </a:defRPr>
             </a:pPr>
             <a:r>
-              <a:t>Real-Time Visualization &amp; Navigation</a:t>
+              <a:t>[6]  Real-Time Visualization &amp; Navigation</a:t>
             </a:r>
           </a:p>
         </p:txBody>
@@ -4909,7 +5134,7 @@
         </p:blipFill>
         <p:spPr>
           <a:xfrm>
-            <a:off x="4937760" y="1188720"/>
+            <a:off x="4937760" y="1143000"/>
             <a:ext cx="6766560" cy="4087280"/>
           </a:xfrm>
           <a:prstGeom prst="rect">
@@ -4919,28 +5144,50 @@
       </p:pic>
       <p:sp>
         <p:nvSpPr>
-          <p:cNvPr id="19" name="TextBox 18"/>
-          <p:cNvSpPr txBox="1"/>
+          <p:cNvPr id="19" name="Rounded Rectangle 18"/>
+          <p:cNvSpPr/>
           <p:nvPr/>
         </p:nvSpPr>
         <p:spPr>
           <a:xfrm>
-            <a:off x="4937760" y="4663440"/>
-            <a:ext cx="6766560" cy="320040"/>
-          </a:xfrm>
-          <a:prstGeom prst="rect">
+            <a:off x="4937760" y="4617720"/>
+            <a:ext cx="6766560" cy="1737360"/>
+          </a:xfrm>
+          <a:prstGeom prst="roundRect">
             <a:avLst/>
           </a:prstGeom>
-          <a:noFill/>
-        </p:spPr>
-        <p:txBody>
-          <a:bodyPr wrap="none" lIns="0" tIns="0">
-            <a:spAutoFit/>
-          </a:bodyPr>
-          <a:lstStyle/>
-          <a:p>
-            <a:pPr>
-              <a:defRPr sz="1400" b="1">
+          <a:solidFill>
+            <a:srgbClr val="F8FAFC"/>
+          </a:solidFill>
+          <a:ln w="19050">
+            <a:solidFill>
+              <a:srgbClr val="E2E8F0"/>
+            </a:solidFill>
+          </a:ln>
+        </p:spPr>
+        <p:style>
+          <a:lnRef idx="1">
+            <a:schemeClr val="accent1"/>
+          </a:lnRef>
+          <a:fillRef idx="3">
+            <a:schemeClr val="accent1"/>
+          </a:fillRef>
+          <a:effectRef idx="2">
+            <a:schemeClr val="accent1"/>
+          </a:effectRef>
+          <a:fontRef idx="minor">
+            <a:schemeClr val="lt1"/>
+          </a:fontRef>
+        </p:style>
+        <p:txBody>
+          <a:bodyPr rtlCol="0" anchor="ctr" wrap="square" lIns="164592" tIns="164592"/>
+          <a:lstStyle/>
+          <a:p>
+            <a:pPr algn="ctr">
+              <a:spcAft>
+                <a:spcPts val="400"/>
+              </a:spcAft>
+              <a:defRPr sz="1350" b="1">
                 <a:solidFill>
                   <a:srgbClr val="1D4ED8"/>
                 </a:solidFill>
@@ -4948,94 +5195,107 @@
               </a:defRPr>
             </a:pPr>
             <a:r>
-              <a:t>Technologies &amp; Implementation:</a:t>
-            </a:r>
-          </a:p>
-        </p:txBody>
-      </p:sp>
-      <p:sp>
-        <p:nvSpPr>
-          <p:cNvPr id="20" name="TextBox 19"/>
-          <p:cNvSpPr txBox="1"/>
-          <p:nvPr/>
-        </p:nvSpPr>
-        <p:spPr>
-          <a:xfrm>
-            <a:off x="4937760" y="5029200"/>
-            <a:ext cx="6766560" cy="1371600"/>
-          </a:xfrm>
-          <a:prstGeom prst="rect">
-            <a:avLst/>
-          </a:prstGeom>
-          <a:noFill/>
-        </p:spPr>
-        <p:txBody>
-          <a:bodyPr wrap="square" lIns="0" tIns="0">
-            <a:spAutoFit/>
-          </a:bodyPr>
-          <a:lstStyle/>
+              <a:t>💻 Technologies &amp; Software Implementation:</a:t>
+            </a:r>
+          </a:p>
           <a:p>
             <a:pPr>
               <a:spcAft>
-                <a:spcPts val="300"/>
+                <a:spcPts val="200"/>
               </a:spcAft>
-              <a:defRPr sz="1100">
-                <a:solidFill>
-                  <a:srgbClr val="1F2937"/>
-                </a:solidFill>
-                <a:latin typeface="Arial"/>
-              </a:defRPr>
-            </a:pPr>
-            <a:r>
-              <a:t>• Python 3.12, NumPy (vectorized hashing), Open3D (point cloud processing)</a:t>
+            </a:pPr>
+            <a:r>
+              <a:rPr sz="1050" b="1">
+                <a:solidFill>
+                  <a:srgbClr val="0F172A"/>
+                </a:solidFill>
+                <a:latin typeface="Arial"/>
+              </a:rPr>
+              <a:t>• Core Stack: </a:t>
+            </a:r>
+            <a:r>
+              <a:rPr sz="1050">
+                <a:solidFill>
+                  <a:srgbClr val="1E293B"/>
+                </a:solidFill>
+                <a:latin typeface="Arial"/>
+              </a:rPr>
+              <a:t>Python 3.12, NumPy (vectorized hashing), Open3D (point cloud geometry)</a:t>
             </a:r>
           </a:p>
           <a:p>
             <a:pPr>
               <a:spcAft>
-                <a:spcPts val="300"/>
+                <a:spcPts val="200"/>
               </a:spcAft>
-              <a:defRPr sz="1100">
-                <a:solidFill>
-                  <a:srgbClr val="1F2937"/>
-                </a:solidFill>
-                <a:latin typeface="Arial"/>
-              </a:defRPr>
-            </a:pPr>
-            <a:r>
-              <a:t>• Deep Learning-Based Semantic Segmentation (Ground, Obstacles, Dynamic Vehicles)</a:t>
+            </a:pPr>
+            <a:r>
+              <a:rPr sz="1050" b="1">
+                <a:solidFill>
+                  <a:srgbClr val="0F172A"/>
+                </a:solidFill>
+                <a:latin typeface="Arial"/>
+              </a:rPr>
+              <a:t>• Semantic Intelligence: </a:t>
+            </a:r>
+            <a:r>
+              <a:rPr sz="1050">
+                <a:solidFill>
+                  <a:srgbClr val="1E293B"/>
+                </a:solidFill>
+                <a:latin typeface="Arial"/>
+              </a:rPr>
+              <a:t>4-Class ML Classifier (Ground, Static Obstacles, Dynamic Vehicles)</a:t>
             </a:r>
           </a:p>
           <a:p>
             <a:pPr>
               <a:spcAft>
-                <a:spcPts val="300"/>
+                <a:spcPts val="200"/>
               </a:spcAft>
-              <a:defRPr sz="1100">
-                <a:solidFill>
-                  <a:srgbClr val="1F2937"/>
-                </a:solidFill>
-                <a:latin typeface="Arial"/>
-              </a:defRPr>
-            </a:pPr>
-            <a:r>
-              <a:t>• A* Graph Search &amp; Pure Pursuit Kinematics (Catmull-Rom splines, Ackermann model)</a:t>
+            </a:pPr>
+            <a:r>
+              <a:rPr sz="1050" b="1">
+                <a:solidFill>
+                  <a:srgbClr val="0F172A"/>
+                </a:solidFill>
+                <a:latin typeface="Arial"/>
+              </a:rPr>
+              <a:t>• Autonomous Motion: </a:t>
+            </a:r>
+            <a:r>
+              <a:rPr sz="1050">
+                <a:solidFill>
+                  <a:srgbClr val="1E293B"/>
+                </a:solidFill>
+                <a:latin typeface="Arial"/>
+              </a:rPr>
+              <a:t>A* Graph Search, Catmull-Rom Splines, Ackermann Pure Pursuit Kinematics</a:t>
             </a:r>
           </a:p>
           <a:p>
             <a:pPr>
               <a:spcAft>
-                <a:spcPts val="300"/>
+                <a:spcPts val="200"/>
               </a:spcAft>
-              <a:defRPr sz="1100">
-                <a:solidFill>
-                  <a:srgbClr val="1F2937"/>
-                </a:solidFill>
-                <a:latin typeface="Arial"/>
-              </a:defRPr>
-            </a:pPr>
-            <a:r>
-              <a:t>• Real-Time Web Dashboard (Flask REST API, 60 FPS Canvas with moving foveation bubble)</a:t>
+            </a:pPr>
+            <a:r>
+              <a:rPr sz="1050" b="1">
+                <a:solidFill>
+                  <a:srgbClr val="0F172A"/>
+                </a:solidFill>
+                <a:latin typeface="Arial"/>
+              </a:rPr>
+              <a:t>• Live Web Dashboard: </a:t>
+            </a:r>
+            <a:r>
+              <a:rPr sz="1050">
+                <a:solidFill>
+                  <a:srgbClr val="1E293B"/>
+                </a:solidFill>
+                <a:latin typeface="Arial"/>
+              </a:rPr>
+              <a:t>Flask REST API, 60 FPS HTML5 Canvas with dynamic moving-car foveation</a:t>
             </a:r>
           </a:p>
         </p:txBody>
@@ -5066,7 +5326,7 @@
         </p:nvSpPr>
         <p:spPr>
           <a:xfrm>
-            <a:off x="457200" y="201168"/>
+            <a:off x="457200" y="182880"/>
             <a:ext cx="1280160" cy="822960"/>
           </a:xfrm>
           <a:prstGeom prst="ellipse">
@@ -5075,9 +5335,9 @@
           <a:solidFill>
             <a:srgbClr val="FFFFFF"/>
           </a:solidFill>
-          <a:ln w="19050">
+          <a:ln w="25400">
             <a:solidFill>
-              <a:srgbClr val="111827"/>
+              <a:srgbClr val="1D4ED8"/>
             </a:solidFill>
           </a:ln>
         </p:spPr>
@@ -5102,7 +5362,7 @@
             <a:pPr algn="ctr">
               <a:defRPr sz="1200" b="1">
                 <a:solidFill>
-                  <a:srgbClr val="111827"/>
+                  <a:srgbClr val="1D4ED8"/>
                 </a:solidFill>
                 <a:latin typeface="Arial"/>
               </a:defRPr>
@@ -5125,7 +5385,7 @@
         </p:nvSpPr>
         <p:spPr>
           <a:xfrm>
-            <a:off x="1920240" y="201168"/>
+            <a:off x="1920240" y="182880"/>
             <a:ext cx="8046720" cy="822960"/>
           </a:xfrm>
           <a:prstGeom prst="rect">
@@ -5140,9 +5400,9 @@
           <a:lstStyle/>
           <a:p>
             <a:pPr algn="ctr">
-              <a:defRPr sz="2150" b="1">
-                <a:solidFill>
-                  <a:srgbClr val="111827"/>
+              <a:defRPr sz="2200" b="1">
+                <a:solidFill>
+                  <a:srgbClr val="0F172A"/>
                 </a:solidFill>
                 <a:latin typeface="Arial"/>
               </a:defRPr>
@@ -5217,7 +5477,7 @@
           <a:lstStyle/>
           <a:p>
             <a:pPr algn="ctr">
-              <a:defRPr sz="1050">
+              <a:defRPr sz="1050" b="1">
                 <a:solidFill>
                   <a:srgbClr val="FFFFFF"/>
                 </a:solidFill>
@@ -5238,8 +5498,344 @@
         </p:nvSpPr>
         <p:spPr>
           <a:xfrm>
-            <a:off x="548640" y="1143000"/>
-            <a:ext cx="2011680" cy="438912"/>
+            <a:off x="548640" y="1115568"/>
+            <a:ext cx="2377440" cy="438912"/>
+          </a:xfrm>
+          <a:prstGeom prst="roundRect">
+            <a:avLst/>
+          </a:prstGeom>
+          <a:solidFill>
+            <a:srgbClr val="047857"/>
+          </a:solidFill>
+          <a:ln>
+            <a:noFill/>
+          </a:ln>
+        </p:spPr>
+        <p:style>
+          <a:lnRef idx="1">
+            <a:schemeClr val="accent1"/>
+          </a:lnRef>
+          <a:fillRef idx="3">
+            <a:schemeClr val="accent1"/>
+          </a:fillRef>
+          <a:effectRef idx="2">
+            <a:schemeClr val="accent1"/>
+          </a:effectRef>
+          <a:fontRef idx="minor">
+            <a:schemeClr val="lt1"/>
+          </a:fontRef>
+        </p:style>
+        <p:txBody>
+          <a:bodyPr rtlCol="0" anchor="ctr"/>
+          <a:lstStyle/>
+          <a:p>
+            <a:pPr algn="ctr">
+              <a:defRPr sz="1300" b="1">
+                <a:solidFill>
+                  <a:srgbClr val="FFFFFF"/>
+                </a:solidFill>
+                <a:latin typeface="Arial"/>
+              </a:defRPr>
+            </a:pPr>
+            <a:r>
+              <a:t>✔ Feasibility &amp; Viability</a:t>
+            </a:r>
+          </a:p>
+        </p:txBody>
+      </p:sp>
+      <p:sp>
+        <p:nvSpPr>
+          <p:cNvPr id="7" name="TextBox 6"/>
+          <p:cNvSpPr txBox="1"/>
+          <p:nvPr/>
+        </p:nvSpPr>
+        <p:spPr>
+          <a:xfrm>
+            <a:off x="548640" y="1645920"/>
+            <a:ext cx="5303520" cy="1828800"/>
+          </a:xfrm>
+          <a:prstGeom prst="rect">
+            <a:avLst/>
+          </a:prstGeom>
+          <a:noFill/>
+        </p:spPr>
+        <p:txBody>
+          <a:bodyPr wrap="square" lIns="0" tIns="0">
+            <a:spAutoFit/>
+          </a:bodyPr>
+          <a:lstStyle/>
+          <a:p>
+            <a:pPr>
+              <a:spcAft>
+                <a:spcPts val="300"/>
+              </a:spcAft>
+            </a:pPr>
+            <a:r>
+              <a:rPr b="1" sz="1100">
+                <a:solidFill>
+                  <a:srgbClr val="047857"/>
+                </a:solidFill>
+              </a:rPr>
+              <a:t>• Open-Source &amp; Standard Datasets: </a:t>
+            </a:r>
+            <a:r>
+              <a:rPr sz="1100">
+                <a:solidFill>
+                  <a:srgbClr val="1E293B"/>
+                </a:solidFill>
+              </a:rPr>
+              <a:t>Built on widely tested LiDAR datasets and open tools.</a:t>
+            </a:r>
+          </a:p>
+          <a:p>
+            <a:pPr>
+              <a:spcAft>
+                <a:spcPts val="300"/>
+              </a:spcAft>
+            </a:pPr>
+            <a:r>
+              <a:rPr b="1" sz="1100">
+                <a:solidFill>
+                  <a:srgbClr val="047857"/>
+                </a:solidFill>
+              </a:rPr>
+              <a:t>• Rapid Edge Prototype: </a:t>
+            </a:r>
+            <a:r>
+              <a:rPr sz="1100">
+                <a:solidFill>
+                  <a:srgbClr val="1E293B"/>
+                </a:solidFill>
+              </a:rPr>
+              <a:t>Python 3.12, Open3D, and PyTorch enable agile modular development.</a:t>
+            </a:r>
+          </a:p>
+          <a:p>
+            <a:pPr>
+              <a:spcAft>
+                <a:spcPts val="300"/>
+              </a:spcAft>
+            </a:pPr>
+            <a:r>
+              <a:rPr b="1" sz="1100">
+                <a:solidFill>
+                  <a:srgbClr val="047857"/>
+                </a:solidFill>
+              </a:rPr>
+              <a:t>• Edge Compute Efficiency: </a:t>
+            </a:r>
+            <a:r>
+              <a:rPr sz="1100">
+                <a:solidFill>
+                  <a:srgbClr val="1E293B"/>
+                </a:solidFill>
+              </a:rPr>
+              <a:t>Adaptive resolution drastically reduces RAM and latency.</a:t>
+            </a:r>
+          </a:p>
+          <a:p>
+            <a:pPr>
+              <a:spcAft>
+                <a:spcPts val="300"/>
+              </a:spcAft>
+            </a:pPr>
+            <a:r>
+              <a:rPr b="1" sz="1100">
+                <a:solidFill>
+                  <a:srgbClr val="047857"/>
+                </a:solidFill>
+              </a:rPr>
+              <a:t>• Independent Subsystem Verification: </a:t>
+            </a:r>
+            <a:r>
+              <a:rPr sz="1100">
+                <a:solidFill>
+                  <a:srgbClr val="1E293B"/>
+                </a:solidFill>
+              </a:rPr>
+              <a:t>Modular pipeline with 5/5 automated unit tests passing.</a:t>
+            </a:r>
+          </a:p>
+        </p:txBody>
+      </p:sp>
+      <p:sp>
+        <p:nvSpPr>
+          <p:cNvPr id="8" name="Rounded Rectangle 7"/>
+          <p:cNvSpPr/>
+          <p:nvPr/>
+        </p:nvSpPr>
+        <p:spPr>
+          <a:xfrm>
+            <a:off x="548640" y="3566160"/>
+            <a:ext cx="2377440" cy="438912"/>
+          </a:xfrm>
+          <a:prstGeom prst="roundRect">
+            <a:avLst/>
+          </a:prstGeom>
+          <a:solidFill>
+            <a:srgbClr val="E11D48"/>
+          </a:solidFill>
+          <a:ln>
+            <a:noFill/>
+          </a:ln>
+        </p:spPr>
+        <p:style>
+          <a:lnRef idx="1">
+            <a:schemeClr val="accent1"/>
+          </a:lnRef>
+          <a:fillRef idx="3">
+            <a:schemeClr val="accent1"/>
+          </a:fillRef>
+          <a:effectRef idx="2">
+            <a:schemeClr val="accent1"/>
+          </a:effectRef>
+          <a:fontRef idx="minor">
+            <a:schemeClr val="lt1"/>
+          </a:fontRef>
+        </p:style>
+        <p:txBody>
+          <a:bodyPr rtlCol="0" anchor="ctr"/>
+          <a:lstStyle/>
+          <a:p>
+            <a:pPr algn="ctr">
+              <a:defRPr sz="1300" b="1">
+                <a:solidFill>
+                  <a:srgbClr val="FFFFFF"/>
+                </a:solidFill>
+                <a:latin typeface="Arial"/>
+              </a:defRPr>
+            </a:pPr>
+            <a:r>
+              <a:t>⚠ Tactical Challenges</a:t>
+            </a:r>
+          </a:p>
+        </p:txBody>
+      </p:sp>
+      <p:sp>
+        <p:nvSpPr>
+          <p:cNvPr id="9" name="TextBox 8"/>
+          <p:cNvSpPr txBox="1"/>
+          <p:nvPr/>
+        </p:nvSpPr>
+        <p:spPr>
+          <a:xfrm>
+            <a:off x="548640" y="4096512"/>
+            <a:ext cx="5303520" cy="2194560"/>
+          </a:xfrm>
+          <a:prstGeom prst="rect">
+            <a:avLst/>
+          </a:prstGeom>
+          <a:noFill/>
+        </p:spPr>
+        <p:txBody>
+          <a:bodyPr wrap="square" lIns="0" tIns="0">
+            <a:spAutoFit/>
+          </a:bodyPr>
+          <a:lstStyle/>
+          <a:p>
+            <a:pPr>
+              <a:spcAft>
+                <a:spcPts val="300"/>
+              </a:spcAft>
+            </a:pPr>
+            <a:r>
+              <a:rPr b="1" sz="1100">
+                <a:solidFill>
+                  <a:srgbClr val="E11D48"/>
+                </a:solidFill>
+              </a:rPr>
+              <a:t>• Heavy LiDAR Data Deluge: </a:t>
+            </a:r>
+            <a:r>
+              <a:rPr sz="1100">
+                <a:solidFill>
+                  <a:srgbClr val="1E293B"/>
+                </a:solidFill>
+              </a:rPr>
+              <a:t>Real-time processing of 1.5M points/sec from 10–20 Hz sweeps.</a:t>
+            </a:r>
+          </a:p>
+          <a:p>
+            <a:pPr>
+              <a:spcAft>
+                <a:spcPts val="300"/>
+              </a:spcAft>
+            </a:pPr>
+            <a:r>
+              <a:rPr b="1" sz="1100">
+                <a:solidFill>
+                  <a:srgbClr val="E11D48"/>
+                </a:solidFill>
+              </a:rPr>
+              <a:t>• Unstructured Off-Road Terrain: </a:t>
+            </a:r>
+            <a:r>
+              <a:rPr sz="1100">
+                <a:solidFill>
+                  <a:srgbClr val="1E293B"/>
+                </a:solidFill>
+              </a:rPr>
+              <a:t>Accurate terrain segmentation in dusty, rocky environments.</a:t>
+            </a:r>
+          </a:p>
+          <a:p>
+            <a:pPr>
+              <a:spcAft>
+                <a:spcPts val="300"/>
+              </a:spcAft>
+            </a:pPr>
+            <a:r>
+              <a:rPr b="1" sz="1100">
+                <a:solidFill>
+                  <a:srgbClr val="E11D48"/>
+                </a:solidFill>
+              </a:rPr>
+              <a:t>• Bridge / Underpass False Obstacles: </a:t>
+            </a:r>
+            <a:r>
+              <a:rPr sz="1100">
+                <a:solidFill>
+                  <a:srgbClr val="1E293B"/>
+                </a:solidFill>
+              </a:rPr>
+              <a:t>Preventing ceiling points from falsely blocking tunnels.</a:t>
+            </a:r>
+          </a:p>
+          <a:p>
+            <a:pPr>
+              <a:spcAft>
+                <a:spcPts val="300"/>
+              </a:spcAft>
+            </a:pPr>
+            <a:r>
+              <a:rPr b="1" sz="1100">
+                <a:solidFill>
+                  <a:srgbClr val="E11D48"/>
+                </a:solidFill>
+              </a:rPr>
+              <a:t>• Preserving Geometry in Low-Res: </a:t>
+            </a:r>
+            <a:r>
+              <a:rPr sz="1100">
+                <a:solidFill>
+                  <a:srgbClr val="1E293B"/>
+                </a:solidFill>
+              </a:rPr>
+              <a:t>Retaining safety clearance while reducing distant cell detail.</a:t>
+            </a:r>
+          </a:p>
+        </p:txBody>
+      </p:sp>
+      <p:sp>
+        <p:nvSpPr>
+          <p:cNvPr id="10" name="Rounded Rectangle 9"/>
+          <p:cNvSpPr/>
+          <p:nvPr/>
+        </p:nvSpPr>
+        <p:spPr>
+          <a:xfrm>
+            <a:off x="6126480" y="1115568"/>
+            <a:ext cx="2560320" cy="438912"/>
           </a:xfrm>
           <a:prstGeom prst="roundRect">
             <a:avLst/>
@@ -5270,7 +5866,7 @@
           <a:lstStyle/>
           <a:p>
             <a:pPr algn="ctr">
-              <a:defRPr sz="1350" b="1">
+              <a:defRPr sz="1300" b="1">
                 <a:solidFill>
                   <a:srgbClr val="FFFFFF"/>
                 </a:solidFill>
@@ -5278,21 +5874,21 @@
               </a:defRPr>
             </a:pPr>
             <a:r>
-              <a:t>Feasibility</a:t>
-            </a:r>
-          </a:p>
-        </p:txBody>
-      </p:sp>
-      <p:sp>
-        <p:nvSpPr>
-          <p:cNvPr id="7" name="TextBox 6"/>
+              <a:t>🛡 Mitigation Strategies</a:t>
+            </a:r>
+          </a:p>
+        </p:txBody>
+      </p:sp>
+      <p:sp>
+        <p:nvSpPr>
+          <p:cNvPr id="11" name="TextBox 10"/>
           <p:cNvSpPr txBox="1"/>
           <p:nvPr/>
         </p:nvSpPr>
         <p:spPr>
           <a:xfrm>
-            <a:off x="548640" y="1691640"/>
-            <a:ext cx="5303520" cy="1828800"/>
+            <a:off x="6126480" y="1645920"/>
+            <a:ext cx="5486400" cy="1463040"/>
           </a:xfrm>
           <a:prstGeom prst="rect">
             <a:avLst/>
@@ -5309,15 +5905,22 @@
               <a:spcAft>
                 <a:spcPts val="300"/>
               </a:spcAft>
-              <a:defRPr sz="1100">
-                <a:solidFill>
-                  <a:srgbClr val="1F2937"/>
-                </a:solidFill>
-                <a:latin typeface="Arial"/>
-              </a:defRPr>
-            </a:pPr>
-            <a:r>
-              <a:t>• Uses widely available LiDAR point cloud datasets and open-source tools</a:t>
+            </a:pPr>
+            <a:r>
+              <a:rPr b="1" sz="1100">
+                <a:solidFill>
+                  <a:srgbClr val="1D4ED8"/>
+                </a:solidFill>
+              </a:rPr>
+              <a:t>• Foveated Attention Hashing: </a:t>
+            </a:r>
+            <a:r>
+              <a:rPr sz="1100">
+                <a:solidFill>
+                  <a:srgbClr val="1E293B"/>
+                </a:solidFill>
+              </a:rPr>
+              <a:t>Focuses 0.25 m resolution in near-field for instant 24.23 ms execution.</a:t>
             </a:r>
           </a:p>
           <a:p>
@@ -5325,15 +5928,22 @@
               <a:spcAft>
                 <a:spcPts val="300"/>
               </a:spcAft>
-              <a:defRPr sz="1100">
-                <a:solidFill>
-                  <a:srgbClr val="1F2937"/>
-                </a:solidFill>
-                <a:latin typeface="Arial"/>
-              </a:defRPr>
-            </a:pPr>
-            <a:r>
-              <a:t>• Python, Open3D, and PyTorch enable rapid prototype development</a:t>
+            </a:pPr>
+            <a:r>
+              <a:rPr b="1" sz="1100">
+                <a:solidFill>
+                  <a:srgbClr val="1D4ED8"/>
+                </a:solidFill>
+              </a:rPr>
+              <a:t>• SOR &amp; RANSAC Ground Fit: </a:t>
+            </a:r>
+            <a:r>
+              <a:rPr sz="1100">
+                <a:solidFill>
+                  <a:srgbClr val="1E293B"/>
+                </a:solidFill>
+              </a:rPr>
+              <a:t>Statistical filters eliminate dust scatter and extract clean ground plane.</a:t>
             </a:r>
           </a:p>
           <a:p>
@@ -5341,15 +5951,22 @@
               <a:spcAft>
                 <a:spcPts val="300"/>
               </a:spcAft>
-              <a:defRPr sz="1100">
-                <a:solidFill>
-                  <a:srgbClr val="1F2937"/>
-                </a:solidFill>
-                <a:latin typeface="Arial"/>
-              </a:defRPr>
-            </a:pPr>
-            <a:r>
-              <a:t>• Adaptive resolution reduces memory and computational requirements</a:t>
+            </a:pPr>
+            <a:r>
+              <a:rPr b="1" sz="1100">
+                <a:solidFill>
+                  <a:srgbClr val="1D4ED8"/>
+                </a:solidFill>
+              </a:rPr>
+              <a:t>• Vertical Clearance Filtering: </a:t>
+            </a:r>
+            <a:r>
+              <a:rPr sz="1100">
+                <a:solidFill>
+                  <a:srgbClr val="1E293B"/>
+                </a:solidFill>
+              </a:rPr>
+              <a:t>Clips points &gt;2.2 m to allow safe tunnel traversal without 3D voxels.</a:t>
             </a:r>
           </a:p>
           <a:p>
@@ -5357,295 +5974,22 @@
               <a:spcAft>
                 <a:spcPts val="300"/>
               </a:spcAft>
-              <a:defRPr sz="1100">
-                <a:solidFill>
-                  <a:srgbClr val="1F2937"/>
-                </a:solidFill>
-                <a:latin typeface="Arial"/>
-              </a:defRPr>
-            </a:pPr>
-            <a:r>
-              <a:t>• Modular pipeline allows components to be developed and tested independently</a:t>
-            </a:r>
-          </a:p>
-        </p:txBody>
-      </p:sp>
-      <p:sp>
-        <p:nvSpPr>
-          <p:cNvPr id="8" name="Rounded Rectangle 7"/>
-          <p:cNvSpPr/>
-          <p:nvPr/>
-        </p:nvSpPr>
-        <p:spPr>
-          <a:xfrm>
-            <a:off x="548640" y="3611880"/>
-            <a:ext cx="2011680" cy="438912"/>
-          </a:xfrm>
-          <a:prstGeom prst="roundRect">
-            <a:avLst/>
-          </a:prstGeom>
-          <a:solidFill>
-            <a:srgbClr val="1D4ED8"/>
-          </a:solidFill>
-          <a:ln>
-            <a:noFill/>
-          </a:ln>
-        </p:spPr>
-        <p:style>
-          <a:lnRef idx="1">
-            <a:schemeClr val="accent1"/>
-          </a:lnRef>
-          <a:fillRef idx="3">
-            <a:schemeClr val="accent1"/>
-          </a:fillRef>
-          <a:effectRef idx="2">
-            <a:schemeClr val="accent1"/>
-          </a:effectRef>
-          <a:fontRef idx="minor">
-            <a:schemeClr val="lt1"/>
-          </a:fontRef>
-        </p:style>
-        <p:txBody>
-          <a:bodyPr rtlCol="0" anchor="ctr"/>
-          <a:lstStyle/>
-          <a:p>
-            <a:pPr algn="ctr">
-              <a:defRPr sz="1350" b="1">
-                <a:solidFill>
-                  <a:srgbClr val="FFFFFF"/>
-                </a:solidFill>
-                <a:latin typeface="Arial"/>
-              </a:defRPr>
-            </a:pPr>
-            <a:r>
-              <a:t>Challenges</a:t>
-            </a:r>
-          </a:p>
-        </p:txBody>
-      </p:sp>
-      <p:sp>
-        <p:nvSpPr>
-          <p:cNvPr id="9" name="TextBox 8"/>
-          <p:cNvSpPr txBox="1"/>
-          <p:nvPr/>
-        </p:nvSpPr>
-        <p:spPr>
-          <a:xfrm>
-            <a:off x="548640" y="4160520"/>
-            <a:ext cx="5303520" cy="2194560"/>
-          </a:xfrm>
-          <a:prstGeom prst="rect">
-            <a:avLst/>
-          </a:prstGeom>
-          <a:noFill/>
-        </p:spPr>
-        <p:txBody>
-          <a:bodyPr wrap="square" lIns="0" tIns="0">
-            <a:spAutoFit/>
-          </a:bodyPr>
-          <a:lstStyle/>
-          <a:p>
-            <a:pPr>
-              <a:spcAft>
-                <a:spcPts val="300"/>
-              </a:spcAft>
-              <a:defRPr sz="1100">
-                <a:solidFill>
-                  <a:srgbClr val="1F2937"/>
-                </a:solidFill>
-                <a:latin typeface="Arial"/>
-              </a:defRPr>
-            </a:pPr>
-            <a:r>
-              <a:t>• Real-time processing of large LiDAR point clouds at 10–20 Hz</a:t>
-            </a:r>
-          </a:p>
-          <a:p>
-            <a:pPr>
-              <a:spcAft>
-                <a:spcPts val="300"/>
-              </a:spcAft>
-              <a:defRPr sz="1100">
-                <a:solidFill>
-                  <a:srgbClr val="1F2937"/>
-                </a:solidFill>
-                <a:latin typeface="Arial"/>
-              </a:defRPr>
-            </a:pPr>
-            <a:r>
-              <a:t>• Accurate semantic classification in unstructured off-road scenes</a:t>
-            </a:r>
-          </a:p>
-          <a:p>
-            <a:pPr>
-              <a:spcAft>
-                <a:spcPts val="300"/>
-              </a:spcAft>
-              <a:defRPr sz="1100">
-                <a:solidFill>
-                  <a:srgbClr val="1F2937"/>
-                </a:solidFill>
-                <a:latin typeface="Arial"/>
-              </a:defRPr>
-            </a:pPr>
-            <a:r>
-              <a:t>• Avoiding false-positive obstacles for underpasses &amp; overhead foliage</a:t>
-            </a:r>
-          </a:p>
-          <a:p>
-            <a:pPr>
-              <a:spcAft>
-                <a:spcPts val="300"/>
-              </a:spcAft>
-              <a:defRPr sz="1100">
-                <a:solidFill>
-                  <a:srgbClr val="1F2937"/>
-                </a:solidFill>
-                <a:latin typeface="Arial"/>
-              </a:defRPr>
-            </a:pPr>
-            <a:r>
-              <a:t>• Maintaining critical safety detail while reducing distant cell resolution</a:t>
-            </a:r>
-          </a:p>
-        </p:txBody>
-      </p:sp>
-      <p:sp>
-        <p:nvSpPr>
-          <p:cNvPr id="10" name="Rounded Rectangle 9"/>
-          <p:cNvSpPr/>
-          <p:nvPr/>
-        </p:nvSpPr>
-        <p:spPr>
-          <a:xfrm>
-            <a:off x="6126480" y="1143000"/>
-            <a:ext cx="2468880" cy="438912"/>
-          </a:xfrm>
-          <a:prstGeom prst="roundRect">
-            <a:avLst/>
-          </a:prstGeom>
-          <a:solidFill>
-            <a:srgbClr val="1D4ED8"/>
-          </a:solidFill>
-          <a:ln>
-            <a:noFill/>
-          </a:ln>
-        </p:spPr>
-        <p:style>
-          <a:lnRef idx="1">
-            <a:schemeClr val="accent1"/>
-          </a:lnRef>
-          <a:fillRef idx="3">
-            <a:schemeClr val="accent1"/>
-          </a:fillRef>
-          <a:effectRef idx="2">
-            <a:schemeClr val="accent1"/>
-          </a:effectRef>
-          <a:fontRef idx="minor">
-            <a:schemeClr val="lt1"/>
-          </a:fontRef>
-        </p:style>
-        <p:txBody>
-          <a:bodyPr rtlCol="0" anchor="ctr"/>
-          <a:lstStyle/>
-          <a:p>
-            <a:pPr algn="ctr">
-              <a:defRPr sz="1350" b="1">
-                <a:solidFill>
-                  <a:srgbClr val="FFFFFF"/>
-                </a:solidFill>
-                <a:latin typeface="Arial"/>
-              </a:defRPr>
-            </a:pPr>
-            <a:r>
-              <a:t>Mitigation Strategy</a:t>
-            </a:r>
-          </a:p>
-        </p:txBody>
-      </p:sp>
-      <p:sp>
-        <p:nvSpPr>
-          <p:cNvPr id="11" name="TextBox 10"/>
-          <p:cNvSpPr txBox="1"/>
-          <p:nvPr/>
-        </p:nvSpPr>
-        <p:spPr>
-          <a:xfrm>
-            <a:off x="6126480" y="1691640"/>
-            <a:ext cx="5486400" cy="1463040"/>
-          </a:xfrm>
-          <a:prstGeom prst="rect">
-            <a:avLst/>
-          </a:prstGeom>
-          <a:noFill/>
-        </p:spPr>
-        <p:txBody>
-          <a:bodyPr wrap="square" lIns="0" tIns="0">
-            <a:spAutoFit/>
-          </a:bodyPr>
-          <a:lstStyle/>
-          <a:p>
-            <a:pPr>
-              <a:spcAft>
-                <a:spcPts val="300"/>
-              </a:spcAft>
-              <a:defRPr sz="1100">
-                <a:solidFill>
-                  <a:srgbClr val="1F2937"/>
-                </a:solidFill>
-                <a:latin typeface="Arial"/>
-              </a:defRPr>
-            </a:pPr>
-            <a:r>
-              <a:t>• Foveated variable-resolution mapping concentrates power in near-field</a:t>
-            </a:r>
-          </a:p>
-          <a:p>
-            <a:pPr>
-              <a:spcAft>
-                <a:spcPts val="300"/>
-              </a:spcAft>
-              <a:defRPr sz="1100">
-                <a:solidFill>
-                  <a:srgbClr val="1F2937"/>
-                </a:solidFill>
-                <a:latin typeface="Arial"/>
-              </a:defRPr>
-            </a:pPr>
-            <a:r>
-              <a:t>• Efficient preprocessing (SOR &amp; RANSAC ground fit) filters dust &amp; noise</a:t>
-            </a:r>
-          </a:p>
-          <a:p>
-            <a:pPr>
-              <a:spcAft>
-                <a:spcPts val="300"/>
-              </a:spcAft>
-              <a:defRPr sz="1100">
-                <a:solidFill>
-                  <a:srgbClr val="1F2937"/>
-                </a:solidFill>
-                <a:latin typeface="Arial"/>
-              </a:defRPr>
-            </a:pPr>
-            <a:r>
-              <a:t>• Vertical beam clearance filter enables underpass &amp; tunnel passage</a:t>
-            </a:r>
-          </a:p>
-          <a:p>
-            <a:pPr>
-              <a:spcAft>
-                <a:spcPts val="300"/>
-              </a:spcAft>
-              <a:defRPr sz="1100">
-                <a:solidFill>
-                  <a:srgbClr val="1F2937"/>
-                </a:solidFill>
-                <a:latin typeface="Arial"/>
-              </a:defRPr>
-            </a:pPr>
-            <a:r>
-              <a:t>• Validated on 20,672 points in 24.23 ms with 5/5 passing unit tests</a:t>
+            </a:pPr>
+            <a:r>
+              <a:rPr b="1" sz="1100">
+                <a:solidFill>
+                  <a:srgbClr val="1D4ED8"/>
+                </a:solidFill>
+              </a:rPr>
+              <a:t>• Rigorous Verification: </a:t>
+            </a:r>
+            <a:r>
+              <a:rPr sz="1100">
+                <a:solidFill>
+                  <a:srgbClr val="1E293B"/>
+                </a:solidFill>
+              </a:rPr>
+              <a:t>Benchmarked on 20,672 points at &gt;35 FPS with zero crash failures.</a:t>
             </a:r>
           </a:p>
         </p:txBody>
@@ -5700,7 +6044,7 @@
         </p:nvSpPr>
         <p:spPr>
           <a:xfrm>
-            <a:off x="457200" y="201168"/>
+            <a:off x="457200" y="182880"/>
             <a:ext cx="1280160" cy="822960"/>
           </a:xfrm>
           <a:prstGeom prst="ellipse">
@@ -5709,9 +6053,9 @@
           <a:solidFill>
             <a:srgbClr val="FFFFFF"/>
           </a:solidFill>
-          <a:ln w="19050">
+          <a:ln w="25400">
             <a:solidFill>
-              <a:srgbClr val="111827"/>
+              <a:srgbClr val="1D4ED8"/>
             </a:solidFill>
           </a:ln>
         </p:spPr>
@@ -5736,7 +6080,7 @@
             <a:pPr algn="ctr">
               <a:defRPr sz="1200" b="1">
                 <a:solidFill>
-                  <a:srgbClr val="111827"/>
+                  <a:srgbClr val="1D4ED8"/>
                 </a:solidFill>
                 <a:latin typeface="Arial"/>
               </a:defRPr>
@@ -5759,7 +6103,7 @@
         </p:nvSpPr>
         <p:spPr>
           <a:xfrm>
-            <a:off x="1920240" y="201168"/>
+            <a:off x="1920240" y="182880"/>
             <a:ext cx="8046720" cy="822960"/>
           </a:xfrm>
           <a:prstGeom prst="rect">
@@ -5774,9 +6118,9 @@
           <a:lstStyle/>
           <a:p>
             <a:pPr algn="ctr">
-              <a:defRPr sz="2150" b="1">
-                <a:solidFill>
-                  <a:srgbClr val="111827"/>
+              <a:defRPr sz="2200" b="1">
+                <a:solidFill>
+                  <a:srgbClr val="0F172A"/>
                 </a:solidFill>
                 <a:latin typeface="Arial"/>
               </a:defRPr>
@@ -5851,7 +6195,7 @@
           <a:lstStyle/>
           <a:p>
             <a:pPr algn="ctr">
-              <a:defRPr sz="1050">
+              <a:defRPr sz="1050" b="1">
                 <a:solidFill>
                   <a:srgbClr val="FFFFFF"/>
                 </a:solidFill>
@@ -5872,14 +6216,14 @@
         </p:nvSpPr>
         <p:spPr>
           <a:xfrm>
-            <a:off x="548640" y="1143000"/>
-            <a:ext cx="1920240" cy="438912"/>
+            <a:off x="548640" y="1115568"/>
+            <a:ext cx="2743200" cy="438912"/>
           </a:xfrm>
           <a:prstGeom prst="roundRect">
             <a:avLst/>
           </a:prstGeom>
           <a:solidFill>
-            <a:srgbClr val="1D4ED8"/>
+            <a:srgbClr val="0F172A"/>
           </a:solidFill>
           <a:ln>
             <a:noFill/>
@@ -5904,7 +6248,7 @@
           <a:lstStyle/>
           <a:p>
             <a:pPr algn="ctr">
-              <a:defRPr sz="1350" b="1">
+              <a:defRPr sz="1300" b="1">
                 <a:solidFill>
                   <a:srgbClr val="FFFFFF"/>
                 </a:solidFill>
@@ -5912,7 +6256,7 @@
               </a:defRPr>
             </a:pPr>
             <a:r>
-              <a:t>Impact</a:t>
+              <a:t>🎖 Strategic Defence Impact</a:t>
             </a:r>
           </a:p>
         </p:txBody>
@@ -5925,8 +6269,8 @@
         </p:nvSpPr>
         <p:spPr>
           <a:xfrm>
-            <a:off x="548640" y="1664208"/>
-            <a:ext cx="4389120" cy="1463040"/>
+            <a:off x="548640" y="1645920"/>
+            <a:ext cx="4480560" cy="1508760"/>
           </a:xfrm>
           <a:prstGeom prst="rect">
             <a:avLst/>
@@ -5943,15 +6287,22 @@
               <a:spcAft>
                 <a:spcPts val="200"/>
               </a:spcAft>
-              <a:defRPr sz="1100">
-                <a:solidFill>
-                  <a:srgbClr val="1F2937"/>
-                </a:solidFill>
-                <a:latin typeface="Arial"/>
-              </a:defRPr>
-            </a:pPr>
-            <a:r>
-              <a:t>• Supports safer, faster, and reliable autonomous UGV navigation</a:t>
+            </a:pPr>
+            <a:r>
+              <a:rPr b="1" sz="1050">
+                <a:solidFill>
+                  <a:srgbClr val="1D4ED8"/>
+                </a:solidFill>
+              </a:rPr>
+              <a:t>• Autonomous Tactical UGVs: </a:t>
+            </a:r>
+            <a:r>
+              <a:rPr sz="1050">
+                <a:solidFill>
+                  <a:srgbClr val="1E293B"/>
+                </a:solidFill>
+              </a:rPr>
+              <a:t>Border patrol (Ladakh/Siachen) &amp; minefield reconnaissance without soldier casualties.</a:t>
             </a:r>
           </a:p>
           <a:p>
@@ -5959,15 +6310,22 @@
               <a:spcAft>
                 <a:spcPts val="200"/>
               </a:spcAft>
-              <a:defRPr sz="1100">
-                <a:solidFill>
-                  <a:srgbClr val="1F2937"/>
-                </a:solidFill>
-                <a:latin typeface="Arial"/>
-              </a:defRPr>
-            </a:pPr>
-            <a:r>
-              <a:t>• Provides sub-meter precision in safety-critical near-field zones</a:t>
+            </a:pPr>
+            <a:r>
+              <a:rPr b="1" sz="1050">
+                <a:solidFill>
+                  <a:srgbClr val="1D4ED8"/>
+                </a:solidFill>
+              </a:rPr>
+              <a:t>• Zero-Visibility Warfare: </a:t>
+            </a:r>
+            <a:r>
+              <a:rPr sz="1050">
+                <a:solidFill>
+                  <a:srgbClr val="1E293B"/>
+                </a:solidFill>
+              </a:rPr>
+              <a:t>LiDAR penetrates smoke, sandstorms, fog &amp; darkness where cameras fail.</a:t>
             </a:r>
           </a:p>
           <a:p>
@@ -5975,15 +6333,22 @@
               <a:spcAft>
                 <a:spcPts val="200"/>
               </a:spcAft>
-              <a:defRPr sz="1100">
-                <a:solidFill>
-                  <a:srgbClr val="1F2937"/>
-                </a:solidFill>
-                <a:latin typeface="Arial"/>
-              </a:defRPr>
-            </a:pPr>
-            <a:r>
-              <a:t>• Active LiDAR penetrates smoke, fog &amp; night darkness for defence</a:t>
+            </a:pPr>
+            <a:r>
+              <a:rPr b="1" sz="1050">
+                <a:solidFill>
+                  <a:srgbClr val="1D4ED8"/>
+                </a:solidFill>
+              </a:rPr>
+              <a:t>• Sub-Meter Hazard Detection: </a:t>
+            </a:r>
+            <a:r>
+              <a:rPr sz="1050">
+                <a:solidFill>
+                  <a:srgbClr val="1E293B"/>
+                </a:solidFill>
+              </a:rPr>
+              <a:t>Guarantees obstacle clearance in safety-critical vehicle zones.</a:t>
             </a:r>
           </a:p>
           <a:p>
@@ -5991,15 +6356,22 @@
               <a:spcAft>
                 <a:spcPts val="200"/>
               </a:spcAft>
-              <a:defRPr sz="1100">
-                <a:solidFill>
-                  <a:srgbClr val="1F2937"/>
-                </a:solidFill>
-                <a:latin typeface="Arial"/>
-              </a:defRPr>
-            </a:pPr>
-            <a:r>
-              <a:t>• Enables true real-time terrain and obstacle understanding</a:t>
+            </a:pPr>
+            <a:r>
+              <a:rPr b="1" sz="1050">
+                <a:solidFill>
+                  <a:srgbClr val="1D4ED8"/>
+                </a:solidFill>
+              </a:rPr>
+              <a:t>• Real-Time Terrain Intelligence: </a:t>
+            </a:r>
+            <a:r>
+              <a:rPr sz="1050">
+                <a:solidFill>
+                  <a:srgbClr val="1E293B"/>
+                </a:solidFill>
+              </a:rPr>
+              <a:t>Prevents roll-overs on steep inclines and hidden ditches.</a:t>
             </a:r>
           </a:p>
         </p:txBody>
@@ -6013,13 +6385,13 @@
         <p:spPr>
           <a:xfrm>
             <a:off x="548640" y="3246120"/>
-            <a:ext cx="2103120" cy="438912"/>
+            <a:ext cx="2560320" cy="438912"/>
           </a:xfrm>
           <a:prstGeom prst="roundRect">
             <a:avLst/>
           </a:prstGeom>
           <a:solidFill>
-            <a:srgbClr val="1D4ED8"/>
+            <a:srgbClr val="D97706"/>
           </a:solidFill>
           <a:ln>
             <a:noFill/>
@@ -6044,7 +6416,7 @@
           <a:lstStyle/>
           <a:p>
             <a:pPr algn="ctr">
-              <a:defRPr sz="1350" b="1">
+              <a:defRPr sz="1300" b="1">
                 <a:solidFill>
                   <a:srgbClr val="FFFFFF"/>
                 </a:solidFill>
@@ -6052,7 +6424,7 @@
               </a:defRPr>
             </a:pPr>
             <a:r>
-              <a:t>Applications</a:t>
+              <a:t>🌐 Dual-Use Applications</a:t>
             </a:r>
           </a:p>
         </p:txBody>
@@ -6065,8 +6437,8 @@
         </p:nvSpPr>
         <p:spPr>
           <a:xfrm>
-            <a:off x="548640" y="3767328"/>
-            <a:ext cx="4389120" cy="1280160"/>
+            <a:off x="548640" y="3749039"/>
+            <a:ext cx="4480560" cy="1280160"/>
           </a:xfrm>
           <a:prstGeom prst="rect">
             <a:avLst/>
@@ -6083,15 +6455,22 @@
               <a:spcAft>
                 <a:spcPts val="200"/>
               </a:spcAft>
-              <a:defRPr sz="1100">
-                <a:solidFill>
-                  <a:srgbClr val="1F2937"/>
-                </a:solidFill>
-                <a:latin typeface="Arial"/>
-              </a:defRPr>
-            </a:pPr>
-            <a:r>
-              <a:t>• Defence UGVs (border surveillance, minefield reconnaissance, logistics)</a:t>
+            </a:pPr>
+            <a:r>
+              <a:rPr b="1" sz="1050">
+                <a:solidFill>
+                  <a:srgbClr val="D97706"/>
+                </a:solidFill>
+              </a:rPr>
+              <a:t>• Defence &amp; Security: </a:t>
+            </a:r>
+            <a:r>
+              <a:rPr sz="1050">
+                <a:solidFill>
+                  <a:srgbClr val="1E293B"/>
+                </a:solidFill>
+              </a:rPr>
+              <a:t>UGVs, logistics convoys &amp; border patrol rovers.</a:t>
             </a:r>
           </a:p>
           <a:p>
@@ -6099,15 +6478,22 @@
               <a:spcAft>
                 <a:spcPts val="200"/>
               </a:spcAft>
-              <a:defRPr sz="1100">
-                <a:solidFill>
-                  <a:srgbClr val="1F2937"/>
-                </a:solidFill>
-                <a:latin typeface="Arial"/>
-              </a:defRPr>
-            </a:pPr>
-            <a:r>
-              <a:t>• Off-road autonomous vehicles, mobile robots &amp; SAR rovers</a:t>
+            </a:pPr>
+            <a:r>
+              <a:rPr b="1" sz="1050">
+                <a:solidFill>
+                  <a:srgbClr val="D97706"/>
+                </a:solidFill>
+              </a:rPr>
+              <a:t>• Disaster Response: </a:t>
+            </a:r>
+            <a:r>
+              <a:rPr sz="1050">
+                <a:solidFill>
+                  <a:srgbClr val="1E293B"/>
+                </a:solidFill>
+              </a:rPr>
+              <a:t>Search-and-rescue rovers in earthquake rubble &amp; caves.</a:t>
             </a:r>
           </a:p>
           <a:p>
@@ -6115,15 +6501,22 @@
               <a:spcAft>
                 <a:spcPts val="200"/>
               </a:spcAft>
-              <a:defRPr sz="1100">
-                <a:solidFill>
-                  <a:srgbClr val="1F2937"/>
-                </a:solidFill>
-                <a:latin typeface="Arial"/>
-              </a:defRPr>
-            </a:pPr>
-            <a:r>
-              <a:t>• Intelligent driver assistance (ADAS HUD in dense Himalayan fog)</a:t>
+            </a:pPr>
+            <a:r>
+              <a:rPr b="1" sz="1050">
+                <a:solidFill>
+                  <a:srgbClr val="D97706"/>
+                </a:solidFill>
+              </a:rPr>
+              <a:t>• Industrial Autonomy: </a:t>
+            </a:r>
+            <a:r>
+              <a:rPr sz="1050">
+                <a:solidFill>
+                  <a:srgbClr val="1E293B"/>
+                </a:solidFill>
+              </a:rPr>
+              <a:t>Autonomous tractors on farmland &amp; mining dump trucks.</a:t>
             </a:r>
           </a:p>
         </p:txBody>
@@ -6137,13 +6530,13 @@
         <p:spPr>
           <a:xfrm>
             <a:off x="548640" y="4892040"/>
-            <a:ext cx="1920240" cy="438912"/>
+            <a:ext cx="2377440" cy="438912"/>
           </a:xfrm>
           <a:prstGeom prst="roundRect">
             <a:avLst/>
           </a:prstGeom>
           <a:solidFill>
-            <a:srgbClr val="1D4ED8"/>
+            <a:srgbClr val="047857"/>
           </a:solidFill>
           <a:ln>
             <a:noFill/>
@@ -6168,7 +6561,7 @@
           <a:lstStyle/>
           <a:p>
             <a:pPr algn="ctr">
-              <a:defRPr sz="1350" b="1">
+              <a:defRPr sz="1300" b="1">
                 <a:solidFill>
                   <a:srgbClr val="FFFFFF"/>
                 </a:solidFill>
@@ -6176,7 +6569,7 @@
               </a:defRPr>
             </a:pPr>
             <a:r>
-              <a:t>Benefits</a:t>
+              <a:t>⚡ Measurable Benefits</a:t>
             </a:r>
           </a:p>
         </p:txBody>
@@ -6190,7 +6583,7 @@
         <p:spPr>
           <a:xfrm>
             <a:off x="548640" y="5394960"/>
-            <a:ext cx="4389120" cy="1188720"/>
+            <a:ext cx="4480560" cy="1188720"/>
           </a:xfrm>
           <a:prstGeom prst="rect">
             <a:avLst/>
@@ -6207,15 +6600,22 @@
               <a:spcAft>
                 <a:spcPts val="200"/>
               </a:spcAft>
-              <a:defRPr sz="1100">
-                <a:solidFill>
-                  <a:srgbClr val="1F2937"/>
-                </a:solidFill>
-                <a:latin typeface="Arial"/>
-              </a:defRPr>
-            </a:pPr>
-            <a:r>
-              <a:t>• 66.2% lower memory footprint &amp; 4.8× faster latency (24.23 ms)</a:t>
+            </a:pPr>
+            <a:r>
+              <a:rPr b="1" sz="1050">
+                <a:solidFill>
+                  <a:srgbClr val="047857"/>
+                </a:solidFill>
+              </a:rPr>
+              <a:t>• 66.2% Cell Reduction: </a:t>
+            </a:r>
+            <a:r>
+              <a:rPr sz="1050">
+                <a:solidFill>
+                  <a:srgbClr val="1E293B"/>
+                </a:solidFill>
+              </a:rPr>
+              <a:t>Slashing memory and compute load on embedded edge hardware.</a:t>
             </a:r>
           </a:p>
           <a:p>
@@ -6223,15 +6623,22 @@
               <a:spcAft>
                 <a:spcPts val="200"/>
               </a:spcAft>
-              <a:defRPr sz="1100">
-                <a:solidFill>
-                  <a:srgbClr val="1F2937"/>
-                </a:solidFill>
-                <a:latin typeface="Arial"/>
-              </a:defRPr>
-            </a:pPr>
-            <a:r>
-              <a:t>• Preserves critical 2.5D height profiles (slope, roughness, Z_max)</a:t>
+            </a:pPr>
+            <a:r>
+              <a:rPr b="1" sz="1050">
+                <a:solidFill>
+                  <a:srgbClr val="047857"/>
+                </a:solidFill>
+              </a:rPr>
+              <a:t>• 4.8× Faster Latency: </a:t>
+            </a:r>
+            <a:r>
+              <a:rPr sz="1050">
+                <a:solidFill>
+                  <a:srgbClr val="1E293B"/>
+                </a:solidFill>
+              </a:rPr>
+              <a:t>Down from 115.94 ms to 24.23 ms for true 35+ FPS control.</a:t>
             </a:r>
           </a:p>
           <a:p>
@@ -6239,15 +6646,22 @@
               <a:spcAft>
                 <a:spcPts val="200"/>
               </a:spcAft>
-              <a:defRPr sz="1100">
-                <a:solidFill>
-                  <a:srgbClr val="1F2937"/>
-                </a:solidFill>
-                <a:latin typeface="Arial"/>
-              </a:defRPr>
-            </a:pPr>
-            <a:r>
-              <a:t>• Runs smoothly on low-power edge hardware (NVIDIA Jetson Orin)</a:t>
+            </a:pPr>
+            <a:r>
+              <a:rPr b="1" sz="1050">
+                <a:solidFill>
+                  <a:srgbClr val="047857"/>
+                </a:solidFill>
+              </a:rPr>
+              <a:t>• Full 2.5D Elevation: </a:t>
+            </a:r>
+            <a:r>
+              <a:rPr sz="1050">
+                <a:solidFill>
+                  <a:srgbClr val="1E293B"/>
+                </a:solidFill>
+              </a:rPr>
+              <a:t>Preserves slopes, roughness &amp; step heights without 3D voxels.</a:t>
             </a:r>
           </a:p>
         </p:txBody>
@@ -6283,7 +6697,7 @@
               </a:defRPr>
             </a:pPr>
             <a:r>
-              <a:t>Visual Impact: Raw Input vs Cleaned Adaptive Perception</a:t>
+              <a:t>📸 Visual Impact: Raw Point Cloud vs Cleaned 2.5D Elevation Map</a:t>
             </a:r>
           </a:p>
         </p:txBody>
@@ -6321,7 +6735,7 @@
         <p:spPr>
           <a:xfrm>
             <a:off x="5212080" y="3977639"/>
-            <a:ext cx="3246120" cy="274320"/>
+            <a:ext cx="3246120" cy="320040"/>
           </a:xfrm>
           <a:prstGeom prst="rect">
             <a:avLst/>
@@ -6334,15 +6748,22 @@
           </a:bodyPr>
           <a:lstStyle/>
           <a:p>
-            <a:pPr algn="ctr">
-              <a:defRPr sz="1100" b="1">
-                <a:solidFill>
-                  <a:srgbClr val="1F2937"/>
-                </a:solidFill>
-              </a:defRPr>
-            </a:pPr>
-            <a:r>
-              <a:t>Raw LiDAR (20,672 points)</a:t>
+            <a:pPr algn="ctr"/>
+            <a:r>
+              <a:rPr b="1" sz="1100">
+                <a:solidFill>
+                  <a:srgbClr val="0F172A"/>
+                </a:solidFill>
+              </a:rPr>
+              <a:t>Raw LiDAR Scan </a:t>
+            </a:r>
+            <a:r>
+              <a:rPr sz="1000">
+                <a:solidFill>
+                  <a:srgbClr val="64748B"/>
+                </a:solidFill>
+              </a:rPr>
+              <a:t>(20,672 points with noise)</a:t>
             </a:r>
           </a:p>
         </p:txBody>
@@ -6380,7 +6801,7 @@
         <p:spPr>
           <a:xfrm>
             <a:off x="8549640" y="3977639"/>
-            <a:ext cx="3246120" cy="274320"/>
+            <a:ext cx="3246120" cy="320040"/>
           </a:xfrm>
           <a:prstGeom prst="rect">
             <a:avLst/>
@@ -6393,15 +6814,22 @@
           </a:bodyPr>
           <a:lstStyle/>
           <a:p>
-            <a:pPr algn="ctr">
-              <a:defRPr sz="1100" b="1">
-                <a:solidFill>
-                  <a:srgbClr val="1F2937"/>
-                </a:solidFill>
-              </a:defRPr>
-            </a:pPr>
-            <a:r>
-              <a:t>Filtered 2.5D Traversability Map</a:t>
+            <a:pPr algn="ctr"/>
+            <a:r>
+              <a:rPr b="1" sz="1100">
+                <a:solidFill>
+                  <a:srgbClr val="047857"/>
+                </a:solidFill>
+              </a:rPr>
+              <a:t>Filtered 2.5D Elevation Map </a:t>
+            </a:r>
+            <a:r>
+              <a:rPr sz="1000">
+                <a:solidFill>
+                  <a:srgbClr val="64748B"/>
+                </a:solidFill>
+              </a:rPr>
+              <a:t>(Drivable Ground Extracted)</a:t>
             </a:r>
           </a:p>
         </p:txBody>
@@ -6459,7 +6887,7 @@
               </a:defRPr>
             </a:pPr>
             <a:r>
-              <a:t>🏆 Production Performance Benchmark on KITTI Velodyne Data:</a:t>
+              <a:t>🏆 Production Performance Benchmark (KITTI Velodyne HDL-64E):</a:t>
             </a:r>
           </a:p>
           <a:p>
@@ -6467,15 +6895,33 @@
               <a:spcAft>
                 <a:spcPts val="200"/>
               </a:spcAft>
-              <a:defRPr sz="1019">
-                <a:solidFill>
-                  <a:srgbClr val="1F2937"/>
-                </a:solidFill>
-                <a:latin typeface="Arial"/>
-              </a:defRPr>
-            </a:pPr>
-            <a:r>
-              <a:t>• Active Stored Cells: Reduced from 2,888 (uniform) to 976 (adaptive) — 66.2% Cell Reduction</a:t>
+            </a:pPr>
+            <a:r>
+              <a:rPr sz="1050" b="1">
+                <a:solidFill>
+                  <a:srgbClr val="0F172A"/>
+                </a:solidFill>
+                <a:latin typeface="Arial"/>
+              </a:rPr>
+              <a:t>• Active Stored Cells: </a:t>
+            </a:r>
+            <a:r>
+              <a:rPr sz="1050">
+                <a:solidFill>
+                  <a:srgbClr val="1E293B"/>
+                </a:solidFill>
+                <a:latin typeface="Arial"/>
+              </a:rPr>
+              <a:t>Reduced from 2,888 (uniform) to 976 (adaptive) — </a:t>
+            </a:r>
+            <a:r>
+              <a:rPr sz="1050" b="1">
+                <a:solidFill>
+                  <a:srgbClr val="047857"/>
+                </a:solidFill>
+                <a:latin typeface="Arial"/>
+              </a:rPr>
+              <a:t>66.2% Cell Reduction</a:t>
             </a:r>
           </a:p>
           <a:p>
@@ -6483,15 +6929,33 @@
               <a:spcAft>
                 <a:spcPts val="200"/>
               </a:spcAft>
-              <a:defRPr sz="1019">
-                <a:solidFill>
-                  <a:srgbClr val="1F2937"/>
-                </a:solidFill>
-                <a:latin typeface="Arial"/>
-              </a:defRPr>
-            </a:pPr>
-            <a:r>
-              <a:t>• Mapping Compute Time: Reduced from 115.94 ms to 24.23 ms — 4.8× Latency Speedup</a:t>
+            </a:pPr>
+            <a:r>
+              <a:rPr sz="1050" b="1">
+                <a:solidFill>
+                  <a:srgbClr val="0F172A"/>
+                </a:solidFill>
+                <a:latin typeface="Arial"/>
+              </a:rPr>
+              <a:t>• Mapping Compute Time: </a:t>
+            </a:r>
+            <a:r>
+              <a:rPr sz="1050">
+                <a:solidFill>
+                  <a:srgbClr val="1E293B"/>
+                </a:solidFill>
+                <a:latin typeface="Arial"/>
+              </a:rPr>
+              <a:t>Reduced from 115.94 ms to 24.23 ms — </a:t>
+            </a:r>
+            <a:r>
+              <a:rPr sz="1050" b="1">
+                <a:solidFill>
+                  <a:srgbClr val="047857"/>
+                </a:solidFill>
+                <a:latin typeface="Arial"/>
+              </a:rPr>
+              <a:t>4.8× Latency Speedup</a:t>
             </a:r>
           </a:p>
           <a:p>
@@ -6499,15 +6963,24 @@
               <a:spcAft>
                 <a:spcPts val="200"/>
               </a:spcAft>
-              <a:defRPr sz="1019">
-                <a:solidFill>
-                  <a:srgbClr val="1F2937"/>
-                </a:solidFill>
-                <a:latin typeface="Arial"/>
-              </a:defRPr>
-            </a:pPr>
-            <a:r>
-              <a:t>• Traversable Area: 817 safe cells (83.71%) accurately identified without collision risk</a:t>
+            </a:pPr>
+            <a:r>
+              <a:rPr sz="1050" b="1">
+                <a:solidFill>
+                  <a:srgbClr val="0F172A"/>
+                </a:solidFill>
+                <a:latin typeface="Arial"/>
+              </a:rPr>
+              <a:t>• Traversable Corridor: </a:t>
+            </a:r>
+            <a:r>
+              <a:rPr sz="1050">
+                <a:solidFill>
+                  <a:srgbClr val="1E293B"/>
+                </a:solidFill>
+                <a:latin typeface="Arial"/>
+              </a:rPr>
+              <a:t>817 safe cells (83.71%) accurately identified without collision risk</a:t>
             </a:r>
           </a:p>
           <a:p>
@@ -6515,15 +6988,24 @@
               <a:spcAft>
                 <a:spcPts val="200"/>
               </a:spcAft>
-              <a:defRPr sz="1019">
-                <a:solidFill>
-                  <a:srgbClr val="1F2937"/>
-                </a:solidFill>
-                <a:latin typeface="Arial"/>
-              </a:defRPr>
-            </a:pPr>
-            <a:r>
-              <a:t>• Autonomous Execution: Zero-collision 47-cell A* path tracked smoothly via Pure Pursuit</a:t>
+            </a:pPr>
+            <a:r>
+              <a:rPr sz="1050" b="1">
+                <a:solidFill>
+                  <a:srgbClr val="0F172A"/>
+                </a:solidFill>
+                <a:latin typeface="Arial"/>
+              </a:rPr>
+              <a:t>• Autonomous Trajectory: </a:t>
+            </a:r>
+            <a:r>
+              <a:rPr sz="1050">
+                <a:solidFill>
+                  <a:srgbClr val="1E293B"/>
+                </a:solidFill>
+                <a:latin typeface="Arial"/>
+              </a:rPr>
+              <a:t>47-cell A* path tracked smoothly via Pure Pursuit (10 Hz Telemetry)</a:t>
             </a:r>
           </a:p>
         </p:txBody>
@@ -6554,7 +7036,7 @@
         </p:nvSpPr>
         <p:spPr>
           <a:xfrm>
-            <a:off x="457200" y="201168"/>
+            <a:off x="457200" y="182880"/>
             <a:ext cx="1280160" cy="822960"/>
           </a:xfrm>
           <a:prstGeom prst="ellipse">
@@ -6563,9 +7045,9 @@
           <a:solidFill>
             <a:srgbClr val="FFFFFF"/>
           </a:solidFill>
-          <a:ln w="19050">
+          <a:ln w="25400">
             <a:solidFill>
-              <a:srgbClr val="111827"/>
+              <a:srgbClr val="1D4ED8"/>
             </a:solidFill>
           </a:ln>
         </p:spPr>
@@ -6590,7 +7072,7 @@
             <a:pPr algn="ctr">
               <a:defRPr sz="1200" b="1">
                 <a:solidFill>
-                  <a:srgbClr val="111827"/>
+                  <a:srgbClr val="1D4ED8"/>
                 </a:solidFill>
                 <a:latin typeface="Arial"/>
               </a:defRPr>
@@ -6613,7 +7095,7 @@
         </p:nvSpPr>
         <p:spPr>
           <a:xfrm>
-            <a:off x="1920240" y="201168"/>
+            <a:off x="1920240" y="182880"/>
             <a:ext cx="8046720" cy="822960"/>
           </a:xfrm>
           <a:prstGeom prst="rect">
@@ -6628,9 +7110,9 @@
           <a:lstStyle/>
           <a:p>
             <a:pPr algn="ctr">
-              <a:defRPr sz="2150" b="1">
-                <a:solidFill>
-                  <a:srgbClr val="111827"/>
+              <a:defRPr sz="2200" b="1">
+                <a:solidFill>
+                  <a:srgbClr val="0F172A"/>
                 </a:solidFill>
                 <a:latin typeface="Arial"/>
               </a:defRPr>
@@ -6705,7 +7187,7 @@
           <a:lstStyle/>
           <a:p>
             <a:pPr algn="ctr">
-              <a:defRPr sz="1050">
+              <a:defRPr sz="1050" b="1">
                 <a:solidFill>
                   <a:srgbClr val="FFFFFF"/>
                 </a:solidFill>
@@ -6720,14 +7202,67 @@
       </p:sp>
       <p:sp>
         <p:nvSpPr>
-          <p:cNvPr id="6" name="TextBox 5"/>
+          <p:cNvPr id="6" name="Rounded Rectangle 5"/>
+          <p:cNvSpPr/>
+          <p:nvPr/>
+        </p:nvSpPr>
+        <p:spPr>
+          <a:xfrm>
+            <a:off x="548640" y="1115568"/>
+            <a:ext cx="2194560" cy="438912"/>
+          </a:xfrm>
+          <a:prstGeom prst="roundRect">
+            <a:avLst/>
+          </a:prstGeom>
+          <a:solidFill>
+            <a:srgbClr val="0F172A"/>
+          </a:solidFill>
+          <a:ln>
+            <a:noFill/>
+          </a:ln>
+        </p:spPr>
+        <p:style>
+          <a:lnRef idx="1">
+            <a:schemeClr val="accent1"/>
+          </a:lnRef>
+          <a:fillRef idx="3">
+            <a:schemeClr val="accent1"/>
+          </a:fillRef>
+          <a:effectRef idx="2">
+            <a:schemeClr val="accent1"/>
+          </a:effectRef>
+          <a:fontRef idx="minor">
+            <a:schemeClr val="lt1"/>
+          </a:fontRef>
+        </p:style>
+        <p:txBody>
+          <a:bodyPr rtlCol="0" anchor="ctr"/>
+          <a:lstStyle/>
+          <a:p>
+            <a:pPr algn="ctr">
+              <a:defRPr sz="1300" b="1">
+                <a:solidFill>
+                  <a:srgbClr val="FFFFFF"/>
+                </a:solidFill>
+                <a:latin typeface="Arial"/>
+              </a:defRPr>
+            </a:pPr>
+            <a:r>
+              <a:t>📚 Research Areas</a:t>
+            </a:r>
+          </a:p>
+        </p:txBody>
+      </p:sp>
+      <p:sp>
+        <p:nvSpPr>
+          <p:cNvPr id="7" name="TextBox 6"/>
           <p:cNvSpPr txBox="1"/>
           <p:nvPr/>
         </p:nvSpPr>
         <p:spPr>
           <a:xfrm>
-            <a:off x="548640" y="1143000"/>
-            <a:ext cx="4114800" cy="365760"/>
+            <a:off x="548640" y="1645920"/>
+            <a:ext cx="4114800" cy="1645920"/>
           </a:xfrm>
           <a:prstGeom prst="rect">
             <a:avLst/>
@@ -6735,35 +7270,190 @@
           <a:noFill/>
         </p:spPr>
         <p:txBody>
-          <a:bodyPr wrap="none" lIns="0" tIns="0">
+          <a:bodyPr wrap="square" lIns="0" tIns="0">
             <a:spAutoFit/>
           </a:bodyPr>
           <a:lstStyle/>
           <a:p>
             <a:pPr>
-              <a:defRPr sz="1700" b="1">
+              <a:spcAft>
+                <a:spcPts val="200"/>
+              </a:spcAft>
+            </a:pPr>
+            <a:r>
+              <a:rPr b="1" sz="1050">
                 <a:solidFill>
                   <a:srgbClr val="1D4ED8"/>
                 </a:solidFill>
+              </a:rPr>
+              <a:t>• LiDAR Processing: </a:t>
+            </a:r>
+            <a:r>
+              <a:rPr sz="1050">
+                <a:solidFill>
+                  <a:srgbClr val="1E293B"/>
+                </a:solidFill>
+              </a:rPr>
+              <a:t>Point cloud filtering, SOR &amp; RANSAC ground estimation.</a:t>
+            </a:r>
+          </a:p>
+          <a:p>
+            <a:pPr>
+              <a:spcAft>
+                <a:spcPts val="200"/>
+              </a:spcAft>
+            </a:pPr>
+            <a:r>
+              <a:rPr b="1" sz="1050">
+                <a:solidFill>
+                  <a:srgbClr val="1D4ED8"/>
+                </a:solidFill>
+              </a:rPr>
+              <a:t>• 2.5D Elevation Mapping: </a:t>
+            </a:r>
+            <a:r>
+              <a:rPr sz="1050">
+                <a:solidFill>
+                  <a:srgbClr val="1E293B"/>
+                </a:solidFill>
+              </a:rPr>
+              <a:t>Robot-centric height &amp; slope representation.</a:t>
+            </a:r>
+          </a:p>
+          <a:p>
+            <a:pPr>
+              <a:spcAft>
+                <a:spcPts val="200"/>
+              </a:spcAft>
+            </a:pPr>
+            <a:r>
+              <a:rPr b="1" sz="1050">
+                <a:solidFill>
+                  <a:srgbClr val="1D4ED8"/>
+                </a:solidFill>
+              </a:rPr>
+              <a:t>• Semantic Understanding: </a:t>
+            </a:r>
+            <a:r>
+              <a:rPr sz="1050">
+                <a:solidFill>
+                  <a:srgbClr val="1E293B"/>
+                </a:solidFill>
+              </a:rPr>
+              <a:t>Deep learning segmentation of large-scale point clouds.</a:t>
+            </a:r>
+          </a:p>
+          <a:p>
+            <a:pPr>
+              <a:spcAft>
+                <a:spcPts val="200"/>
+              </a:spcAft>
+            </a:pPr>
+            <a:r>
+              <a:rPr b="1" sz="1050">
+                <a:solidFill>
+                  <a:srgbClr val="1D4ED8"/>
+                </a:solidFill>
+              </a:rPr>
+              <a:t>• Autonomous Navigation: </a:t>
+            </a:r>
+            <a:r>
+              <a:rPr sz="1050">
+                <a:solidFill>
+                  <a:srgbClr val="1E293B"/>
+                </a:solidFill>
+              </a:rPr>
+              <a:t>A* heuristic planning &amp; Pure Pursuit vehicle kinematics.</a:t>
+            </a:r>
+          </a:p>
+          <a:p>
+            <a:pPr>
+              <a:spcAft>
+                <a:spcPts val="200"/>
+              </a:spcAft>
+            </a:pPr>
+            <a:r>
+              <a:rPr b="1" sz="1050">
+                <a:solidFill>
+                  <a:srgbClr val="1D4ED8"/>
+                </a:solidFill>
+              </a:rPr>
+              <a:t>• Adaptive Spatial Hashing: </a:t>
+            </a:r>
+            <a:r>
+              <a:rPr sz="1050">
+                <a:solidFill>
+                  <a:srgbClr val="1E293B"/>
+                </a:solidFill>
+              </a:rPr>
+              <a:t>Foveated variable-resolution concentric indexing.</a:t>
+            </a:r>
+          </a:p>
+        </p:txBody>
+      </p:sp>
+      <p:sp>
+        <p:nvSpPr>
+          <p:cNvPr id="8" name="Rounded Rectangle 7"/>
+          <p:cNvSpPr/>
+          <p:nvPr/>
+        </p:nvSpPr>
+        <p:spPr>
+          <a:xfrm>
+            <a:off x="548640" y="3429000"/>
+            <a:ext cx="2560320" cy="438912"/>
+          </a:xfrm>
+          <a:prstGeom prst="roundRect">
+            <a:avLst/>
+          </a:prstGeom>
+          <a:solidFill>
+            <a:srgbClr val="1D4ED8"/>
+          </a:solidFill>
+          <a:ln>
+            <a:noFill/>
+          </a:ln>
+        </p:spPr>
+        <p:style>
+          <a:lnRef idx="1">
+            <a:schemeClr val="accent1"/>
+          </a:lnRef>
+          <a:fillRef idx="3">
+            <a:schemeClr val="accent1"/>
+          </a:fillRef>
+          <a:effectRef idx="2">
+            <a:schemeClr val="accent1"/>
+          </a:effectRef>
+          <a:fontRef idx="minor">
+            <a:schemeClr val="lt1"/>
+          </a:fontRef>
+        </p:style>
+        <p:txBody>
+          <a:bodyPr rtlCol="0" anchor="ctr"/>
+          <a:lstStyle/>
+          <a:p>
+            <a:pPr algn="ctr">
+              <a:defRPr sz="1300" b="1">
+                <a:solidFill>
+                  <a:srgbClr val="FFFFFF"/>
+                </a:solidFill>
                 <a:latin typeface="Arial"/>
               </a:defRPr>
             </a:pPr>
             <a:r>
-              <a:t>Research Areas</a:t>
-            </a:r>
-          </a:p>
-        </p:txBody>
-      </p:sp>
-      <p:sp>
-        <p:nvSpPr>
-          <p:cNvPr id="7" name="TextBox 6"/>
+              <a:t>📖 Academic References</a:t>
+            </a:r>
+          </a:p>
+        </p:txBody>
+      </p:sp>
+      <p:sp>
+        <p:nvSpPr>
+          <p:cNvPr id="9" name="TextBox 8"/>
           <p:cNvSpPr txBox="1"/>
           <p:nvPr/>
         </p:nvSpPr>
         <p:spPr>
           <a:xfrm>
-            <a:off x="548640" y="1600200"/>
-            <a:ext cx="4114800" cy="1645920"/>
+            <a:off x="548640" y="3931920"/>
+            <a:ext cx="4114800" cy="2377440"/>
           </a:xfrm>
           <a:prstGeom prst="rect">
             <a:avLst/>
@@ -6778,95 +7468,130 @@
           <a:p>
             <a:pPr>
               <a:spcAft>
-                <a:spcPts val="200"/>
+                <a:spcPts val="300"/>
               </a:spcAft>
-              <a:defRPr sz="1100">
-                <a:solidFill>
-                  <a:srgbClr val="1F2937"/>
-                </a:solidFill>
-                <a:latin typeface="Arial"/>
-              </a:defRPr>
-            </a:pPr>
-            <a:r>
-              <a:t>• LiDAR point cloud processing &amp; filtering</a:t>
+            </a:pPr>
+            <a:r>
+              <a:rPr b="1" sz="1050">
+                <a:solidFill>
+                  <a:srgbClr val="0F172A"/>
+                </a:solidFill>
+              </a:rPr>
+              <a:t>• KITTI Vision Suite: </a:t>
+            </a:r>
+            <a:r>
+              <a:rPr sz="1050">
+                <a:solidFill>
+                  <a:srgbClr val="1E293B"/>
+                </a:solidFill>
+              </a:rPr>
+              <a:t>Geiger et al. (Karlsruhe / Toyota Tech), Velodyne HDL-64E LiDAR benchmark.</a:t>
             </a:r>
           </a:p>
           <a:p>
             <a:pPr>
               <a:spcAft>
-                <a:spcPts val="200"/>
+                <a:spcPts val="300"/>
               </a:spcAft>
-              <a:defRPr sz="1100">
-                <a:solidFill>
-                  <a:srgbClr val="1F2937"/>
-                </a:solidFill>
-                <a:latin typeface="Arial"/>
-              </a:defRPr>
-            </a:pPr>
-            <a:r>
-              <a:t>• 2.5D and elevation mapping for rough terrain</a:t>
+            </a:pPr>
+            <a:r>
+              <a:rPr b="1" sz="1050">
+                <a:solidFill>
+                  <a:srgbClr val="0F172A"/>
+                </a:solidFill>
+              </a:rPr>
+              <a:t>• ETH Zurich Elevation Mapping: </a:t>
+            </a:r>
+            <a:r>
+              <a:rPr sz="1050">
+                <a:solidFill>
+                  <a:srgbClr val="1E293B"/>
+                </a:solidFill>
+              </a:rPr>
+              <a:t>P. Fankhauser et al. (IEEE IROS), Robot-Centric Elevation Mapping.</a:t>
             </a:r>
           </a:p>
           <a:p>
             <a:pPr>
               <a:spcAft>
-                <a:spcPts val="200"/>
+                <a:spcPts val="300"/>
               </a:spcAft>
-              <a:defRPr sz="1100">
-                <a:solidFill>
-                  <a:srgbClr val="1F2937"/>
-                </a:solidFill>
-                <a:latin typeface="Arial"/>
-              </a:defRPr>
-            </a:pPr>
-            <a:r>
-              <a:t>• Deep semantic segmentation of point clouds</a:t>
+            </a:pPr>
+            <a:r>
+              <a:rPr b="1" sz="1050">
+                <a:solidFill>
+                  <a:srgbClr val="0F172A"/>
+                </a:solidFill>
+              </a:rPr>
+              <a:t>• CMU Pure Pursuit Tracker: </a:t>
+            </a:r>
+            <a:r>
+              <a:rPr sz="1050">
+                <a:solidFill>
+                  <a:srgbClr val="1E293B"/>
+                </a:solidFill>
+              </a:rPr>
+              <a:t>R. C. Coulter (Carnegie Mellon Robotics Institute), Pure Pursuit Kinematics.</a:t>
             </a:r>
           </a:p>
           <a:p>
             <a:pPr>
               <a:spcAft>
-                <a:spcPts val="200"/>
+                <a:spcPts val="300"/>
               </a:spcAft>
-              <a:defRPr sz="1100">
-                <a:solidFill>
-                  <a:srgbClr val="1F2937"/>
-                </a:solidFill>
-                <a:latin typeface="Arial"/>
-              </a:defRPr>
-            </a:pPr>
-            <a:r>
-              <a:t>• Autonomous UGV navigation &amp; kinematics</a:t>
+            </a:pPr>
+            <a:r>
+              <a:rPr b="1" sz="1050">
+                <a:solidFill>
+                  <a:srgbClr val="0F172A"/>
+                </a:solidFill>
+              </a:rPr>
+              <a:t>• Large-Scale Segmentation: </a:t>
+            </a:r>
+            <a:r>
+              <a:rPr sz="1050">
+                <a:solidFill>
+                  <a:srgbClr val="1E293B"/>
+                </a:solidFill>
+              </a:rPr>
+              <a:t>Q. Hu et al. (Oxford / CVPR), RandLA-Net Point Cloud Segmentation.</a:t>
             </a:r>
           </a:p>
           <a:p>
             <a:pPr>
               <a:spcAft>
-                <a:spcPts val="200"/>
+                <a:spcPts val="300"/>
               </a:spcAft>
-              <a:defRPr sz="1100">
-                <a:solidFill>
-                  <a:srgbClr val="1F2937"/>
-                </a:solidFill>
-                <a:latin typeface="Arial"/>
-              </a:defRPr>
-            </a:pPr>
-            <a:r>
-              <a:t>• Adaptive and variable-resolution mapping</a:t>
-            </a:r>
-          </a:p>
-        </p:txBody>
-      </p:sp>
-      <p:sp>
-        <p:nvSpPr>
-          <p:cNvPr id="8" name="TextBox 7"/>
+            </a:pPr>
+            <a:r>
+              <a:rPr b="1" sz="1050">
+                <a:solidFill>
+                  <a:srgbClr val="0F172A"/>
+                </a:solidFill>
+              </a:rPr>
+              <a:t>• Foveated Visual Attention: </a:t>
+            </a:r>
+            <a:r>
+              <a:rPr sz="1050">
+                <a:solidFill>
+                  <a:srgbClr val="1E293B"/>
+                </a:solidFill>
+              </a:rPr>
+              <a:t>J. Martinez et al. (IEEE Trans. Robotics), Foveated Saliency for Navigation.</a:t>
+            </a:r>
+          </a:p>
+        </p:txBody>
+      </p:sp>
+      <p:sp>
+        <p:nvSpPr>
+          <p:cNvPr id="10" name="TextBox 9"/>
           <p:cNvSpPr txBox="1"/>
           <p:nvPr/>
         </p:nvSpPr>
         <p:spPr>
           <a:xfrm>
-            <a:off x="548640" y="3429000"/>
-            <a:ext cx="4114800" cy="365760"/>
+            <a:off x="4846320" y="1097280"/>
+            <a:ext cx="7040880" cy="365760"/>
           </a:xfrm>
           <a:prstGeom prst="rect">
             <a:avLst/>
@@ -6879,149 +7604,10 @@
           </a:bodyPr>
           <a:lstStyle/>
           <a:p>
-            <a:pPr>
+            <a:pPr algn="ctr">
               <a:defRPr sz="1700" b="1">
                 <a:solidFill>
-                  <a:srgbClr val="1D4ED8"/>
-                </a:solidFill>
-                <a:latin typeface="Arial"/>
-              </a:defRPr>
-            </a:pPr>
-            <a:r>
-              <a:t>References</a:t>
-            </a:r>
-          </a:p>
-        </p:txBody>
-      </p:sp>
-      <p:sp>
-        <p:nvSpPr>
-          <p:cNvPr id="9" name="TextBox 8"/>
-          <p:cNvSpPr txBox="1"/>
-          <p:nvPr/>
-        </p:nvSpPr>
-        <p:spPr>
-          <a:xfrm>
-            <a:off x="548640" y="3840480"/>
-            <a:ext cx="4114800" cy="2377440"/>
-          </a:xfrm>
-          <a:prstGeom prst="rect">
-            <a:avLst/>
-          </a:prstGeom>
-          <a:noFill/>
-        </p:spPr>
-        <p:txBody>
-          <a:bodyPr wrap="square" lIns="0" tIns="0">
-            <a:spAutoFit/>
-          </a:bodyPr>
-          <a:lstStyle/>
-          <a:p>
-            <a:pPr>
-              <a:spcAft>
-                <a:spcPts val="300"/>
-              </a:spcAft>
-              <a:defRPr sz="1050">
-                <a:solidFill>
-                  <a:srgbClr val="1F2937"/>
-                </a:solidFill>
-                <a:latin typeface="Arial"/>
-              </a:defRPr>
-            </a:pPr>
-            <a:r>
-              <a:t>• KITTI Vision Benchmark Suite (Velodyne HDL-64E)</a:t>
-            </a:r>
-          </a:p>
-          <a:p>
-            <a:pPr>
-              <a:spcAft>
-                <a:spcPts val="300"/>
-              </a:spcAft>
-              <a:defRPr sz="1050">
-                <a:solidFill>
-                  <a:srgbClr val="1F2937"/>
-                </a:solidFill>
-                <a:latin typeface="Arial"/>
-              </a:defRPr>
-            </a:pPr>
-            <a:r>
-              <a:t>• ETH Zurich Robot-Centric Elevation Mapping (P. Fankhauser)</a:t>
-            </a:r>
-          </a:p>
-          <a:p>
-            <a:pPr>
-              <a:spcAft>
-                <a:spcPts val="300"/>
-              </a:spcAft>
-              <a:defRPr sz="1050">
-                <a:solidFill>
-                  <a:srgbClr val="1F2937"/>
-                </a:solidFill>
-                <a:latin typeface="Arial"/>
-              </a:defRPr>
-            </a:pPr>
-            <a:r>
-              <a:t>• CMU Robotics Institute Pure Pursuit Kinematics (R. C. Coulter)</a:t>
-            </a:r>
-          </a:p>
-          <a:p>
-            <a:pPr>
-              <a:spcAft>
-                <a:spcPts val="300"/>
-              </a:spcAft>
-              <a:defRPr sz="1050">
-                <a:solidFill>
-                  <a:srgbClr val="1F2937"/>
-                </a:solidFill>
-                <a:latin typeface="Arial"/>
-              </a:defRPr>
-            </a:pPr>
-            <a:r>
-              <a:t>• Open3D &amp; PyTorch Deep Learning Documentation</a:t>
-            </a:r>
-          </a:p>
-          <a:p>
-            <a:pPr>
-              <a:spcAft>
-                <a:spcPts val="300"/>
-              </a:spcAft>
-              <a:defRPr sz="1050">
-                <a:solidFill>
-                  <a:srgbClr val="1F2937"/>
-                </a:solidFill>
-                <a:latin typeface="Arial"/>
-              </a:defRPr>
-            </a:pPr>
-            <a:r>
-              <a:t>• Research literature on LiDAR semantic segmentation &amp; autonomous foveated navigation</a:t>
-            </a:r>
-          </a:p>
-        </p:txBody>
-      </p:sp>
-      <p:sp>
-        <p:nvSpPr>
-          <p:cNvPr id="10" name="TextBox 9"/>
-          <p:cNvSpPr txBox="1"/>
-          <p:nvPr/>
-        </p:nvSpPr>
-        <p:spPr>
-          <a:xfrm>
-            <a:off x="4846320" y="1115568"/>
-            <a:ext cx="7040880" cy="365760"/>
-          </a:xfrm>
-          <a:prstGeom prst="rect">
-            <a:avLst/>
-          </a:prstGeom>
-          <a:noFill/>
-        </p:spPr>
-        <p:txBody>
-          <a:bodyPr wrap="none" lIns="0" tIns="0">
-            <a:spAutoFit/>
-          </a:bodyPr>
-          <a:lstStyle/>
-          <a:p>
-            <a:pPr algn="ctr">
-              <a:defRPr sz="1650" b="1">
-                <a:solidFill>
-                  <a:srgbClr val="111827"/>
+                  <a:srgbClr val="0F172A"/>
                 </a:solidFill>
                 <a:latin typeface="Arial"/>
               </a:defRPr>
@@ -7048,7 +7634,7 @@
         </p:blipFill>
         <p:spPr>
           <a:xfrm>
-            <a:off x="4754880" y="1600200"/>
+            <a:off x="4754880" y="1554480"/>
             <a:ext cx="7132320" cy="3913718"/>
           </a:xfrm>
           <a:prstGeom prst="rect">
@@ -7064,8 +7650,8 @@
         </p:nvSpPr>
         <p:spPr>
           <a:xfrm>
-            <a:off x="4754880" y="4663440"/>
-            <a:ext cx="7132320" cy="1691640"/>
+            <a:off x="4754880" y="4617720"/>
+            <a:ext cx="7132320" cy="1737360"/>
           </a:xfrm>
           <a:prstGeom prst="roundRect">
             <a:avLst/>
@@ -7101,7 +7687,7 @@
               <a:spcAft>
                 <a:spcPts val="300"/>
               </a:spcAft>
-              <a:defRPr sz="1150" b="1">
+              <a:defRPr sz="1200" b="1">
                 <a:solidFill>
                   <a:srgbClr val="1D4ED8"/>
                 </a:solidFill>
@@ -7117,15 +7703,22 @@
               <a:spcAft>
                 <a:spcPts val="200"/>
               </a:spcAft>
-              <a:defRPr sz="1019">
-                <a:solidFill>
-                  <a:srgbClr val="1F2937"/>
-                </a:solidFill>
-                <a:latin typeface="Arial"/>
-              </a:defRPr>
-            </a:pPr>
-            <a:r>
-              <a:t>• Working 60 FPS HTML5 / Flask Localhost Simulator with moving-car foveation</a:t>
+            </a:pPr>
+            <a:r>
+              <a:rPr b="1" sz="1050">
+                <a:solidFill>
+                  <a:srgbClr val="047857"/>
+                </a:solidFill>
+              </a:rPr>
+              <a:t>✔ Interactive Localhost Simulator: </a:t>
+            </a:r>
+            <a:r>
+              <a:rPr sz="1050">
+                <a:solidFill>
+                  <a:srgbClr val="1E293B"/>
+                </a:solidFill>
+              </a:rPr>
+              <a:t>60 FPS HTML5 / Flask Dashboard with live dynamic foveation &amp; HUD</a:t>
             </a:r>
           </a:p>
           <a:p>
@@ -7133,15 +7726,22 @@
               <a:spcAft>
                 <a:spcPts val="200"/>
               </a:spcAft>
-              <a:defRPr sz="1019">
-                <a:solidFill>
-                  <a:srgbClr val="1F2937"/>
-                </a:solidFill>
-                <a:latin typeface="Arial"/>
-              </a:defRPr>
-            </a:pPr>
-            <a:r>
-              <a:t>• Automated Unit Test Suite (5/5 tests passing in 4.0s verifying all modules)</a:t>
+            </a:pPr>
+            <a:r>
+              <a:rPr b="1" sz="1050">
+                <a:solidFill>
+                  <a:srgbClr val="047857"/>
+                </a:solidFill>
+              </a:rPr>
+              <a:t>✔ Automated Test Suite: </a:t>
+            </a:r>
+            <a:r>
+              <a:rPr sz="1050">
+                <a:solidFill>
+                  <a:srgbClr val="1E293B"/>
+                </a:solidFill>
+              </a:rPr>
+              <a:t>5/5 comprehensive unit tests (tests/test_pipeline.py) passing in 4.0s</a:t>
             </a:r>
           </a:p>
           <a:p>
@@ -7149,15 +7749,22 @@
               <a:spcAft>
                 <a:spcPts val="200"/>
               </a:spcAft>
-              <a:defRPr sz="1019">
-                <a:solidFill>
-                  <a:srgbClr val="1F2937"/>
-                </a:solidFill>
-                <a:latin typeface="Arial"/>
-              </a:defRPr>
-            </a:pPr>
-            <a:r>
-              <a:t>• Open Source GitHub Repository: github.com/AbhayVerma628/SIH26053_Lidar</a:t>
+            </a:pPr>
+            <a:r>
+              <a:rPr b="1" sz="1050">
+                <a:solidFill>
+                  <a:srgbClr val="047857"/>
+                </a:solidFill>
+              </a:rPr>
+              <a:t>✔ Open-Source Codebase: </a:t>
+            </a:r>
+            <a:r>
+              <a:rPr sz="1050">
+                <a:solidFill>
+                  <a:srgbClr val="1E293B"/>
+                </a:solidFill>
+              </a:rPr>
+              <a:t>Production GitHub repository: github.com/AbhayVerma628/SIH26053_Lidar</a:t>
             </a:r>
           </a:p>
           <a:p>
@@ -7165,15 +7772,22 @@
               <a:spcAft>
                 <a:spcPts val="200"/>
               </a:spcAft>
-              <a:defRPr sz="1019">
-                <a:solidFill>
-                  <a:srgbClr val="1F2937"/>
-                </a:solidFill>
-                <a:latin typeface="Arial"/>
-              </a:defRPr>
-            </a:pPr>
-            <a:r>
-              <a:t>• Complete 5-panel Matplotlib dashboard, 10 Hz vehicle telemetry log CSV &amp; benchmarks</a:t>
+            </a:pPr>
+            <a:r>
+              <a:rPr b="1" sz="1050">
+                <a:solidFill>
+                  <a:srgbClr val="047857"/>
+                </a:solidFill>
+              </a:rPr>
+              <a:t>✔ Autonomous Output Artifacts: </a:t>
+            </a:r>
+            <a:r>
+              <a:rPr sz="1050">
+                <a:solidFill>
+                  <a:srgbClr val="1E293B"/>
+                </a:solidFill>
+              </a:rPr>
+              <a:t>5-panel dashboard, 10 Hz telemetry CSV, planned A* path, benchmark JSON</a:t>
             </a:r>
           </a:p>
         </p:txBody>

</xml_diff>

<commit_message>
docs: add full-color research pipeline infographic to Slide 6
</commit_message>
<xml_diff>
--- a/docs/SIH26053_TeraPulse_Official_Presentation.pptx
+++ b/docs/SIH26053_TeraPulse_Official_Presentation.pptx
@@ -8784,7 +8784,7 @@
       </p:sp>
       <p:pic>
         <p:nvPicPr>
-          <p:cNvPr id="11" name="Picture 10" descr="page_6_33_Im2.jpg"/>
+          <p:cNvPr id="11" name="Picture 10" descr="colored_research_pipeline.jpg"/>
           <p:cNvPicPr>
             <a:picLocks noChangeAspect="1"/>
           </p:cNvPicPr>
@@ -8799,7 +8799,7 @@
         <p:spPr>
           <a:xfrm>
             <a:off x="5212080" y="1188720"/>
-            <a:ext cx="6309360" cy="3462136"/>
+            <a:ext cx="6309360" cy="3521503"/>
           </a:xfrm>
           <a:prstGeom prst="rect">
             <a:avLst/>

</xml_diff>

<commit_message>
docs: update Slide 4 car perception image to clean style within screen bounds and set Team ID to 137735
</commit_message>
<xml_diff>
--- a/docs/SIH26053_TeraPulse_Official_Presentation.pptx
+++ b/docs/SIH26053_TeraPulse_Official_Presentation.pptx
@@ -3336,7 +3336,7 @@
                 </a:solidFill>
                 <a:latin typeface="Arial"/>
               </a:rPr>
-              <a:t> TBA</a:t>
+              <a:t> 137735</a:t>
             </a:r>
           </a:p>
           <a:p>
@@ -6842,7 +6842,7 @@
       </p:sp>
       <p:pic>
         <p:nvPicPr>
-          <p:cNvPr id="14" name="Picture 13" descr="car_lidar_sensor.png"/>
+          <p:cNvPr id="14" name="Picture 13" descr="clean_car_lidar_sensor.png"/>
           <p:cNvPicPr>
             <a:picLocks noChangeAspect="1"/>
           </p:cNvPicPr>
@@ -6856,8 +6856,8 @@
         </p:blipFill>
         <p:spPr>
           <a:xfrm>
-            <a:off x="6217920" y="3291840"/>
-            <a:ext cx="5394960" cy="3964348"/>
+            <a:off x="6309360" y="3429000"/>
+            <a:ext cx="5029200" cy="2921374"/>
           </a:xfrm>
           <a:prstGeom prst="rect">
             <a:avLst/>

</xml_diff>

<commit_message>
docs: remove legacy ppt slides, video script, and template images folder
</commit_message>
<xml_diff>
--- a/docs/SIH26053_TeraPulse_Official_Presentation.pptx
+++ b/docs/SIH26053_TeraPulse_Official_Presentation.pptx
@@ -3171,7 +3171,7 @@
       </p:sp>
       <p:pic>
         <p:nvPicPr>
-          <p:cNvPr id="4" name="Picture 3" descr="page_1_1_Im1.png"/>
+          <p:cNvPr id="4" name="Picture 3" descr="sih_logo.png"/>
           <p:cNvPicPr>
             <a:picLocks noChangeAspect="1"/>
           </p:cNvPicPr>
@@ -3419,7 +3419,7 @@
       </p:sp>
       <p:pic>
         <p:nvPicPr>
-          <p:cNvPr id="6" name="Picture 5" descr="page_1_0_Im0.png"/>
+          <p:cNvPr id="6" name="Picture 5" descr="sih_brain.png"/>
           <p:cNvPicPr>
             <a:picLocks noChangeAspect="1"/>
           </p:cNvPicPr>
@@ -3577,7 +3577,7 @@
       </p:sp>
       <p:pic>
         <p:nvPicPr>
-          <p:cNvPr id="4" name="Picture 3" descr="page_1_1_Im1.png"/>
+          <p:cNvPr id="4" name="Picture 3" descr="sih_logo.png"/>
           <p:cNvPicPr>
             <a:picLocks noChangeAspect="1"/>
           </p:cNvPicPr>
@@ -5158,7 +5158,7 @@
       </p:sp>
       <p:pic>
         <p:nvPicPr>
-          <p:cNvPr id="4" name="Picture 3" descr="page_1_1_Im1.png"/>
+          <p:cNvPr id="4" name="Picture 3" descr="sih_logo.png"/>
           <p:cNvPicPr>
             <a:picLocks noChangeAspect="1"/>
           </p:cNvPicPr>
@@ -6158,7 +6158,7 @@
       </p:sp>
       <p:pic>
         <p:nvPicPr>
-          <p:cNvPr id="4" name="Picture 3" descr="page_1_1_Im1.png"/>
+          <p:cNvPr id="4" name="Picture 3" descr="sih_logo.png"/>
           <p:cNvPicPr>
             <a:picLocks noChangeAspect="1"/>
           </p:cNvPicPr>
@@ -6842,7 +6842,7 @@
       </p:sp>
       <p:pic>
         <p:nvPicPr>
-          <p:cNvPr id="14" name="Picture 13" descr="clean_car_lidar_sensor.png"/>
+          <p:cNvPr id="14" name="Picture 13" descr="car_lidar_sensor.png"/>
           <p:cNvPicPr>
             <a:picLocks noChangeAspect="1"/>
           </p:cNvPicPr>
@@ -6996,7 +6996,7 @@
       </p:sp>
       <p:pic>
         <p:nvPicPr>
-          <p:cNvPr id="4" name="Picture 3" descr="page_1_1_Im1.png"/>
+          <p:cNvPr id="4" name="Picture 3" descr="sih_logo.png"/>
           <p:cNvPicPr>
             <a:picLocks noChangeAspect="1"/>
           </p:cNvPicPr>
@@ -8303,7 +8303,7 @@
       </p:sp>
       <p:pic>
         <p:nvPicPr>
-          <p:cNvPr id="4" name="Picture 3" descr="page_1_1_Im1.png"/>
+          <p:cNvPr id="4" name="Picture 3" descr="sih_logo.png"/>
           <p:cNvPicPr>
             <a:picLocks noChangeAspect="1"/>
           </p:cNvPicPr>

</xml_diff>